<commit_message>
slides com identidade fiap e o recorte do diagrama no slide de arquitetura
</commit_message>
<xml_diff>
--- a/reports/slides/pipeline_alfabetizacao_fase2.pptx
+++ b/reports/slides/pipeline_alfabetizacao_fase2.pptx
@@ -3113,7 +3113,7 @@
             <a:avLst/>
           </a:prstGeom>
           <a:solidFill>
-            <a:srgbClr val="1E2761"/>
+            <a:srgbClr val="1A1A1A"/>
           </a:solidFill>
           <a:ln>
             <a:noFill/>
@@ -3144,13 +3144,57 @@
       </p:sp>
       <p:sp>
         <p:nvSpPr>
-          <p:cNvPr id="3" name="TextBox 2"/>
+          <p:cNvPr id="3" name="Rectangle 2"/>
+          <p:cNvSpPr/>
+          <p:nvPr/>
+        </p:nvSpPr>
+        <p:spPr>
+          <a:xfrm>
+            <a:off x="822960" y="2148840"/>
+            <a:ext cx="1828800" cy="54864"/>
+          </a:xfrm>
+          <a:prstGeom prst="rect">
+            <a:avLst/>
+          </a:prstGeom>
+          <a:solidFill>
+            <a:srgbClr val="ED145B"/>
+          </a:solidFill>
+          <a:ln>
+            <a:noFill/>
+          </a:ln>
+          <a:effectLst/>
+        </p:spPr>
+        <p:style>
+          <a:lnRef idx="1">
+            <a:schemeClr val="accent1"/>
+          </a:lnRef>
+          <a:fillRef idx="3">
+            <a:schemeClr val="accent1"/>
+          </a:fillRef>
+          <a:effectRef idx="2">
+            <a:schemeClr val="accent1"/>
+          </a:effectRef>
+          <a:fontRef idx="minor">
+            <a:schemeClr val="lt1"/>
+          </a:fontRef>
+        </p:style>
+        <p:txBody>
+          <a:bodyPr rtlCol="0" anchor="ctr"/>
+          <a:lstStyle/>
+          <a:p>
+            <a:pPr algn="ctr"/>
+          </a:p>
+        </p:txBody>
+      </p:sp>
+      <p:sp>
+        <p:nvSpPr>
+          <p:cNvPr id="4" name="TextBox 3"/>
           <p:cNvSpPr txBox="1"/>
           <p:nvPr/>
         </p:nvSpPr>
         <p:spPr>
           <a:xfrm>
-            <a:off x="822960" y="2286000"/>
+            <a:off x="822960" y="2331720"/>
             <a:ext cx="10515600" cy="1828800"/>
           </a:xfrm>
           <a:prstGeom prst="rect">
@@ -3179,13 +3223,13 @@
       </p:sp>
       <p:sp>
         <p:nvSpPr>
-          <p:cNvPr id="4" name="TextBox 3"/>
+          <p:cNvPr id="5" name="TextBox 4"/>
           <p:cNvSpPr txBox="1"/>
           <p:nvPr/>
         </p:nvSpPr>
         <p:spPr>
           <a:xfrm>
-            <a:off x="822960" y="3749039"/>
+            <a:off x="822960" y="3794760"/>
             <a:ext cx="10515600" cy="1371600"/>
           </a:xfrm>
           <a:prstGeom prst="rect">
@@ -3207,7 +3251,7 @@
             <a:r>
               <a:rPr sz="2000" b="0">
                 <a:solidFill>
-                  <a:srgbClr val="CADCFC"/>
+                  <a:srgbClr val="E5E5E5"/>
                 </a:solidFill>
                 <a:latin typeface="Calibri"/>
               </a:rPr>
@@ -3223,7 +3267,7 @@
             <a:r>
               <a:rPr sz="1500" b="0">
                 <a:solidFill>
-                  <a:srgbClr val="CADCFC"/>
+                  <a:srgbClr val="E5E5E5"/>
                 </a:solidFill>
                 <a:latin typeface="Calibri"/>
               </a:rPr>
@@ -3234,7 +3278,7 @@
       </p:sp>
       <p:sp>
         <p:nvSpPr>
-          <p:cNvPr id="5" name="TextBox 4"/>
+          <p:cNvPr id="6" name="TextBox 5"/>
           <p:cNvSpPr txBox="1"/>
           <p:nvPr/>
         </p:nvSpPr>
@@ -3256,9 +3300,9 @@
           <a:p>
             <a:pPr algn="l"/>
             <a:r>
-              <a:rPr sz="1400" b="0">
-                <a:solidFill>
-                  <a:srgbClr val="00A896"/>
+              <a:rPr sz="1400" b="1">
+                <a:solidFill>
+                  <a:srgbClr val="ED145B"/>
                 </a:solidFill>
                 <a:latin typeface="Calibri"/>
               </a:rPr>
@@ -3355,7 +3399,7 @@
             <a:r>
               <a:rPr sz="3400" b="1">
                 <a:solidFill>
-                  <a:srgbClr val="1E2761"/>
+                  <a:srgbClr val="1A1A1A"/>
                 </a:solidFill>
                 <a:latin typeface="Calibri"/>
               </a:rPr>
@@ -3366,20 +3410,20 @@
       </p:sp>
       <p:sp>
         <p:nvSpPr>
-          <p:cNvPr id="4" name="Oval 3"/>
+          <p:cNvPr id="4" name="Rectangle 3"/>
           <p:cNvSpPr/>
           <p:nvPr/>
         </p:nvSpPr>
         <p:spPr>
           <a:xfrm>
-            <a:off x="640080" y="1645920"/>
-            <a:ext cx="640080" cy="640080"/>
-          </a:xfrm>
-          <a:prstGeom prst="ellipse">
+            <a:off x="658368" y="1252728"/>
+            <a:ext cx="1280160" cy="54864"/>
+          </a:xfrm>
+          <a:prstGeom prst="rect">
             <a:avLst/>
           </a:prstGeom>
           <a:solidFill>
-            <a:srgbClr val="1E2761"/>
+            <a:srgbClr val="ED145B"/>
           </a:solidFill>
           <a:ln>
             <a:noFill/>
@@ -3401,6 +3445,50 @@
           </a:fontRef>
         </p:style>
         <p:txBody>
+          <a:bodyPr rtlCol="0" anchor="ctr"/>
+          <a:lstStyle/>
+          <a:p>
+            <a:pPr algn="ctr"/>
+          </a:p>
+        </p:txBody>
+      </p:sp>
+      <p:sp>
+        <p:nvSpPr>
+          <p:cNvPr id="5" name="Oval 4"/>
+          <p:cNvSpPr/>
+          <p:nvPr/>
+        </p:nvSpPr>
+        <p:spPr>
+          <a:xfrm>
+            <a:off x="640080" y="1737360"/>
+            <a:ext cx="640080" cy="640080"/>
+          </a:xfrm>
+          <a:prstGeom prst="ellipse">
+            <a:avLst/>
+          </a:prstGeom>
+          <a:solidFill>
+            <a:srgbClr val="1A1A1A"/>
+          </a:solidFill>
+          <a:ln>
+            <a:noFill/>
+          </a:ln>
+          <a:effectLst/>
+        </p:spPr>
+        <p:style>
+          <a:lnRef idx="1">
+            <a:schemeClr val="accent1"/>
+          </a:lnRef>
+          <a:fillRef idx="3">
+            <a:schemeClr val="accent1"/>
+          </a:fillRef>
+          <a:effectRef idx="2">
+            <a:schemeClr val="accent1"/>
+          </a:effectRef>
+          <a:fontRef idx="minor">
+            <a:schemeClr val="lt1"/>
+          </a:fontRef>
+        </p:style>
+        <p:txBody>
           <a:bodyPr rtlCol="0" anchor="ctr" wrap="none"/>
           <a:lstStyle/>
           <a:p>
@@ -3419,13 +3507,13 @@
       </p:sp>
       <p:sp>
         <p:nvSpPr>
-          <p:cNvPr id="5" name="TextBox 4"/>
+          <p:cNvPr id="6" name="TextBox 5"/>
           <p:cNvSpPr txBox="1"/>
           <p:nvPr/>
         </p:nvSpPr>
         <p:spPr>
           <a:xfrm>
-            <a:off x="1554480" y="1645920"/>
+            <a:off x="1554480" y="1737360"/>
             <a:ext cx="9875520" cy="1280160"/>
           </a:xfrm>
           <a:prstGeom prst="rect">
@@ -3447,7 +3535,7 @@
             <a:r>
               <a:rPr sz="1900" b="1">
                 <a:solidFill>
-                  <a:srgbClr val="1E2761"/>
+                  <a:srgbClr val="1A1A1A"/>
                 </a:solidFill>
                 <a:latin typeface="Calibri"/>
               </a:rPr>
@@ -3463,7 +3551,7 @@
             <a:r>
               <a:rPr sz="1500" b="0">
                 <a:solidFill>
-                  <a:srgbClr val="2B2B2B"/>
+                  <a:srgbClr val="555555"/>
                 </a:solidFill>
                 <a:latin typeface="Calibri"/>
               </a:rPr>
@@ -3474,20 +3562,20 @@
       </p:sp>
       <p:sp>
         <p:nvSpPr>
-          <p:cNvPr id="6" name="Oval 5"/>
+          <p:cNvPr id="7" name="Oval 6"/>
           <p:cNvSpPr/>
           <p:nvPr/>
         </p:nvSpPr>
         <p:spPr>
           <a:xfrm>
-            <a:off x="640080" y="3108960"/>
+            <a:off x="640080" y="3200400"/>
             <a:ext cx="640080" cy="640080"/>
           </a:xfrm>
           <a:prstGeom prst="ellipse">
             <a:avLst/>
           </a:prstGeom>
           <a:solidFill>
-            <a:srgbClr val="1E2761"/>
+            <a:srgbClr val="1A1A1A"/>
           </a:solidFill>
           <a:ln>
             <a:noFill/>
@@ -3527,13 +3615,13 @@
       </p:sp>
       <p:sp>
         <p:nvSpPr>
-          <p:cNvPr id="7" name="TextBox 6"/>
+          <p:cNvPr id="8" name="TextBox 7"/>
           <p:cNvSpPr txBox="1"/>
           <p:nvPr/>
         </p:nvSpPr>
         <p:spPr>
           <a:xfrm>
-            <a:off x="1554480" y="3108960"/>
+            <a:off x="1554480" y="3200400"/>
             <a:ext cx="9875520" cy="1280160"/>
           </a:xfrm>
           <a:prstGeom prst="rect">
@@ -3555,7 +3643,7 @@
             <a:r>
               <a:rPr sz="1900" b="1">
                 <a:solidFill>
-                  <a:srgbClr val="1E2761"/>
+                  <a:srgbClr val="1A1A1A"/>
                 </a:solidFill>
                 <a:latin typeface="Calibri"/>
               </a:rPr>
@@ -3571,7 +3659,7 @@
             <a:r>
               <a:rPr sz="1500" b="0">
                 <a:solidFill>
-                  <a:srgbClr val="2B2B2B"/>
+                  <a:srgbClr val="555555"/>
                 </a:solidFill>
                 <a:latin typeface="Calibri"/>
               </a:rPr>
@@ -3582,20 +3670,20 @@
       </p:sp>
       <p:sp>
         <p:nvSpPr>
-          <p:cNvPr id="8" name="Oval 7"/>
+          <p:cNvPr id="9" name="Oval 8"/>
           <p:cNvSpPr/>
           <p:nvPr/>
         </p:nvSpPr>
         <p:spPr>
           <a:xfrm>
-            <a:off x="640080" y="4572000"/>
+            <a:off x="640080" y="4663440"/>
             <a:ext cx="640080" cy="640080"/>
           </a:xfrm>
           <a:prstGeom prst="ellipse">
             <a:avLst/>
           </a:prstGeom>
           <a:solidFill>
-            <a:srgbClr val="00A896"/>
+            <a:srgbClr val="ED145B"/>
           </a:solidFill>
           <a:ln>
             <a:noFill/>
@@ -3635,13 +3723,13 @@
       </p:sp>
       <p:sp>
         <p:nvSpPr>
-          <p:cNvPr id="9" name="TextBox 8"/>
+          <p:cNvPr id="10" name="TextBox 9"/>
           <p:cNvSpPr txBox="1"/>
           <p:nvPr/>
         </p:nvSpPr>
         <p:spPr>
           <a:xfrm>
-            <a:off x="1554480" y="4572000"/>
+            <a:off x="1554480" y="4663440"/>
             <a:ext cx="9875520" cy="1280160"/>
           </a:xfrm>
           <a:prstGeom prst="rect">
@@ -3663,7 +3751,7 @@
             <a:r>
               <a:rPr sz="1900" b="1">
                 <a:solidFill>
-                  <a:srgbClr val="1E2761"/>
+                  <a:srgbClr val="1A1A1A"/>
                 </a:solidFill>
                 <a:latin typeface="Calibri"/>
               </a:rPr>
@@ -3679,7 +3767,7 @@
             <a:r>
               <a:rPr sz="1500" b="0">
                 <a:solidFill>
-                  <a:srgbClr val="2B2B2B"/>
+                  <a:srgbClr val="555555"/>
                 </a:solidFill>
                 <a:latin typeface="Calibri"/>
               </a:rPr>
@@ -3721,7 +3809,7 @@
             <a:avLst/>
           </a:prstGeom>
           <a:solidFill>
-            <a:srgbClr val="1E2761"/>
+            <a:srgbClr val="1A1A1A"/>
           </a:solidFill>
           <a:ln>
             <a:noFill/>
@@ -3752,7 +3840,51 @@
       </p:sp>
       <p:sp>
         <p:nvSpPr>
-          <p:cNvPr id="3" name="TextBox 2"/>
+          <p:cNvPr id="3" name="Rectangle 2"/>
+          <p:cNvSpPr/>
+          <p:nvPr/>
+        </p:nvSpPr>
+        <p:spPr>
+          <a:xfrm>
+            <a:off x="822960" y="2194560"/>
+            <a:ext cx="1828800" cy="54864"/>
+          </a:xfrm>
+          <a:prstGeom prst="rect">
+            <a:avLst/>
+          </a:prstGeom>
+          <a:solidFill>
+            <a:srgbClr val="ED145B"/>
+          </a:solidFill>
+          <a:ln>
+            <a:noFill/>
+          </a:ln>
+          <a:effectLst/>
+        </p:spPr>
+        <p:style>
+          <a:lnRef idx="1">
+            <a:schemeClr val="accent1"/>
+          </a:lnRef>
+          <a:fillRef idx="3">
+            <a:schemeClr val="accent1"/>
+          </a:fillRef>
+          <a:effectRef idx="2">
+            <a:schemeClr val="accent1"/>
+          </a:effectRef>
+          <a:fontRef idx="minor">
+            <a:schemeClr val="lt1"/>
+          </a:fontRef>
+        </p:style>
+        <p:txBody>
+          <a:bodyPr rtlCol="0" anchor="ctr"/>
+          <a:lstStyle/>
+          <a:p>
+            <a:pPr algn="ctr"/>
+          </a:p>
+        </p:txBody>
+      </p:sp>
+      <p:sp>
+        <p:nvSpPr>
+          <p:cNvPr id="4" name="TextBox 3"/>
           <p:cNvSpPr txBox="1"/>
           <p:nvPr/>
         </p:nvSpPr>
@@ -3796,7 +3928,7 @@
             <a:r>
               <a:rPr sz="1800" b="0">
                 <a:solidFill>
-                  <a:srgbClr val="CADCFC"/>
+                  <a:srgbClr val="E5E5E5"/>
                 </a:solidFill>
                 <a:latin typeface="Calibri"/>
               </a:rPr>
@@ -3807,7 +3939,7 @@
       </p:sp>
       <p:sp>
         <p:nvSpPr>
-          <p:cNvPr id="4" name="TextBox 3"/>
+          <p:cNvPr id="5" name="TextBox 4"/>
           <p:cNvSpPr txBox="1"/>
           <p:nvPr/>
         </p:nvSpPr>
@@ -3831,7 +3963,7 @@
             <a:r>
               <a:rPr sz="2000" b="1">
                 <a:solidFill>
-                  <a:srgbClr val="00A896"/>
+                  <a:srgbClr val="ED145B"/>
                 </a:solidFill>
                 <a:latin typeface="Calibri"/>
               </a:rPr>
@@ -3928,7 +4060,7 @@
             <a:r>
               <a:rPr sz="3400" b="1">
                 <a:solidFill>
-                  <a:srgbClr val="1E2761"/>
+                  <a:srgbClr val="1A1A1A"/>
                 </a:solidFill>
                 <a:latin typeface="Calibri"/>
               </a:rPr>
@@ -3939,13 +4071,57 @@
       </p:sp>
       <p:sp>
         <p:nvSpPr>
-          <p:cNvPr id="4" name="TextBox 3"/>
+          <p:cNvPr id="4" name="Rectangle 3"/>
+          <p:cNvSpPr/>
+          <p:nvPr/>
+        </p:nvSpPr>
+        <p:spPr>
+          <a:xfrm>
+            <a:off x="658368" y="1252728"/>
+            <a:ext cx="1280160" cy="54864"/>
+          </a:xfrm>
+          <a:prstGeom prst="rect">
+            <a:avLst/>
+          </a:prstGeom>
+          <a:solidFill>
+            <a:srgbClr val="ED145B"/>
+          </a:solidFill>
+          <a:ln>
+            <a:noFill/>
+          </a:ln>
+          <a:effectLst/>
+        </p:spPr>
+        <p:style>
+          <a:lnRef idx="1">
+            <a:schemeClr val="accent1"/>
+          </a:lnRef>
+          <a:fillRef idx="3">
+            <a:schemeClr val="accent1"/>
+          </a:fillRef>
+          <a:effectRef idx="2">
+            <a:schemeClr val="accent1"/>
+          </a:effectRef>
+          <a:fontRef idx="minor">
+            <a:schemeClr val="lt1"/>
+          </a:fontRef>
+        </p:style>
+        <p:txBody>
+          <a:bodyPr rtlCol="0" anchor="ctr"/>
+          <a:lstStyle/>
+          <a:p>
+            <a:pPr algn="ctr"/>
+          </a:p>
+        </p:txBody>
+      </p:sp>
+      <p:sp>
+        <p:nvSpPr>
+          <p:cNvPr id="5" name="TextBox 4"/>
           <p:cNvSpPr txBox="1"/>
           <p:nvPr/>
         </p:nvSpPr>
         <p:spPr>
           <a:xfrm>
-            <a:off x="640080" y="1463040"/>
+            <a:off x="640080" y="1554480"/>
             <a:ext cx="6126480" cy="4389120"/>
           </a:xfrm>
           <a:prstGeom prst="rect">
@@ -3967,7 +4143,7 @@
             <a:r>
               <a:rPr sz="1700" b="0">
                 <a:solidFill>
-                  <a:srgbClr val="2B2B2B"/>
+                  <a:srgbClr val="1A1A1A"/>
                 </a:solidFill>
                 <a:latin typeface="Calibri"/>
               </a:rPr>
@@ -3983,7 +4159,7 @@
             <a:r>
               <a:rPr sz="1700" b="0">
                 <a:solidFill>
-                  <a:srgbClr val="2B2B2B"/>
+                  <a:srgbClr val="1A1A1A"/>
                 </a:solidFill>
                 <a:latin typeface="Calibri"/>
               </a:rPr>
@@ -3999,7 +4175,7 @@
             <a:r>
               <a:rPr sz="1700" b="0">
                 <a:solidFill>
-                  <a:srgbClr val="2B2B2B"/>
+                  <a:srgbClr val="1A1A1A"/>
                 </a:solidFill>
                 <a:latin typeface="Calibri"/>
               </a:rPr>
@@ -4010,20 +4186,20 @@
       </p:sp>
       <p:sp>
         <p:nvSpPr>
-          <p:cNvPr id="5" name="Rounded Rectangle 4"/>
+          <p:cNvPr id="6" name="Rounded Rectangle 5"/>
           <p:cNvSpPr/>
           <p:nvPr/>
         </p:nvSpPr>
         <p:spPr>
           <a:xfrm>
-            <a:off x="7223760" y="1554480"/>
+            <a:off x="7223760" y="1645920"/>
             <a:ext cx="4297680" cy="1828800"/>
           </a:xfrm>
           <a:prstGeom prst="roundRect">
             <a:avLst/>
           </a:prstGeom>
           <a:solidFill>
-            <a:srgbClr val="F4F6FB"/>
+            <a:srgbClr val="F4F4F6"/>
           </a:solidFill>
           <a:ln>
             <a:noFill/>
@@ -4054,13 +4230,13 @@
       </p:sp>
       <p:sp>
         <p:nvSpPr>
-          <p:cNvPr id="6" name="TextBox 5"/>
+          <p:cNvPr id="7" name="TextBox 6"/>
           <p:cNvSpPr txBox="1"/>
           <p:nvPr/>
         </p:nvSpPr>
         <p:spPr>
           <a:xfrm>
-            <a:off x="7406640" y="1783080"/>
+            <a:off x="7406640" y="1874519"/>
             <a:ext cx="3931920" cy="1463040"/>
           </a:xfrm>
           <a:prstGeom prst="rect">
@@ -4082,7 +4258,7 @@
             <a:r>
               <a:rPr sz="6000" b="1">
                 <a:solidFill>
-                  <a:srgbClr val="00A896"/>
+                  <a:srgbClr val="ED145B"/>
                 </a:solidFill>
                 <a:latin typeface="Calibri"/>
               </a:rPr>
@@ -4098,7 +4274,7 @@
             <a:r>
               <a:rPr sz="1300" b="0">
                 <a:solidFill>
-                  <a:srgbClr val="5A5A5A"/>
+                  <a:srgbClr val="555555"/>
                 </a:solidFill>
                 <a:latin typeface="Calibri"/>
               </a:rPr>
@@ -4109,20 +4285,20 @@
       </p:sp>
       <p:sp>
         <p:nvSpPr>
-          <p:cNvPr id="7" name="Rounded Rectangle 6"/>
+          <p:cNvPr id="8" name="Rounded Rectangle 7"/>
           <p:cNvSpPr/>
           <p:nvPr/>
         </p:nvSpPr>
         <p:spPr>
           <a:xfrm>
-            <a:off x="7223760" y="3657600"/>
+            <a:off x="7223760" y="3749039"/>
             <a:ext cx="4297680" cy="1828800"/>
           </a:xfrm>
           <a:prstGeom prst="roundRect">
             <a:avLst/>
           </a:prstGeom>
           <a:solidFill>
-            <a:srgbClr val="F4F6FB"/>
+            <a:srgbClr val="F4F4F6"/>
           </a:solidFill>
           <a:ln>
             <a:noFill/>
@@ -4153,13 +4329,13 @@
       </p:sp>
       <p:sp>
         <p:nvSpPr>
-          <p:cNvPr id="8" name="TextBox 7"/>
+          <p:cNvPr id="9" name="TextBox 8"/>
           <p:cNvSpPr txBox="1"/>
           <p:nvPr/>
         </p:nvSpPr>
         <p:spPr>
           <a:xfrm>
-            <a:off x="7406640" y="3886200"/>
+            <a:off x="7406640" y="3977639"/>
             <a:ext cx="3931920" cy="1463040"/>
           </a:xfrm>
           <a:prstGeom prst="rect">
@@ -4181,7 +4357,7 @@
             <a:r>
               <a:rPr sz="6000" b="1">
                 <a:solidFill>
-                  <a:srgbClr val="1E2761"/>
+                  <a:srgbClr val="1A1A1A"/>
                 </a:solidFill>
                 <a:latin typeface="Calibri"/>
               </a:rPr>
@@ -4197,7 +4373,7 @@
             <a:r>
               <a:rPr sz="1300" b="0">
                 <a:solidFill>
-                  <a:srgbClr val="5A5A5A"/>
+                  <a:srgbClr val="555555"/>
                 </a:solidFill>
                 <a:latin typeface="Calibri"/>
               </a:rPr>
@@ -4294,7 +4470,7 @@
             <a:r>
               <a:rPr sz="3400" b="1">
                 <a:solidFill>
-                  <a:srgbClr val="1E2761"/>
+                  <a:srgbClr val="1A1A1A"/>
                 </a:solidFill>
                 <a:latin typeface="Calibri"/>
               </a:rPr>
@@ -4305,20 +4481,20 @@
       </p:sp>
       <p:sp>
         <p:nvSpPr>
-          <p:cNvPr id="4" name="Rounded Rectangle 3"/>
+          <p:cNvPr id="4" name="Rectangle 3"/>
           <p:cNvSpPr/>
           <p:nvPr/>
         </p:nvSpPr>
         <p:spPr>
           <a:xfrm>
-            <a:off x="640080" y="1737360"/>
-            <a:ext cx="2560320" cy="2103120"/>
-          </a:xfrm>
-          <a:prstGeom prst="roundRect">
+            <a:off x="658368" y="1252728"/>
+            <a:ext cx="1280160" cy="54864"/>
+          </a:xfrm>
+          <a:prstGeom prst="rect">
             <a:avLst/>
           </a:prstGeom>
           <a:solidFill>
-            <a:srgbClr val="F4F6FB"/>
+            <a:srgbClr val="ED145B"/>
           </a:solidFill>
           <a:ln>
             <a:noFill/>
@@ -4349,20 +4525,20 @@
       </p:sp>
       <p:sp>
         <p:nvSpPr>
-          <p:cNvPr id="5" name="Oval 4"/>
+          <p:cNvPr id="5" name="Rounded Rectangle 4"/>
           <p:cNvSpPr/>
           <p:nvPr/>
         </p:nvSpPr>
         <p:spPr>
           <a:xfrm>
-            <a:off x="1600200" y="1965960"/>
-            <a:ext cx="640080" cy="640080"/>
-          </a:xfrm>
-          <a:prstGeom prst="ellipse">
+            <a:off x="640080" y="1828800"/>
+            <a:ext cx="2560320" cy="2103120"/>
+          </a:xfrm>
+          <a:prstGeom prst="roundRect">
             <a:avLst/>
           </a:prstGeom>
           <a:solidFill>
-            <a:srgbClr val="1E2761"/>
+            <a:srgbClr val="F4F4F6"/>
           </a:solidFill>
           <a:ln>
             <a:noFill/>
@@ -4384,73 +4560,29 @@
           </a:fontRef>
         </p:style>
         <p:txBody>
-          <a:bodyPr rtlCol="0" anchor="ctr" wrap="none"/>
+          <a:bodyPr rtlCol="0" anchor="ctr"/>
           <a:lstStyle/>
           <a:p>
             <a:pPr algn="ctr"/>
-            <a:r>
-              <a:rPr sz="1400" b="1">
-                <a:solidFill>
-                  <a:srgbClr val="FFFFFF"/>
-                </a:solidFill>
-                <a:latin typeface="Calibri"/>
-              </a:rPr>
-              <a:t>UF</a:t>
-            </a:r>
-          </a:p>
-        </p:txBody>
-      </p:sp>
-      <p:sp>
-        <p:nvSpPr>
-          <p:cNvPr id="6" name="TextBox 5"/>
-          <p:cNvSpPr txBox="1"/>
-          <p:nvPr/>
-        </p:nvSpPr>
-        <p:spPr>
-          <a:xfrm>
-            <a:off x="822959" y="2788920"/>
-            <a:ext cx="2194560" cy="1005840"/>
-          </a:xfrm>
-          <a:prstGeom prst="rect">
-            <a:avLst/>
-          </a:prstGeom>
-          <a:noFill/>
-        </p:spPr>
-        <p:txBody>
-          <a:bodyPr wrap="square" anchor="t" lIns="0" rIns="0" tIns="0" bIns="0">
-            <a:spAutoFit/>
-          </a:bodyPr>
-          <a:lstStyle/>
-          <a:p>
-            <a:pPr algn="ctr"/>
-            <a:r>
-              <a:rPr sz="1300" b="0">
-                <a:solidFill>
-                  <a:srgbClr val="2B2B2B"/>
-                </a:solidFill>
-                <a:latin typeface="Calibri"/>
-              </a:rPr>
-              <a:t>Unidades da federacao e regioes</a:t>
-            </a:r>
-          </a:p>
-        </p:txBody>
-      </p:sp>
-      <p:sp>
-        <p:nvSpPr>
-          <p:cNvPr id="7" name="Rounded Rectangle 6"/>
+          </a:p>
+        </p:txBody>
+      </p:sp>
+      <p:sp>
+        <p:nvSpPr>
+          <p:cNvPr id="6" name="Oval 5"/>
           <p:cNvSpPr/>
           <p:nvPr/>
         </p:nvSpPr>
         <p:spPr>
           <a:xfrm>
-            <a:off x="3429000" y="1737360"/>
-            <a:ext cx="2560320" cy="2103120"/>
-          </a:xfrm>
-          <a:prstGeom prst="roundRect">
+            <a:off x="1600200" y="2057400"/>
+            <a:ext cx="640080" cy="640080"/>
+          </a:xfrm>
+          <a:prstGeom prst="ellipse">
             <a:avLst/>
           </a:prstGeom>
           <a:solidFill>
-            <a:srgbClr val="F4F6FB"/>
+            <a:srgbClr val="1A1A1A"/>
           </a:solidFill>
           <a:ln>
             <a:noFill/>
@@ -4472,29 +4604,73 @@
           </a:fontRef>
         </p:style>
         <p:txBody>
-          <a:bodyPr rtlCol="0" anchor="ctr"/>
+          <a:bodyPr rtlCol="0" anchor="ctr" wrap="none"/>
           <a:lstStyle/>
           <a:p>
             <a:pPr algn="ctr"/>
-          </a:p>
-        </p:txBody>
-      </p:sp>
-      <p:sp>
-        <p:nvSpPr>
-          <p:cNvPr id="8" name="Oval 7"/>
+            <a:r>
+              <a:rPr sz="1400" b="1">
+                <a:solidFill>
+                  <a:srgbClr val="FFFFFF"/>
+                </a:solidFill>
+                <a:latin typeface="Calibri"/>
+              </a:rPr>
+              <a:t>UF</a:t>
+            </a:r>
+          </a:p>
+        </p:txBody>
+      </p:sp>
+      <p:sp>
+        <p:nvSpPr>
+          <p:cNvPr id="7" name="TextBox 6"/>
+          <p:cNvSpPr txBox="1"/>
+          <p:nvPr/>
+        </p:nvSpPr>
+        <p:spPr>
+          <a:xfrm>
+            <a:off x="822959" y="2880360"/>
+            <a:ext cx="2194560" cy="1005840"/>
+          </a:xfrm>
+          <a:prstGeom prst="rect">
+            <a:avLst/>
+          </a:prstGeom>
+          <a:noFill/>
+        </p:spPr>
+        <p:txBody>
+          <a:bodyPr wrap="square" anchor="t" lIns="0" rIns="0" tIns="0" bIns="0">
+            <a:spAutoFit/>
+          </a:bodyPr>
+          <a:lstStyle/>
+          <a:p>
+            <a:pPr algn="ctr"/>
+            <a:r>
+              <a:rPr sz="1300" b="0">
+                <a:solidFill>
+                  <a:srgbClr val="1A1A1A"/>
+                </a:solidFill>
+                <a:latin typeface="Calibri"/>
+              </a:rPr>
+              <a:t>Unidades da federacao e regioes</a:t>
+            </a:r>
+          </a:p>
+        </p:txBody>
+      </p:sp>
+      <p:sp>
+        <p:nvSpPr>
+          <p:cNvPr id="8" name="Rounded Rectangle 7"/>
           <p:cNvSpPr/>
           <p:nvPr/>
         </p:nvSpPr>
         <p:spPr>
           <a:xfrm>
-            <a:off x="4389120" y="1965960"/>
-            <a:ext cx="640080" cy="640080"/>
-          </a:xfrm>
-          <a:prstGeom prst="ellipse">
+            <a:off x="3429000" y="1828800"/>
+            <a:ext cx="2560320" cy="2103120"/>
+          </a:xfrm>
+          <a:prstGeom prst="roundRect">
             <a:avLst/>
           </a:prstGeom>
           <a:solidFill>
-            <a:srgbClr val="00A896"/>
+            <a:srgbClr val="F4F4F6"/>
           </a:solidFill>
           <a:ln>
             <a:noFill/>
@@ -4516,73 +4692,29 @@
           </a:fontRef>
         </p:style>
         <p:txBody>
-          <a:bodyPr rtlCol="0" anchor="ctr" wrap="none"/>
+          <a:bodyPr rtlCol="0" anchor="ctr"/>
           <a:lstStyle/>
           <a:p>
             <a:pPr algn="ctr"/>
-            <a:r>
-              <a:rPr sz="1400" b="1">
-                <a:solidFill>
-                  <a:srgbClr val="FFFFFF"/>
-                </a:solidFill>
-                <a:latin typeface="Calibri"/>
-              </a:rPr>
-              <a:t>MUN</a:t>
-            </a:r>
-          </a:p>
-        </p:txBody>
-      </p:sp>
-      <p:sp>
-        <p:nvSpPr>
-          <p:cNvPr id="9" name="TextBox 8"/>
-          <p:cNvSpPr txBox="1"/>
-          <p:nvPr/>
-        </p:nvSpPr>
-        <p:spPr>
-          <a:xfrm>
-            <a:off x="3611880" y="2788920"/>
-            <a:ext cx="2194560" cy="1005840"/>
-          </a:xfrm>
-          <a:prstGeom prst="rect">
-            <a:avLst/>
-          </a:prstGeom>
-          <a:noFill/>
-        </p:spPr>
-        <p:txBody>
-          <a:bodyPr wrap="square" anchor="t" lIns="0" rIns="0" tIns="0" bIns="0">
-            <a:spAutoFit/>
-          </a:bodyPr>
-          <a:lstStyle/>
-          <a:p>
-            <a:pPr algn="ctr"/>
-            <a:r>
-              <a:rPr sz="1300" b="0">
-                <a:solidFill>
-                  <a:srgbClr val="2B2B2B"/>
-                </a:solidFill>
-                <a:latin typeface="Calibri"/>
-              </a:rPr>
-              <a:t>Municipios e vinculo com a UF</a:t>
-            </a:r>
-          </a:p>
-        </p:txBody>
-      </p:sp>
-      <p:sp>
-        <p:nvSpPr>
-          <p:cNvPr id="10" name="Rounded Rectangle 9"/>
+          </a:p>
+        </p:txBody>
+      </p:sp>
+      <p:sp>
+        <p:nvSpPr>
+          <p:cNvPr id="9" name="Oval 8"/>
           <p:cNvSpPr/>
           <p:nvPr/>
         </p:nvSpPr>
         <p:spPr>
           <a:xfrm>
-            <a:off x="6217920" y="1737360"/>
-            <a:ext cx="2560320" cy="2103120"/>
-          </a:xfrm>
-          <a:prstGeom prst="roundRect">
+            <a:off x="4389120" y="2057400"/>
+            <a:ext cx="640080" cy="640080"/>
+          </a:xfrm>
+          <a:prstGeom prst="ellipse">
             <a:avLst/>
           </a:prstGeom>
           <a:solidFill>
-            <a:srgbClr val="F4F6FB"/>
+            <a:srgbClr val="ED145B"/>
           </a:solidFill>
           <a:ln>
             <a:noFill/>
@@ -4604,29 +4736,73 @@
           </a:fontRef>
         </p:style>
         <p:txBody>
-          <a:bodyPr rtlCol="0" anchor="ctr"/>
+          <a:bodyPr rtlCol="0" anchor="ctr" wrap="none"/>
           <a:lstStyle/>
           <a:p>
             <a:pPr algn="ctr"/>
-          </a:p>
-        </p:txBody>
-      </p:sp>
-      <p:sp>
-        <p:nvSpPr>
-          <p:cNvPr id="11" name="Oval 10"/>
+            <a:r>
+              <a:rPr sz="1400" b="1">
+                <a:solidFill>
+                  <a:srgbClr val="FFFFFF"/>
+                </a:solidFill>
+                <a:latin typeface="Calibri"/>
+              </a:rPr>
+              <a:t>MUN</a:t>
+            </a:r>
+          </a:p>
+        </p:txBody>
+      </p:sp>
+      <p:sp>
+        <p:nvSpPr>
+          <p:cNvPr id="10" name="TextBox 9"/>
+          <p:cNvSpPr txBox="1"/>
+          <p:nvPr/>
+        </p:nvSpPr>
+        <p:spPr>
+          <a:xfrm>
+            <a:off x="3611880" y="2880360"/>
+            <a:ext cx="2194560" cy="1005840"/>
+          </a:xfrm>
+          <a:prstGeom prst="rect">
+            <a:avLst/>
+          </a:prstGeom>
+          <a:noFill/>
+        </p:spPr>
+        <p:txBody>
+          <a:bodyPr wrap="square" anchor="t" lIns="0" rIns="0" tIns="0" bIns="0">
+            <a:spAutoFit/>
+          </a:bodyPr>
+          <a:lstStyle/>
+          <a:p>
+            <a:pPr algn="ctr"/>
+            <a:r>
+              <a:rPr sz="1300" b="0">
+                <a:solidFill>
+                  <a:srgbClr val="1A1A1A"/>
+                </a:solidFill>
+                <a:latin typeface="Calibri"/>
+              </a:rPr>
+              <a:t>Municipios e vinculo com a UF</a:t>
+            </a:r>
+          </a:p>
+        </p:txBody>
+      </p:sp>
+      <p:sp>
+        <p:nvSpPr>
+          <p:cNvPr id="11" name="Rounded Rectangle 10"/>
           <p:cNvSpPr/>
           <p:nvPr/>
         </p:nvSpPr>
         <p:spPr>
           <a:xfrm>
-            <a:off x="7178040" y="1965960"/>
-            <a:ext cx="640080" cy="640080"/>
-          </a:xfrm>
-          <a:prstGeom prst="ellipse">
+            <a:off x="6217920" y="1828800"/>
+            <a:ext cx="2560320" cy="2103120"/>
+          </a:xfrm>
+          <a:prstGeom prst="roundRect">
             <a:avLst/>
           </a:prstGeom>
           <a:solidFill>
-            <a:srgbClr val="1E2761"/>
+            <a:srgbClr val="F4F4F6"/>
           </a:solidFill>
           <a:ln>
             <a:noFill/>
@@ -4648,73 +4824,29 @@
           </a:fontRef>
         </p:style>
         <p:txBody>
-          <a:bodyPr rtlCol="0" anchor="ctr" wrap="none"/>
+          <a:bodyPr rtlCol="0" anchor="ctr"/>
           <a:lstStyle/>
           <a:p>
             <a:pPr algn="ctr"/>
-            <a:r>
-              <a:rPr sz="1400" b="1">
-                <a:solidFill>
-                  <a:srgbClr val="FFFFFF"/>
-                </a:solidFill>
-                <a:latin typeface="Calibri"/>
-              </a:rPr>
-              <a:t>META</a:t>
-            </a:r>
-          </a:p>
-        </p:txBody>
-      </p:sp>
-      <p:sp>
-        <p:nvSpPr>
-          <p:cNvPr id="12" name="TextBox 11"/>
-          <p:cNvSpPr txBox="1"/>
-          <p:nvPr/>
-        </p:nvSpPr>
-        <p:spPr>
-          <a:xfrm>
-            <a:off x="6400800" y="2788920"/>
-            <a:ext cx="2194560" cy="1005840"/>
-          </a:xfrm>
-          <a:prstGeom prst="rect">
-            <a:avLst/>
-          </a:prstGeom>
-          <a:noFill/>
-        </p:spPr>
-        <p:txBody>
-          <a:bodyPr wrap="square" anchor="t" lIns="0" rIns="0" tIns="0" bIns="0">
-            <a:spAutoFit/>
-          </a:bodyPr>
-          <a:lstStyle/>
-          <a:p>
-            <a:pPr algn="ctr"/>
-            <a:r>
-              <a:rPr sz="1300" b="0">
-                <a:solidFill>
-                  <a:srgbClr val="2B2B2B"/>
-                </a:solidFill>
-                <a:latin typeface="Calibri"/>
-              </a:rPr>
-              <a:t>Metas nacional, por UF e por municipio</a:t>
-            </a:r>
-          </a:p>
-        </p:txBody>
-      </p:sp>
-      <p:sp>
-        <p:nvSpPr>
-          <p:cNvPr id="13" name="Rounded Rectangle 12"/>
+          </a:p>
+        </p:txBody>
+      </p:sp>
+      <p:sp>
+        <p:nvSpPr>
+          <p:cNvPr id="12" name="Oval 11"/>
           <p:cNvSpPr/>
           <p:nvPr/>
         </p:nvSpPr>
         <p:spPr>
           <a:xfrm>
-            <a:off x="9006839" y="1737360"/>
-            <a:ext cx="2560320" cy="2103120"/>
-          </a:xfrm>
-          <a:prstGeom prst="roundRect">
+            <a:off x="7178040" y="2057400"/>
+            <a:ext cx="640080" cy="640080"/>
+          </a:xfrm>
+          <a:prstGeom prst="ellipse">
             <a:avLst/>
           </a:prstGeom>
           <a:solidFill>
-            <a:srgbClr val="F4F6FB"/>
+            <a:srgbClr val="1A1A1A"/>
           </a:solidFill>
           <a:ln>
             <a:noFill/>
@@ -4736,29 +4868,73 @@
           </a:fontRef>
         </p:style>
         <p:txBody>
-          <a:bodyPr rtlCol="0" anchor="ctr"/>
+          <a:bodyPr rtlCol="0" anchor="ctr" wrap="none"/>
           <a:lstStyle/>
           <a:p>
             <a:pPr algn="ctr"/>
-          </a:p>
-        </p:txBody>
-      </p:sp>
-      <p:sp>
-        <p:nvSpPr>
-          <p:cNvPr id="14" name="Oval 13"/>
+            <a:r>
+              <a:rPr sz="1400" b="1">
+                <a:solidFill>
+                  <a:srgbClr val="FFFFFF"/>
+                </a:solidFill>
+                <a:latin typeface="Calibri"/>
+              </a:rPr>
+              <a:t>META</a:t>
+            </a:r>
+          </a:p>
+        </p:txBody>
+      </p:sp>
+      <p:sp>
+        <p:nvSpPr>
+          <p:cNvPr id="13" name="TextBox 12"/>
+          <p:cNvSpPr txBox="1"/>
+          <p:nvPr/>
+        </p:nvSpPr>
+        <p:spPr>
+          <a:xfrm>
+            <a:off x="6400800" y="2880360"/>
+            <a:ext cx="2194560" cy="1005840"/>
+          </a:xfrm>
+          <a:prstGeom prst="rect">
+            <a:avLst/>
+          </a:prstGeom>
+          <a:noFill/>
+        </p:spPr>
+        <p:txBody>
+          <a:bodyPr wrap="square" anchor="t" lIns="0" rIns="0" tIns="0" bIns="0">
+            <a:spAutoFit/>
+          </a:bodyPr>
+          <a:lstStyle/>
+          <a:p>
+            <a:pPr algn="ctr"/>
+            <a:r>
+              <a:rPr sz="1300" b="0">
+                <a:solidFill>
+                  <a:srgbClr val="1A1A1A"/>
+                </a:solidFill>
+                <a:latin typeface="Calibri"/>
+              </a:rPr>
+              <a:t>Metas nacional, por UF e por municipio</a:t>
+            </a:r>
+          </a:p>
+        </p:txBody>
+      </p:sp>
+      <p:sp>
+        <p:nvSpPr>
+          <p:cNvPr id="14" name="Rounded Rectangle 13"/>
           <p:cNvSpPr/>
           <p:nvPr/>
         </p:nvSpPr>
         <p:spPr>
           <a:xfrm>
-            <a:off x="9966959" y="1965960"/>
-            <a:ext cx="640080" cy="640080"/>
-          </a:xfrm>
-          <a:prstGeom prst="ellipse">
+            <a:off x="9006839" y="1828800"/>
+            <a:ext cx="2560320" cy="2103120"/>
+          </a:xfrm>
+          <a:prstGeom prst="roundRect">
             <a:avLst/>
           </a:prstGeom>
           <a:solidFill>
-            <a:srgbClr val="00A896"/>
+            <a:srgbClr val="F4F4F6"/>
           </a:solidFill>
           <a:ln>
             <a:noFill/>
@@ -4780,6 +4956,50 @@
           </a:fontRef>
         </p:style>
         <p:txBody>
+          <a:bodyPr rtlCol="0" anchor="ctr"/>
+          <a:lstStyle/>
+          <a:p>
+            <a:pPr algn="ctr"/>
+          </a:p>
+        </p:txBody>
+      </p:sp>
+      <p:sp>
+        <p:nvSpPr>
+          <p:cNvPr id="15" name="Oval 14"/>
+          <p:cNvSpPr/>
+          <p:nvPr/>
+        </p:nvSpPr>
+        <p:spPr>
+          <a:xfrm>
+            <a:off x="9966959" y="2057400"/>
+            <a:ext cx="640080" cy="640080"/>
+          </a:xfrm>
+          <a:prstGeom prst="ellipse">
+            <a:avLst/>
+          </a:prstGeom>
+          <a:solidFill>
+            <a:srgbClr val="ED145B"/>
+          </a:solidFill>
+          <a:ln>
+            <a:noFill/>
+          </a:ln>
+          <a:effectLst/>
+        </p:spPr>
+        <p:style>
+          <a:lnRef idx="1">
+            <a:schemeClr val="accent1"/>
+          </a:lnRef>
+          <a:fillRef idx="3">
+            <a:schemeClr val="accent1"/>
+          </a:fillRef>
+          <a:effectRef idx="2">
+            <a:schemeClr val="accent1"/>
+          </a:effectRef>
+          <a:fontRef idx="minor">
+            <a:schemeClr val="lt1"/>
+          </a:fontRef>
+        </p:style>
+        <p:txBody>
           <a:bodyPr rtlCol="0" anchor="ctr" wrap="none"/>
           <a:lstStyle/>
           <a:p>
@@ -4798,13 +5018,13 @@
       </p:sp>
       <p:sp>
         <p:nvSpPr>
-          <p:cNvPr id="15" name="TextBox 14"/>
+          <p:cNvPr id="16" name="TextBox 15"/>
           <p:cNvSpPr txBox="1"/>
           <p:nvPr/>
         </p:nvSpPr>
         <p:spPr>
           <a:xfrm>
-            <a:off x="9189719" y="2788920"/>
+            <a:off x="9189719" y="2880360"/>
             <a:ext cx="2194560" cy="1005840"/>
           </a:xfrm>
           <a:prstGeom prst="rect">
@@ -4822,7 +5042,7 @@
             <a:r>
               <a:rPr sz="1300" b="0">
                 <a:solidFill>
-                  <a:srgbClr val="2B2B2B"/>
+                  <a:srgbClr val="1A1A1A"/>
                 </a:solidFill>
                 <a:latin typeface="Calibri"/>
               </a:rPr>
@@ -4833,13 +5053,13 @@
       </p:sp>
       <p:sp>
         <p:nvSpPr>
-          <p:cNvPr id="16" name="TextBox 15"/>
+          <p:cNvPr id="17" name="TextBox 16"/>
           <p:cNvSpPr txBox="1"/>
           <p:nvPr/>
         </p:nvSpPr>
         <p:spPr>
           <a:xfrm>
-            <a:off x="640080" y="4297680"/>
+            <a:off x="640080" y="4389120"/>
             <a:ext cx="10881360" cy="1371600"/>
           </a:xfrm>
           <a:prstGeom prst="rect">
@@ -4857,7 +5077,7 @@
             <a:r>
               <a:rPr sz="1700" b="0">
                 <a:solidFill>
-                  <a:srgbClr val="2B2B2B"/>
+                  <a:srgbClr val="1A1A1A"/>
                 </a:solidFill>
                 <a:latin typeface="Calibri"/>
               </a:rPr>
@@ -4899,7 +5119,7 @@
             <a:avLst/>
           </a:prstGeom>
           <a:solidFill>
-            <a:srgbClr val="1E2761"/>
+            <a:srgbClr val="1A1A1A"/>
           </a:solidFill>
           <a:ln>
             <a:noFill/>
@@ -4965,55 +5185,20 @@
       </p:sp>
       <p:sp>
         <p:nvSpPr>
-          <p:cNvPr id="4" name="TextBox 3"/>
-          <p:cNvSpPr txBox="1"/>
-          <p:nvPr/>
-        </p:nvSpPr>
-        <p:spPr>
-          <a:xfrm>
-            <a:off x="640080" y="1371600"/>
-            <a:ext cx="10881360" cy="822960"/>
+          <p:cNvPr id="4" name="Rectangle 3"/>
+          <p:cNvSpPr/>
+          <p:nvPr/>
+        </p:nvSpPr>
+        <p:spPr>
+          <a:xfrm>
+            <a:off x="658368" y="1252728"/>
+            <a:ext cx="1280160" cy="54864"/>
           </a:xfrm>
           <a:prstGeom prst="rect">
             <a:avLst/>
           </a:prstGeom>
-          <a:noFill/>
-        </p:spPr>
-        <p:txBody>
-          <a:bodyPr wrap="square" anchor="t" lIns="0" rIns="0" tIns="0" bIns="0">
-            <a:spAutoFit/>
-          </a:bodyPr>
-          <a:lstStyle/>
-          <a:p>
-            <a:pPr algn="l"/>
-            <a:r>
-              <a:rPr sz="1900" b="0">
-                <a:solidFill>
-                  <a:srgbClr val="CADCFC"/>
-                </a:solidFill>
-                <a:latin typeface="Calibri"/>
-              </a:rPr>
-              <a:t>Uma pipeline de dados que integra essas fontes de forma automatica, confiavel e barata, na nuvem.</a:t>
-            </a:r>
-          </a:p>
-        </p:txBody>
-      </p:sp>
-      <p:sp>
-        <p:nvSpPr>
-          <p:cNvPr id="5" name="Rounded Rectangle 4"/>
-          <p:cNvSpPr/>
-          <p:nvPr/>
-        </p:nvSpPr>
-        <p:spPr>
-          <a:xfrm>
-            <a:off x="640080" y="2651760"/>
-            <a:ext cx="2560320" cy="2468880"/>
-          </a:xfrm>
-          <a:prstGeom prst="roundRect">
-            <a:avLst/>
-          </a:prstGeom>
           <a:solidFill>
-            <a:srgbClr val="2A3475"/>
+            <a:srgbClr val="ED145B"/>
           </a:solidFill>
           <a:ln>
             <a:noFill/>
@@ -5044,20 +5229,55 @@
       </p:sp>
       <p:sp>
         <p:nvSpPr>
-          <p:cNvPr id="6" name="Oval 5"/>
+          <p:cNvPr id="5" name="TextBox 4"/>
+          <p:cNvSpPr txBox="1"/>
+          <p:nvPr/>
+        </p:nvSpPr>
+        <p:spPr>
+          <a:xfrm>
+            <a:off x="640080" y="1463040"/>
+            <a:ext cx="10881360" cy="822960"/>
+          </a:xfrm>
+          <a:prstGeom prst="rect">
+            <a:avLst/>
+          </a:prstGeom>
+          <a:noFill/>
+        </p:spPr>
+        <p:txBody>
+          <a:bodyPr wrap="square" anchor="t" lIns="0" rIns="0" tIns="0" bIns="0">
+            <a:spAutoFit/>
+          </a:bodyPr>
+          <a:lstStyle/>
+          <a:p>
+            <a:pPr algn="l"/>
+            <a:r>
+              <a:rPr sz="1900" b="0">
+                <a:solidFill>
+                  <a:srgbClr val="E5E5E5"/>
+                </a:solidFill>
+                <a:latin typeface="Calibri"/>
+              </a:rPr>
+              <a:t>Uma pipeline de dados que integra essas fontes de forma automatica, confiavel e barata, na nuvem.</a:t>
+            </a:r>
+          </a:p>
+        </p:txBody>
+      </p:sp>
+      <p:sp>
+        <p:nvSpPr>
+          <p:cNvPr id="6" name="Rounded Rectangle 5"/>
           <p:cNvSpPr/>
           <p:nvPr/>
         </p:nvSpPr>
         <p:spPr>
           <a:xfrm>
-            <a:off x="1691639" y="2926080"/>
-            <a:ext cx="457200" cy="457200"/>
-          </a:xfrm>
-          <a:prstGeom prst="ellipse">
+            <a:off x="640080" y="2743200"/>
+            <a:ext cx="2560320" cy="2468880"/>
+          </a:xfrm>
+          <a:prstGeom prst="roundRect">
             <a:avLst/>
           </a:prstGeom>
           <a:solidFill>
-            <a:srgbClr val="00A896"/>
+            <a:srgbClr val="2B2B2B"/>
           </a:solidFill>
           <a:ln>
             <a:noFill/>
@@ -5079,6 +5299,50 @@
           </a:fontRef>
         </p:style>
         <p:txBody>
+          <a:bodyPr rtlCol="0" anchor="ctr"/>
+          <a:lstStyle/>
+          <a:p>
+            <a:pPr algn="ctr"/>
+          </a:p>
+        </p:txBody>
+      </p:sp>
+      <p:sp>
+        <p:nvSpPr>
+          <p:cNvPr id="7" name="Oval 6"/>
+          <p:cNvSpPr/>
+          <p:nvPr/>
+        </p:nvSpPr>
+        <p:spPr>
+          <a:xfrm>
+            <a:off x="1691639" y="3017520"/>
+            <a:ext cx="457200" cy="457200"/>
+          </a:xfrm>
+          <a:prstGeom prst="ellipse">
+            <a:avLst/>
+          </a:prstGeom>
+          <a:solidFill>
+            <a:srgbClr val="ED145B"/>
+          </a:solidFill>
+          <a:ln>
+            <a:noFill/>
+          </a:ln>
+          <a:effectLst/>
+        </p:spPr>
+        <p:style>
+          <a:lnRef idx="1">
+            <a:schemeClr val="accent1"/>
+          </a:lnRef>
+          <a:fillRef idx="3">
+            <a:schemeClr val="accent1"/>
+          </a:fillRef>
+          <a:effectRef idx="2">
+            <a:schemeClr val="accent1"/>
+          </a:effectRef>
+          <a:fontRef idx="minor">
+            <a:schemeClr val="lt1"/>
+          </a:fontRef>
+        </p:style>
+        <p:txBody>
           <a:bodyPr rtlCol="0" anchor="ctr" wrap="none"/>
           <a:lstStyle/>
           <a:p>
@@ -5097,13 +5361,13 @@
       </p:sp>
       <p:sp>
         <p:nvSpPr>
-          <p:cNvPr id="7" name="TextBox 6"/>
+          <p:cNvPr id="8" name="TextBox 7"/>
           <p:cNvSpPr txBox="1"/>
           <p:nvPr/>
         </p:nvSpPr>
         <p:spPr>
           <a:xfrm>
-            <a:off x="868680" y="3611880"/>
+            <a:off x="868680" y="3703320"/>
             <a:ext cx="2103120" cy="1371600"/>
           </a:xfrm>
           <a:prstGeom prst="rect">
@@ -5141,7 +5405,7 @@
             <a:r>
               <a:rPr sz="1300" b="0">
                 <a:solidFill>
-                  <a:srgbClr val="CADCFC"/>
+                  <a:srgbClr val="E5E5E5"/>
                 </a:solidFill>
                 <a:latin typeface="Calibri"/>
               </a:rPr>
@@ -5152,20 +5416,20 @@
       </p:sp>
       <p:sp>
         <p:nvSpPr>
-          <p:cNvPr id="8" name="Rounded Rectangle 7"/>
+          <p:cNvPr id="9" name="Rounded Rectangle 8"/>
           <p:cNvSpPr/>
           <p:nvPr/>
         </p:nvSpPr>
         <p:spPr>
           <a:xfrm>
-            <a:off x="3429000" y="2651760"/>
+            <a:off x="3429000" y="2743200"/>
             <a:ext cx="2560320" cy="2468880"/>
           </a:xfrm>
           <a:prstGeom prst="roundRect">
             <a:avLst/>
           </a:prstGeom>
           <a:solidFill>
-            <a:srgbClr val="2A3475"/>
+            <a:srgbClr val="2B2B2B"/>
           </a:solidFill>
           <a:ln>
             <a:noFill/>
@@ -5196,20 +5460,20 @@
       </p:sp>
       <p:sp>
         <p:nvSpPr>
-          <p:cNvPr id="9" name="Oval 8"/>
+          <p:cNvPr id="10" name="Oval 9"/>
           <p:cNvSpPr/>
           <p:nvPr/>
         </p:nvSpPr>
         <p:spPr>
           <a:xfrm>
-            <a:off x="4480560" y="2926080"/>
+            <a:off x="4480560" y="3017520"/>
             <a:ext cx="457200" cy="457200"/>
           </a:xfrm>
           <a:prstGeom prst="ellipse">
             <a:avLst/>
           </a:prstGeom>
           <a:solidFill>
-            <a:srgbClr val="00A896"/>
+            <a:srgbClr val="ED145B"/>
           </a:solidFill>
           <a:ln>
             <a:noFill/>
@@ -5249,13 +5513,13 @@
       </p:sp>
       <p:sp>
         <p:nvSpPr>
-          <p:cNvPr id="10" name="TextBox 9"/>
+          <p:cNvPr id="11" name="TextBox 10"/>
           <p:cNvSpPr txBox="1"/>
           <p:nvPr/>
         </p:nvSpPr>
         <p:spPr>
           <a:xfrm>
-            <a:off x="3657600" y="3611880"/>
+            <a:off x="3657600" y="3703320"/>
             <a:ext cx="2103120" cy="1371600"/>
           </a:xfrm>
           <a:prstGeom prst="rect">
@@ -5293,7 +5557,7 @@
             <a:r>
               <a:rPr sz="1300" b="0">
                 <a:solidFill>
-                  <a:srgbClr val="CADCFC"/>
+                  <a:srgbClr val="E5E5E5"/>
                 </a:solidFill>
                 <a:latin typeface="Calibri"/>
               </a:rPr>
@@ -5304,20 +5568,20 @@
       </p:sp>
       <p:sp>
         <p:nvSpPr>
-          <p:cNvPr id="11" name="Rounded Rectangle 10"/>
+          <p:cNvPr id="12" name="Rounded Rectangle 11"/>
           <p:cNvSpPr/>
           <p:nvPr/>
         </p:nvSpPr>
         <p:spPr>
           <a:xfrm>
-            <a:off x="6217920" y="2651760"/>
+            <a:off x="6217920" y="2743200"/>
             <a:ext cx="2560320" cy="2468880"/>
           </a:xfrm>
           <a:prstGeom prst="roundRect">
             <a:avLst/>
           </a:prstGeom>
           <a:solidFill>
-            <a:srgbClr val="2A3475"/>
+            <a:srgbClr val="2B2B2B"/>
           </a:solidFill>
           <a:ln>
             <a:noFill/>
@@ -5348,20 +5612,20 @@
       </p:sp>
       <p:sp>
         <p:nvSpPr>
-          <p:cNvPr id="12" name="Oval 11"/>
+          <p:cNvPr id="13" name="Oval 12"/>
           <p:cNvSpPr/>
           <p:nvPr/>
         </p:nvSpPr>
         <p:spPr>
           <a:xfrm>
-            <a:off x="7269479" y="2926080"/>
+            <a:off x="7269479" y="3017520"/>
             <a:ext cx="457200" cy="457200"/>
           </a:xfrm>
           <a:prstGeom prst="ellipse">
             <a:avLst/>
           </a:prstGeom>
           <a:solidFill>
-            <a:srgbClr val="00A896"/>
+            <a:srgbClr val="ED145B"/>
           </a:solidFill>
           <a:ln>
             <a:noFill/>
@@ -5401,13 +5665,13 @@
       </p:sp>
       <p:sp>
         <p:nvSpPr>
-          <p:cNvPr id="13" name="TextBox 12"/>
+          <p:cNvPr id="14" name="TextBox 13"/>
           <p:cNvSpPr txBox="1"/>
           <p:nvPr/>
         </p:nvSpPr>
         <p:spPr>
           <a:xfrm>
-            <a:off x="6446520" y="3611880"/>
+            <a:off x="6446520" y="3703320"/>
             <a:ext cx="2103120" cy="1371600"/>
           </a:xfrm>
           <a:prstGeom prst="rect">
@@ -5445,7 +5709,7 @@
             <a:r>
               <a:rPr sz="1300" b="0">
                 <a:solidFill>
-                  <a:srgbClr val="CADCFC"/>
+                  <a:srgbClr val="E5E5E5"/>
                 </a:solidFill>
                 <a:latin typeface="Calibri"/>
               </a:rPr>
@@ -5456,20 +5720,20 @@
       </p:sp>
       <p:sp>
         <p:nvSpPr>
-          <p:cNvPr id="14" name="Rounded Rectangle 13"/>
+          <p:cNvPr id="15" name="Rounded Rectangle 14"/>
           <p:cNvSpPr/>
           <p:nvPr/>
         </p:nvSpPr>
         <p:spPr>
           <a:xfrm>
-            <a:off x="9006839" y="2651760"/>
+            <a:off x="9006839" y="2743200"/>
             <a:ext cx="2560320" cy="2468880"/>
           </a:xfrm>
           <a:prstGeom prst="roundRect">
             <a:avLst/>
           </a:prstGeom>
           <a:solidFill>
-            <a:srgbClr val="2A3475"/>
+            <a:srgbClr val="2B2B2B"/>
           </a:solidFill>
           <a:ln>
             <a:noFill/>
@@ -5500,20 +5764,20 @@
       </p:sp>
       <p:sp>
         <p:nvSpPr>
-          <p:cNvPr id="15" name="Oval 14"/>
+          <p:cNvPr id="16" name="Oval 15"/>
           <p:cNvSpPr/>
           <p:nvPr/>
         </p:nvSpPr>
         <p:spPr>
           <a:xfrm>
-            <a:off x="10058399" y="2926080"/>
+            <a:off x="10058399" y="3017520"/>
             <a:ext cx="457200" cy="457200"/>
           </a:xfrm>
           <a:prstGeom prst="ellipse">
             <a:avLst/>
           </a:prstGeom>
           <a:solidFill>
-            <a:srgbClr val="00A896"/>
+            <a:srgbClr val="ED145B"/>
           </a:solidFill>
           <a:ln>
             <a:noFill/>
@@ -5553,13 +5817,13 @@
       </p:sp>
       <p:sp>
         <p:nvSpPr>
-          <p:cNvPr id="16" name="TextBox 15"/>
+          <p:cNvPr id="17" name="TextBox 16"/>
           <p:cNvSpPr txBox="1"/>
           <p:nvPr/>
         </p:nvSpPr>
         <p:spPr>
           <a:xfrm>
-            <a:off x="9235439" y="3611880"/>
+            <a:off x="9235439" y="3703320"/>
             <a:ext cx="2103120" cy="1371600"/>
           </a:xfrm>
           <a:prstGeom prst="rect">
@@ -5597,7 +5861,7 @@
             <a:r>
               <a:rPr sz="1300" b="0">
                 <a:solidFill>
-                  <a:srgbClr val="CADCFC"/>
+                  <a:srgbClr val="E5E5E5"/>
                 </a:solidFill>
                 <a:latin typeface="Calibri"/>
               </a:rPr>
@@ -5676,7 +5940,7 @@
         </p:nvSpPr>
         <p:spPr>
           <a:xfrm>
-            <a:off x="640080" y="502920"/>
+            <a:off x="640080" y="320040"/>
             <a:ext cx="10972800" cy="914400"/>
           </a:xfrm>
           <a:prstGeom prst="rect">
@@ -5694,7 +5958,7 @@
             <a:r>
               <a:rPr sz="3400" b="1">
                 <a:solidFill>
-                  <a:srgbClr val="1E2761"/>
+                  <a:srgbClr val="1A1A1A"/>
                 </a:solidFill>
                 <a:latin typeface="Calibri"/>
               </a:rPr>
@@ -5705,20 +5969,20 @@
       </p:sp>
       <p:sp>
         <p:nvSpPr>
-          <p:cNvPr id="4" name="Rounded Rectangle 3"/>
+          <p:cNvPr id="4" name="Rectangle 3"/>
           <p:cNvSpPr/>
           <p:nvPr/>
         </p:nvSpPr>
         <p:spPr>
           <a:xfrm>
-            <a:off x="640080" y="2103120"/>
-            <a:ext cx="1965960" cy="1645920"/>
-          </a:xfrm>
-          <a:prstGeom prst="roundRect">
+            <a:off x="658368" y="1069848"/>
+            <a:ext cx="1280160" cy="54864"/>
+          </a:xfrm>
+          <a:prstGeom prst="rect">
             <a:avLst/>
           </a:prstGeom>
           <a:solidFill>
-            <a:srgbClr val="CADCFC"/>
+            <a:srgbClr val="ED145B"/>
           </a:solidFill>
           <a:ln>
             <a:noFill/>
@@ -5747,16 +6011,40 @@
           </a:p>
         </p:txBody>
       </p:sp>
-      <p:sp>
-        <p:nvSpPr>
-          <p:cNvPr id="5" name="TextBox 4"/>
+      <p:pic>
+        <p:nvPicPr>
+          <p:cNvPr id="5" name="Picture 4" descr="arquitetura_fase2.png"/>
+          <p:cNvPicPr>
+            <a:picLocks noChangeAspect="1"/>
+          </p:cNvPicPr>
+          <p:nvPr/>
+        </p:nvPicPr>
+        <p:blipFill>
+          <a:blip r:embed="rId2"/>
+          <a:stretch>
+            <a:fillRect/>
+          </a:stretch>
+        </p:blipFill>
+        <p:spPr>
+          <a:xfrm>
+            <a:off x="335127" y="1051560"/>
+            <a:ext cx="11521440" cy="5812024"/>
+          </a:xfrm>
+          <a:prstGeom prst="rect">
+            <a:avLst/>
+          </a:prstGeom>
+        </p:spPr>
+      </p:pic>
+      <p:sp>
+        <p:nvSpPr>
+          <p:cNvPr id="6" name="TextBox 5"/>
           <p:cNvSpPr txBox="1"/>
           <p:nvPr/>
         </p:nvSpPr>
         <p:spPr>
           <a:xfrm>
-            <a:off x="731519" y="2286000"/>
-            <a:ext cx="1783080" cy="1371600"/>
+            <a:off x="640080" y="6909304"/>
+            <a:ext cx="10972800" cy="365760"/>
           </a:xfrm>
           <a:prstGeom prst="rect">
             <a:avLst/>
@@ -5769,642 +6057,15 @@
           </a:bodyPr>
           <a:lstStyle/>
           <a:p>
-            <a:pPr algn="ctr">
-              <a:spcAft>
-                <a:spcPts val="400"/>
-              </a:spcAft>
-            </a:pPr>
-            <a:r>
-              <a:rPr sz="1800" b="1">
-                <a:solidFill>
-                  <a:srgbClr val="1E2761"/>
-                </a:solidFill>
-                <a:latin typeface="Calibri"/>
-              </a:rPr>
-              <a:t>Fontes</a:t>
-            </a:r>
-          </a:p>
-          <a:p>
-            <a:pPr algn="ctr">
-              <a:spcAft>
-                <a:spcPts val="400"/>
-              </a:spcAft>
-            </a:pPr>
+            <a:pPr algn="l"/>
             <a:r>
               <a:rPr sz="1200" b="0">
                 <a:solidFill>
-                  <a:srgbClr val="5A5A5A"/>
-                </a:solidFill>
-                <a:latin typeface="Calibri"/>
-              </a:rPr>
-              <a:t>Base dos Dados e eventos</a:t>
-            </a:r>
-          </a:p>
-        </p:txBody>
-      </p:sp>
-      <p:sp>
-        <p:nvSpPr>
-          <p:cNvPr id="6" name="Right Arrow 5"/>
-          <p:cNvSpPr/>
-          <p:nvPr/>
-        </p:nvSpPr>
-        <p:spPr>
-          <a:xfrm>
-            <a:off x="2624327" y="2697480"/>
-            <a:ext cx="283464" cy="457200"/>
-          </a:xfrm>
-          <a:prstGeom prst="rightArrow">
-            <a:avLst/>
-          </a:prstGeom>
-          <a:solidFill>
-            <a:srgbClr val="1E2761"/>
-          </a:solidFill>
-          <a:ln>
-            <a:noFill/>
-          </a:ln>
-          <a:effectLst/>
-        </p:spPr>
-        <p:style>
-          <a:lnRef idx="1">
-            <a:schemeClr val="accent1"/>
-          </a:lnRef>
-          <a:fillRef idx="3">
-            <a:schemeClr val="accent1"/>
-          </a:fillRef>
-          <a:effectRef idx="2">
-            <a:schemeClr val="accent1"/>
-          </a:effectRef>
-          <a:fontRef idx="minor">
-            <a:schemeClr val="lt1"/>
-          </a:fontRef>
-        </p:style>
-        <p:txBody>
-          <a:bodyPr rtlCol="0" anchor="ctr"/>
-          <a:lstStyle/>
-          <a:p>
-            <a:pPr algn="ctr"/>
-          </a:p>
-        </p:txBody>
-      </p:sp>
-      <p:sp>
-        <p:nvSpPr>
-          <p:cNvPr id="7" name="Rounded Rectangle 6"/>
-          <p:cNvSpPr/>
-          <p:nvPr/>
-        </p:nvSpPr>
-        <p:spPr>
-          <a:xfrm>
-            <a:off x="2926080" y="2103120"/>
-            <a:ext cx="1965960" cy="1645920"/>
-          </a:xfrm>
-          <a:prstGeom prst="roundRect">
-            <a:avLst/>
-          </a:prstGeom>
-          <a:solidFill>
-            <a:srgbClr val="F4F6FB"/>
-          </a:solidFill>
-          <a:ln>
-            <a:noFill/>
-          </a:ln>
-          <a:effectLst/>
-        </p:spPr>
-        <p:style>
-          <a:lnRef idx="1">
-            <a:schemeClr val="accent1"/>
-          </a:lnRef>
-          <a:fillRef idx="3">
-            <a:schemeClr val="accent1"/>
-          </a:fillRef>
-          <a:effectRef idx="2">
-            <a:schemeClr val="accent1"/>
-          </a:effectRef>
-          <a:fontRef idx="minor">
-            <a:schemeClr val="lt1"/>
-          </a:fontRef>
-        </p:style>
-        <p:txBody>
-          <a:bodyPr rtlCol="0" anchor="ctr"/>
-          <a:lstStyle/>
-          <a:p>
-            <a:pPr algn="ctr"/>
-          </a:p>
-        </p:txBody>
-      </p:sp>
-      <p:sp>
-        <p:nvSpPr>
-          <p:cNvPr id="8" name="TextBox 7"/>
-          <p:cNvSpPr txBox="1"/>
-          <p:nvPr/>
-        </p:nvSpPr>
-        <p:spPr>
-          <a:xfrm>
-            <a:off x="3017520" y="2286000"/>
-            <a:ext cx="1783080" cy="1371600"/>
-          </a:xfrm>
-          <a:prstGeom prst="rect">
-            <a:avLst/>
-          </a:prstGeom>
-          <a:noFill/>
-        </p:spPr>
-        <p:txBody>
-          <a:bodyPr wrap="square" anchor="t" lIns="0" rIns="0" tIns="0" bIns="0">
-            <a:spAutoFit/>
-          </a:bodyPr>
-          <a:lstStyle/>
-          <a:p>
-            <a:pPr algn="ctr">
-              <a:spcAft>
-                <a:spcPts val="400"/>
-              </a:spcAft>
-            </a:pPr>
-            <a:r>
-              <a:rPr sz="1800" b="1">
-                <a:solidFill>
-                  <a:srgbClr val="1E2761"/>
-                </a:solidFill>
-                <a:latin typeface="Calibri"/>
-              </a:rPr>
-              <a:t>Bronze</a:t>
-            </a:r>
-          </a:p>
-          <a:p>
-            <a:pPr algn="ctr">
-              <a:spcAft>
-                <a:spcPts val="400"/>
-              </a:spcAft>
-            </a:pPr>
-            <a:r>
-              <a:rPr sz="1200" b="0">
-                <a:solidFill>
-                  <a:srgbClr val="5A5A5A"/>
-                </a:solidFill>
-                <a:latin typeface="Calibri"/>
-              </a:rPr>
-              <a:t>dado bruto</a:t>
-            </a:r>
-          </a:p>
-        </p:txBody>
-      </p:sp>
-      <p:sp>
-        <p:nvSpPr>
-          <p:cNvPr id="9" name="Right Arrow 8"/>
-          <p:cNvSpPr/>
-          <p:nvPr/>
-        </p:nvSpPr>
-        <p:spPr>
-          <a:xfrm>
-            <a:off x="4910327" y="2697480"/>
-            <a:ext cx="283464" cy="457200"/>
-          </a:xfrm>
-          <a:prstGeom prst="rightArrow">
-            <a:avLst/>
-          </a:prstGeom>
-          <a:solidFill>
-            <a:srgbClr val="1E2761"/>
-          </a:solidFill>
-          <a:ln>
-            <a:noFill/>
-          </a:ln>
-          <a:effectLst/>
-        </p:spPr>
-        <p:style>
-          <a:lnRef idx="1">
-            <a:schemeClr val="accent1"/>
-          </a:lnRef>
-          <a:fillRef idx="3">
-            <a:schemeClr val="accent1"/>
-          </a:fillRef>
-          <a:effectRef idx="2">
-            <a:schemeClr val="accent1"/>
-          </a:effectRef>
-          <a:fontRef idx="minor">
-            <a:schemeClr val="lt1"/>
-          </a:fontRef>
-        </p:style>
-        <p:txBody>
-          <a:bodyPr rtlCol="0" anchor="ctr"/>
-          <a:lstStyle/>
-          <a:p>
-            <a:pPr algn="ctr"/>
-          </a:p>
-        </p:txBody>
-      </p:sp>
-      <p:sp>
-        <p:nvSpPr>
-          <p:cNvPr id="10" name="Rounded Rectangle 9"/>
-          <p:cNvSpPr/>
-          <p:nvPr/>
-        </p:nvSpPr>
-        <p:spPr>
-          <a:xfrm>
-            <a:off x="5212080" y="2103120"/>
-            <a:ext cx="1965960" cy="1645920"/>
-          </a:xfrm>
-          <a:prstGeom prst="roundRect">
-            <a:avLst/>
-          </a:prstGeom>
-          <a:solidFill>
-            <a:srgbClr val="F4F6FB"/>
-          </a:solidFill>
-          <a:ln>
-            <a:noFill/>
-          </a:ln>
-          <a:effectLst/>
-        </p:spPr>
-        <p:style>
-          <a:lnRef idx="1">
-            <a:schemeClr val="accent1"/>
-          </a:lnRef>
-          <a:fillRef idx="3">
-            <a:schemeClr val="accent1"/>
-          </a:fillRef>
-          <a:effectRef idx="2">
-            <a:schemeClr val="accent1"/>
-          </a:effectRef>
-          <a:fontRef idx="minor">
-            <a:schemeClr val="lt1"/>
-          </a:fontRef>
-        </p:style>
-        <p:txBody>
-          <a:bodyPr rtlCol="0" anchor="ctr"/>
-          <a:lstStyle/>
-          <a:p>
-            <a:pPr algn="ctr"/>
-          </a:p>
-        </p:txBody>
-      </p:sp>
-      <p:sp>
-        <p:nvSpPr>
-          <p:cNvPr id="11" name="TextBox 10"/>
-          <p:cNvSpPr txBox="1"/>
-          <p:nvPr/>
-        </p:nvSpPr>
-        <p:spPr>
-          <a:xfrm>
-            <a:off x="5303520" y="2286000"/>
-            <a:ext cx="1783080" cy="1371600"/>
-          </a:xfrm>
-          <a:prstGeom prst="rect">
-            <a:avLst/>
-          </a:prstGeom>
-          <a:noFill/>
-        </p:spPr>
-        <p:txBody>
-          <a:bodyPr wrap="square" anchor="t" lIns="0" rIns="0" tIns="0" bIns="0">
-            <a:spAutoFit/>
-          </a:bodyPr>
-          <a:lstStyle/>
-          <a:p>
-            <a:pPr algn="ctr">
-              <a:spcAft>
-                <a:spcPts val="400"/>
-              </a:spcAft>
-            </a:pPr>
-            <a:r>
-              <a:rPr sz="1800" b="1">
-                <a:solidFill>
-                  <a:srgbClr val="1E2761"/>
-                </a:solidFill>
-                <a:latin typeface="Calibri"/>
-              </a:rPr>
-              <a:t>Silver</a:t>
-            </a:r>
-          </a:p>
-          <a:p>
-            <a:pPr algn="ctr">
-              <a:spcAft>
-                <a:spcPts val="400"/>
-              </a:spcAft>
-            </a:pPr>
-            <a:r>
-              <a:rPr sz="1200" b="0">
-                <a:solidFill>
-                  <a:srgbClr val="5A5A5A"/>
-                </a:solidFill>
-                <a:latin typeface="Calibri"/>
-              </a:rPr>
-              <a:t>limpo e integrado</a:t>
-            </a:r>
-          </a:p>
-        </p:txBody>
-      </p:sp>
-      <p:sp>
-        <p:nvSpPr>
-          <p:cNvPr id="12" name="Right Arrow 11"/>
-          <p:cNvSpPr/>
-          <p:nvPr/>
-        </p:nvSpPr>
-        <p:spPr>
-          <a:xfrm>
-            <a:off x="7196327" y="2697480"/>
-            <a:ext cx="283464" cy="457200"/>
-          </a:xfrm>
-          <a:prstGeom prst="rightArrow">
-            <a:avLst/>
-          </a:prstGeom>
-          <a:solidFill>
-            <a:srgbClr val="1E2761"/>
-          </a:solidFill>
-          <a:ln>
-            <a:noFill/>
-          </a:ln>
-          <a:effectLst/>
-        </p:spPr>
-        <p:style>
-          <a:lnRef idx="1">
-            <a:schemeClr val="accent1"/>
-          </a:lnRef>
-          <a:fillRef idx="3">
-            <a:schemeClr val="accent1"/>
-          </a:fillRef>
-          <a:effectRef idx="2">
-            <a:schemeClr val="accent1"/>
-          </a:effectRef>
-          <a:fontRef idx="minor">
-            <a:schemeClr val="lt1"/>
-          </a:fontRef>
-        </p:style>
-        <p:txBody>
-          <a:bodyPr rtlCol="0" anchor="ctr"/>
-          <a:lstStyle/>
-          <a:p>
-            <a:pPr algn="ctr"/>
-          </a:p>
-        </p:txBody>
-      </p:sp>
-      <p:sp>
-        <p:nvSpPr>
-          <p:cNvPr id="13" name="Rounded Rectangle 12"/>
-          <p:cNvSpPr/>
-          <p:nvPr/>
-        </p:nvSpPr>
-        <p:spPr>
-          <a:xfrm>
-            <a:off x="7498079" y="2103120"/>
-            <a:ext cx="1965960" cy="1645920"/>
-          </a:xfrm>
-          <a:prstGeom prst="roundRect">
-            <a:avLst/>
-          </a:prstGeom>
-          <a:solidFill>
-            <a:srgbClr val="00A896"/>
-          </a:solidFill>
-          <a:ln>
-            <a:noFill/>
-          </a:ln>
-          <a:effectLst/>
-        </p:spPr>
-        <p:style>
-          <a:lnRef idx="1">
-            <a:schemeClr val="accent1"/>
-          </a:lnRef>
-          <a:fillRef idx="3">
-            <a:schemeClr val="accent1"/>
-          </a:fillRef>
-          <a:effectRef idx="2">
-            <a:schemeClr val="accent1"/>
-          </a:effectRef>
-          <a:fontRef idx="minor">
-            <a:schemeClr val="lt1"/>
-          </a:fontRef>
-        </p:style>
-        <p:txBody>
-          <a:bodyPr rtlCol="0" anchor="ctr"/>
-          <a:lstStyle/>
-          <a:p>
-            <a:pPr algn="ctr"/>
-          </a:p>
-        </p:txBody>
-      </p:sp>
-      <p:sp>
-        <p:nvSpPr>
-          <p:cNvPr id="14" name="TextBox 13"/>
-          <p:cNvSpPr txBox="1"/>
-          <p:nvPr/>
-        </p:nvSpPr>
-        <p:spPr>
-          <a:xfrm>
-            <a:off x="7589519" y="2286000"/>
-            <a:ext cx="1783080" cy="1371600"/>
-          </a:xfrm>
-          <a:prstGeom prst="rect">
-            <a:avLst/>
-          </a:prstGeom>
-          <a:noFill/>
-        </p:spPr>
-        <p:txBody>
-          <a:bodyPr wrap="square" anchor="t" lIns="0" rIns="0" tIns="0" bIns="0">
-            <a:spAutoFit/>
-          </a:bodyPr>
-          <a:lstStyle/>
-          <a:p>
-            <a:pPr algn="ctr">
-              <a:spcAft>
-                <a:spcPts val="400"/>
-              </a:spcAft>
-            </a:pPr>
-            <a:r>
-              <a:rPr sz="1800" b="1">
-                <a:solidFill>
-                  <a:srgbClr val="FFFFFF"/>
-                </a:solidFill>
-                <a:latin typeface="Calibri"/>
-              </a:rPr>
-              <a:t>Gold</a:t>
-            </a:r>
-          </a:p>
-          <a:p>
-            <a:pPr algn="ctr">
-              <a:spcAft>
-                <a:spcPts val="400"/>
-              </a:spcAft>
-            </a:pPr>
-            <a:r>
-              <a:rPr sz="1200" b="0">
-                <a:solidFill>
-                  <a:srgbClr val="FFFFFF"/>
-                </a:solidFill>
-                <a:latin typeface="Calibri"/>
-              </a:rPr>
-              <a:t>analitico</a:t>
-            </a:r>
-          </a:p>
-        </p:txBody>
-      </p:sp>
-      <p:sp>
-        <p:nvSpPr>
-          <p:cNvPr id="15" name="Right Arrow 14"/>
-          <p:cNvSpPr/>
-          <p:nvPr/>
-        </p:nvSpPr>
-        <p:spPr>
-          <a:xfrm>
-            <a:off x="9482328" y="2697480"/>
-            <a:ext cx="283464" cy="457200"/>
-          </a:xfrm>
-          <a:prstGeom prst="rightArrow">
-            <a:avLst/>
-          </a:prstGeom>
-          <a:solidFill>
-            <a:srgbClr val="1E2761"/>
-          </a:solidFill>
-          <a:ln>
-            <a:noFill/>
-          </a:ln>
-          <a:effectLst/>
-        </p:spPr>
-        <p:style>
-          <a:lnRef idx="1">
-            <a:schemeClr val="accent1"/>
-          </a:lnRef>
-          <a:fillRef idx="3">
-            <a:schemeClr val="accent1"/>
-          </a:fillRef>
-          <a:effectRef idx="2">
-            <a:schemeClr val="accent1"/>
-          </a:effectRef>
-          <a:fontRef idx="minor">
-            <a:schemeClr val="lt1"/>
-          </a:fontRef>
-        </p:style>
-        <p:txBody>
-          <a:bodyPr rtlCol="0" anchor="ctr"/>
-          <a:lstStyle/>
-          <a:p>
-            <a:pPr algn="ctr"/>
-          </a:p>
-        </p:txBody>
-      </p:sp>
-      <p:sp>
-        <p:nvSpPr>
-          <p:cNvPr id="16" name="Rounded Rectangle 15"/>
-          <p:cNvSpPr/>
-          <p:nvPr/>
-        </p:nvSpPr>
-        <p:spPr>
-          <a:xfrm>
-            <a:off x="9784080" y="2103120"/>
-            <a:ext cx="1965960" cy="1645920"/>
-          </a:xfrm>
-          <a:prstGeom prst="roundRect">
-            <a:avLst/>
-          </a:prstGeom>
-          <a:solidFill>
-            <a:srgbClr val="CADCFC"/>
-          </a:solidFill>
-          <a:ln>
-            <a:noFill/>
-          </a:ln>
-          <a:effectLst/>
-        </p:spPr>
-        <p:style>
-          <a:lnRef idx="1">
-            <a:schemeClr val="accent1"/>
-          </a:lnRef>
-          <a:fillRef idx="3">
-            <a:schemeClr val="accent1"/>
-          </a:fillRef>
-          <a:effectRef idx="2">
-            <a:schemeClr val="accent1"/>
-          </a:effectRef>
-          <a:fontRef idx="minor">
-            <a:schemeClr val="lt1"/>
-          </a:fontRef>
-        </p:style>
-        <p:txBody>
-          <a:bodyPr rtlCol="0" anchor="ctr"/>
-          <a:lstStyle/>
-          <a:p>
-            <a:pPr algn="ctr"/>
-          </a:p>
-        </p:txBody>
-      </p:sp>
-      <p:sp>
-        <p:nvSpPr>
-          <p:cNvPr id="17" name="TextBox 16"/>
-          <p:cNvSpPr txBox="1"/>
-          <p:nvPr/>
-        </p:nvSpPr>
-        <p:spPr>
-          <a:xfrm>
-            <a:off x="9875519" y="2286000"/>
-            <a:ext cx="1783080" cy="1371600"/>
-          </a:xfrm>
-          <a:prstGeom prst="rect">
-            <a:avLst/>
-          </a:prstGeom>
-          <a:noFill/>
-        </p:spPr>
-        <p:txBody>
-          <a:bodyPr wrap="square" anchor="t" lIns="0" rIns="0" tIns="0" bIns="0">
-            <a:spAutoFit/>
-          </a:bodyPr>
-          <a:lstStyle/>
-          <a:p>
-            <a:pPr algn="ctr">
-              <a:spcAft>
-                <a:spcPts val="400"/>
-              </a:spcAft>
-            </a:pPr>
-            <a:r>
-              <a:rPr sz="1800" b="1">
-                <a:solidFill>
-                  <a:srgbClr val="1E2761"/>
-                </a:solidFill>
-                <a:latin typeface="Calibri"/>
-              </a:rPr>
-              <a:t>Consumo</a:t>
-            </a:r>
-          </a:p>
-          <a:p>
-            <a:pPr algn="ctr">
-              <a:spcAft>
-                <a:spcPts val="400"/>
-              </a:spcAft>
-            </a:pPr>
-            <a:r>
-              <a:rPr sz="1200" b="0">
-                <a:solidFill>
-                  <a:srgbClr val="5A5A5A"/>
-                </a:solidFill>
-                <a:latin typeface="Calibri"/>
-              </a:rPr>
-              <a:t>Athena, BI e ML</a:t>
-            </a:r>
-          </a:p>
-        </p:txBody>
-      </p:sp>
-      <p:sp>
-        <p:nvSpPr>
-          <p:cNvPr id="18" name="TextBox 17"/>
-          <p:cNvSpPr txBox="1"/>
-          <p:nvPr/>
-        </p:nvSpPr>
-        <p:spPr>
-          <a:xfrm>
-            <a:off x="640080" y="4297680"/>
-            <a:ext cx="10881360" cy="1463040"/>
-          </a:xfrm>
-          <a:prstGeom prst="rect">
-            <a:avLst/>
-          </a:prstGeom>
-          <a:noFill/>
-        </p:spPr>
-        <p:txBody>
-          <a:bodyPr wrap="square" anchor="t" lIns="0" rIns="0" tIns="0" bIns="0">
-            <a:spAutoFit/>
-          </a:bodyPr>
-          <a:lstStyle/>
-          <a:p>
-            <a:pPr algn="l"/>
-            <a:r>
-              <a:rPr sz="1600" b="0">
-                <a:solidFill>
-                  <a:srgbClr val="2B2B2B"/>
-                </a:solidFill>
-                <a:latin typeface="Calibri"/>
-              </a:rPr>
-              <a:t>Step Functions orquestra as etapas e o EventBridge dispara na agenda. Um gate de qualidade barra dado ruim antes da camada analitica, e o CloudWatch acompanha latencia, volume e falhas.</a:t>
+                  <a:srgbClr val="555555"/>
+                </a:solidFill>
+                <a:latin typeface="Calibri"/>
+              </a:rPr>
+              <a:t>Bronze bruto, Silver limpo e integrado, Gold analitico em star schema; batch e streaming na entrada, Athena, BI e ML na saida.</a:t>
             </a:r>
           </a:p>
         </p:txBody>
@@ -6497,7 +6158,7 @@
             <a:r>
               <a:rPr sz="3400" b="1">
                 <a:solidFill>
-                  <a:srgbClr val="1E2761"/>
+                  <a:srgbClr val="1A1A1A"/>
                 </a:solidFill>
                 <a:latin typeface="Calibri"/>
               </a:rPr>
@@ -6508,20 +6169,20 @@
       </p:sp>
       <p:sp>
         <p:nvSpPr>
-          <p:cNvPr id="4" name="Rounded Rectangle 3"/>
+          <p:cNvPr id="4" name="Rectangle 3"/>
           <p:cNvSpPr/>
           <p:nvPr/>
         </p:nvSpPr>
         <p:spPr>
           <a:xfrm>
-            <a:off x="640080" y="1554480"/>
-            <a:ext cx="5349240" cy="4206240"/>
-          </a:xfrm>
-          <a:prstGeom prst="roundRect">
+            <a:off x="658368" y="1252728"/>
+            <a:ext cx="1280160" cy="54864"/>
+          </a:xfrm>
+          <a:prstGeom prst="rect">
             <a:avLst/>
           </a:prstGeom>
           <a:solidFill>
-            <a:srgbClr val="F4F6FB"/>
+            <a:srgbClr val="ED145B"/>
           </a:solidFill>
           <a:ln>
             <a:noFill/>
@@ -6552,20 +6213,20 @@
       </p:sp>
       <p:sp>
         <p:nvSpPr>
-          <p:cNvPr id="5" name="Oval 4"/>
+          <p:cNvPr id="5" name="Rounded Rectangle 4"/>
           <p:cNvSpPr/>
           <p:nvPr/>
         </p:nvSpPr>
         <p:spPr>
           <a:xfrm>
-            <a:off x="914400" y="1828800"/>
-            <a:ext cx="548640" cy="548640"/>
-          </a:xfrm>
-          <a:prstGeom prst="ellipse">
+            <a:off x="640080" y="1645920"/>
+            <a:ext cx="5349240" cy="4206240"/>
+          </a:xfrm>
+          <a:prstGeom prst="roundRect">
             <a:avLst/>
           </a:prstGeom>
           <a:solidFill>
-            <a:srgbClr val="1E2761"/>
+            <a:srgbClr val="F4F4F6"/>
           </a:solidFill>
           <a:ln>
             <a:noFill/>
@@ -6587,6 +6248,50 @@
           </a:fontRef>
         </p:style>
         <p:txBody>
+          <a:bodyPr rtlCol="0" anchor="ctr"/>
+          <a:lstStyle/>
+          <a:p>
+            <a:pPr algn="ctr"/>
+          </a:p>
+        </p:txBody>
+      </p:sp>
+      <p:sp>
+        <p:nvSpPr>
+          <p:cNvPr id="6" name="Oval 5"/>
+          <p:cNvSpPr/>
+          <p:nvPr/>
+        </p:nvSpPr>
+        <p:spPr>
+          <a:xfrm>
+            <a:off x="914400" y="1920240"/>
+            <a:ext cx="548640" cy="548640"/>
+          </a:xfrm>
+          <a:prstGeom prst="ellipse">
+            <a:avLst/>
+          </a:prstGeom>
+          <a:solidFill>
+            <a:srgbClr val="1A1A1A"/>
+          </a:solidFill>
+          <a:ln>
+            <a:noFill/>
+          </a:ln>
+          <a:effectLst/>
+        </p:spPr>
+        <p:style>
+          <a:lnRef idx="1">
+            <a:schemeClr val="accent1"/>
+          </a:lnRef>
+          <a:fillRef idx="3">
+            <a:schemeClr val="accent1"/>
+          </a:fillRef>
+          <a:effectRef idx="2">
+            <a:schemeClr val="accent1"/>
+          </a:effectRef>
+          <a:fontRef idx="minor">
+            <a:schemeClr val="lt1"/>
+          </a:fontRef>
+        </p:style>
+        <p:txBody>
           <a:bodyPr rtlCol="0" anchor="ctr" wrap="none"/>
           <a:lstStyle/>
           <a:p>
@@ -6605,13 +6310,13 @@
       </p:sp>
       <p:sp>
         <p:nvSpPr>
-          <p:cNvPr id="6" name="TextBox 5"/>
+          <p:cNvPr id="7" name="TextBox 6"/>
           <p:cNvSpPr txBox="1"/>
           <p:nvPr/>
         </p:nvSpPr>
         <p:spPr>
           <a:xfrm>
-            <a:off x="1645920" y="1874519"/>
+            <a:off x="1645920" y="1965960"/>
             <a:ext cx="4206240" cy="548640"/>
           </a:xfrm>
           <a:prstGeom prst="rect">
@@ -6629,7 +6334,7 @@
             <a:r>
               <a:rPr sz="2200" b="1">
                 <a:solidFill>
-                  <a:srgbClr val="1E2761"/>
+                  <a:srgbClr val="1A1A1A"/>
                 </a:solidFill>
                 <a:latin typeface="Calibri"/>
               </a:rPr>
@@ -6640,13 +6345,13 @@
       </p:sp>
       <p:sp>
         <p:nvSpPr>
-          <p:cNvPr id="7" name="TextBox 6"/>
+          <p:cNvPr id="8" name="TextBox 7"/>
           <p:cNvSpPr txBox="1"/>
           <p:nvPr/>
         </p:nvSpPr>
         <p:spPr>
           <a:xfrm>
-            <a:off x="914400" y="2697480"/>
+            <a:off x="914400" y="2788920"/>
             <a:ext cx="4846320" cy="2834640"/>
           </a:xfrm>
           <a:prstGeom prst="rect">
@@ -6668,7 +6373,7 @@
             <a:r>
               <a:rPr sz="1500" b="1">
                 <a:solidFill>
-                  <a:srgbClr val="2B2B2B"/>
+                  <a:srgbClr val="1A1A1A"/>
                 </a:solidFill>
                 <a:latin typeface="Calibri"/>
               </a:rPr>
@@ -6684,7 +6389,7 @@
             <a:r>
               <a:rPr sz="1400" b="0">
                 <a:solidFill>
-                  <a:srgbClr val="5A5A5A"/>
+                  <a:srgbClr val="555555"/>
                 </a:solidFill>
                 <a:latin typeface="Calibri"/>
               </a:rPr>
@@ -6700,7 +6405,7 @@
             <a:r>
               <a:rPr sz="1400" b="0">
                 <a:solidFill>
-                  <a:srgbClr val="5A5A5A"/>
+                  <a:srgbClr val="555555"/>
                 </a:solidFill>
                 <a:latin typeface="Calibri"/>
               </a:rPr>
@@ -6711,20 +6416,20 @@
       </p:sp>
       <p:sp>
         <p:nvSpPr>
-          <p:cNvPr id="8" name="Rounded Rectangle 7"/>
+          <p:cNvPr id="9" name="Rounded Rectangle 8"/>
           <p:cNvSpPr/>
           <p:nvPr/>
         </p:nvSpPr>
         <p:spPr>
           <a:xfrm>
-            <a:off x="6217920" y="1554480"/>
+            <a:off x="6217920" y="1645920"/>
             <a:ext cx="5349240" cy="4206240"/>
           </a:xfrm>
           <a:prstGeom prst="roundRect">
             <a:avLst/>
           </a:prstGeom>
           <a:solidFill>
-            <a:srgbClr val="F4F6FB"/>
+            <a:srgbClr val="F4F4F6"/>
           </a:solidFill>
           <a:ln>
             <a:noFill/>
@@ -6755,20 +6460,20 @@
       </p:sp>
       <p:sp>
         <p:nvSpPr>
-          <p:cNvPr id="9" name="Oval 8"/>
+          <p:cNvPr id="10" name="Oval 9"/>
           <p:cNvSpPr/>
           <p:nvPr/>
         </p:nvSpPr>
         <p:spPr>
           <a:xfrm>
-            <a:off x="6492240" y="1828800"/>
+            <a:off x="6492240" y="1920240"/>
             <a:ext cx="548640" cy="548640"/>
           </a:xfrm>
           <a:prstGeom prst="ellipse">
             <a:avLst/>
           </a:prstGeom>
           <a:solidFill>
-            <a:srgbClr val="00A896"/>
+            <a:srgbClr val="ED145B"/>
           </a:solidFill>
           <a:ln>
             <a:noFill/>
@@ -6808,13 +6513,13 @@
       </p:sp>
       <p:sp>
         <p:nvSpPr>
-          <p:cNvPr id="10" name="TextBox 9"/>
+          <p:cNvPr id="11" name="TextBox 10"/>
           <p:cNvSpPr txBox="1"/>
           <p:nvPr/>
         </p:nvSpPr>
         <p:spPr>
           <a:xfrm>
-            <a:off x="7223760" y="1874519"/>
+            <a:off x="7223760" y="1965960"/>
             <a:ext cx="4206240" cy="548640"/>
           </a:xfrm>
           <a:prstGeom prst="rect">
@@ -6832,7 +6537,7 @@
             <a:r>
               <a:rPr sz="2200" b="1">
                 <a:solidFill>
-                  <a:srgbClr val="00A896"/>
+                  <a:srgbClr val="ED145B"/>
                 </a:solidFill>
                 <a:latin typeface="Calibri"/>
               </a:rPr>
@@ -6843,13 +6548,13 @@
       </p:sp>
       <p:sp>
         <p:nvSpPr>
-          <p:cNvPr id="11" name="TextBox 10"/>
+          <p:cNvPr id="12" name="TextBox 11"/>
           <p:cNvSpPr txBox="1"/>
           <p:nvPr/>
         </p:nvSpPr>
         <p:spPr>
           <a:xfrm>
-            <a:off x="6492240" y="2697480"/>
+            <a:off x="6492240" y="2788920"/>
             <a:ext cx="4846320" cy="2834640"/>
           </a:xfrm>
           <a:prstGeom prst="rect">
@@ -6871,7 +6576,7 @@
             <a:r>
               <a:rPr sz="1500" b="1">
                 <a:solidFill>
-                  <a:srgbClr val="2B2B2B"/>
+                  <a:srgbClr val="1A1A1A"/>
                 </a:solidFill>
                 <a:latin typeface="Calibri"/>
               </a:rPr>
@@ -6887,7 +6592,7 @@
             <a:r>
               <a:rPr sz="1400" b="0">
                 <a:solidFill>
-                  <a:srgbClr val="5A5A5A"/>
+                  <a:srgbClr val="555555"/>
                 </a:solidFill>
                 <a:latin typeface="Calibri"/>
               </a:rPr>
@@ -6903,7 +6608,7 @@
             <a:r>
               <a:rPr sz="1400" b="0">
                 <a:solidFill>
-                  <a:srgbClr val="5A5A5A"/>
+                  <a:srgbClr val="555555"/>
                 </a:solidFill>
                 <a:latin typeface="Calibri"/>
               </a:rPr>
@@ -7000,7 +6705,7 @@
             <a:r>
               <a:rPr sz="3400" b="1">
                 <a:solidFill>
-                  <a:srgbClr val="1E2761"/>
+                  <a:srgbClr val="1A1A1A"/>
                 </a:solidFill>
                 <a:latin typeface="Calibri"/>
               </a:rPr>
@@ -7011,20 +6716,20 @@
       </p:sp>
       <p:sp>
         <p:nvSpPr>
-          <p:cNvPr id="4" name="Rounded Rectangle 3"/>
+          <p:cNvPr id="4" name="Rectangle 3"/>
           <p:cNvSpPr/>
           <p:nvPr/>
         </p:nvSpPr>
         <p:spPr>
           <a:xfrm>
-            <a:off x="640080" y="1737360"/>
-            <a:ext cx="3474720" cy="3474720"/>
-          </a:xfrm>
-          <a:prstGeom prst="roundRect">
+            <a:off x="658368" y="1252728"/>
+            <a:ext cx="1280160" cy="54864"/>
+          </a:xfrm>
+          <a:prstGeom prst="rect">
             <a:avLst/>
           </a:prstGeom>
           <a:solidFill>
-            <a:srgbClr val="F4F6FB"/>
+            <a:srgbClr val="ED145B"/>
           </a:solidFill>
           <a:ln>
             <a:noFill/>
@@ -7055,20 +6760,20 @@
       </p:sp>
       <p:sp>
         <p:nvSpPr>
-          <p:cNvPr id="5" name="Oval 4"/>
+          <p:cNvPr id="5" name="Rounded Rectangle 4"/>
           <p:cNvSpPr/>
           <p:nvPr/>
         </p:nvSpPr>
         <p:spPr>
           <a:xfrm>
-            <a:off x="914400" y="2011680"/>
-            <a:ext cx="502920" cy="502920"/>
-          </a:xfrm>
-          <a:prstGeom prst="ellipse">
+            <a:off x="640080" y="1828800"/>
+            <a:ext cx="3474720" cy="3474720"/>
+          </a:xfrm>
+          <a:prstGeom prst="roundRect">
             <a:avLst/>
           </a:prstGeom>
           <a:solidFill>
-            <a:srgbClr val="B07A3C"/>
+            <a:srgbClr val="F4F4F6"/>
           </a:solidFill>
           <a:ln>
             <a:noFill/>
@@ -7090,6 +6795,50 @@
           </a:fontRef>
         </p:style>
         <p:txBody>
+          <a:bodyPr rtlCol="0" anchor="ctr"/>
+          <a:lstStyle/>
+          <a:p>
+            <a:pPr algn="ctr"/>
+          </a:p>
+        </p:txBody>
+      </p:sp>
+      <p:sp>
+        <p:nvSpPr>
+          <p:cNvPr id="6" name="Oval 5"/>
+          <p:cNvSpPr/>
+          <p:nvPr/>
+        </p:nvSpPr>
+        <p:spPr>
+          <a:xfrm>
+            <a:off x="914400" y="2103120"/>
+            <a:ext cx="502920" cy="502920"/>
+          </a:xfrm>
+          <a:prstGeom prst="ellipse">
+            <a:avLst/>
+          </a:prstGeom>
+          <a:solidFill>
+            <a:srgbClr val="B0794A"/>
+          </a:solidFill>
+          <a:ln>
+            <a:noFill/>
+          </a:ln>
+          <a:effectLst/>
+        </p:spPr>
+        <p:style>
+          <a:lnRef idx="1">
+            <a:schemeClr val="accent1"/>
+          </a:lnRef>
+          <a:fillRef idx="3">
+            <a:schemeClr val="accent1"/>
+          </a:fillRef>
+          <a:effectRef idx="2">
+            <a:schemeClr val="accent1"/>
+          </a:effectRef>
+          <a:fontRef idx="minor">
+            <a:schemeClr val="lt1"/>
+          </a:fontRef>
+        </p:style>
+        <p:txBody>
           <a:bodyPr rtlCol="0" anchor="ctr" wrap="none"/>
           <a:lstStyle/>
           <a:p>
@@ -7108,13 +6857,13 @@
       </p:sp>
       <p:sp>
         <p:nvSpPr>
-          <p:cNvPr id="6" name="TextBox 5"/>
+          <p:cNvPr id="7" name="TextBox 6"/>
           <p:cNvSpPr txBox="1"/>
           <p:nvPr/>
         </p:nvSpPr>
         <p:spPr>
           <a:xfrm>
-            <a:off x="914400" y="2743200"/>
+            <a:off x="914400" y="2834640"/>
             <a:ext cx="2926080" cy="2286000"/>
           </a:xfrm>
           <a:prstGeom prst="rect">
@@ -7136,7 +6885,7 @@
             <a:r>
               <a:rPr sz="2200" b="1">
                 <a:solidFill>
-                  <a:srgbClr val="1E2761"/>
+                  <a:srgbClr val="1A1A1A"/>
                 </a:solidFill>
                 <a:latin typeface="Calibri"/>
               </a:rPr>
@@ -7152,7 +6901,7 @@
             <a:r>
               <a:rPr sz="1500" b="0">
                 <a:solidFill>
-                  <a:srgbClr val="2B2B2B"/>
+                  <a:srgbClr val="1A1A1A"/>
                 </a:solidFill>
                 <a:latin typeface="Calibri"/>
               </a:rPr>
@@ -7163,20 +6912,20 @@
       </p:sp>
       <p:sp>
         <p:nvSpPr>
-          <p:cNvPr id="7" name="Rounded Rectangle 6"/>
+          <p:cNvPr id="8" name="Rounded Rectangle 7"/>
           <p:cNvSpPr/>
           <p:nvPr/>
         </p:nvSpPr>
         <p:spPr>
           <a:xfrm>
-            <a:off x="4343400" y="1737360"/>
+            <a:off x="4343400" y="1828800"/>
             <a:ext cx="3474720" cy="3474720"/>
           </a:xfrm>
           <a:prstGeom prst="roundRect">
             <a:avLst/>
           </a:prstGeom>
           <a:solidFill>
-            <a:srgbClr val="F4F6FB"/>
+            <a:srgbClr val="F4F4F6"/>
           </a:solidFill>
           <a:ln>
             <a:noFill/>
@@ -7207,13 +6956,13 @@
       </p:sp>
       <p:sp>
         <p:nvSpPr>
-          <p:cNvPr id="8" name="Oval 7"/>
+          <p:cNvPr id="9" name="Oval 8"/>
           <p:cNvSpPr/>
           <p:nvPr/>
         </p:nvSpPr>
         <p:spPr>
           <a:xfrm>
-            <a:off x="4617720" y="2011680"/>
+            <a:off x="4617720" y="2103120"/>
             <a:ext cx="502920" cy="502920"/>
           </a:xfrm>
           <a:prstGeom prst="ellipse">
@@ -7260,13 +7009,13 @@
       </p:sp>
       <p:sp>
         <p:nvSpPr>
-          <p:cNvPr id="9" name="TextBox 8"/>
+          <p:cNvPr id="10" name="TextBox 9"/>
           <p:cNvSpPr txBox="1"/>
           <p:nvPr/>
         </p:nvSpPr>
         <p:spPr>
           <a:xfrm>
-            <a:off x="4617720" y="2743200"/>
+            <a:off x="4617720" y="2834640"/>
             <a:ext cx="2926080" cy="2286000"/>
           </a:xfrm>
           <a:prstGeom prst="rect">
@@ -7288,7 +7037,7 @@
             <a:r>
               <a:rPr sz="2200" b="1">
                 <a:solidFill>
-                  <a:srgbClr val="1E2761"/>
+                  <a:srgbClr val="1A1A1A"/>
                 </a:solidFill>
                 <a:latin typeface="Calibri"/>
               </a:rPr>
@@ -7304,7 +7053,7 @@
             <a:r>
               <a:rPr sz="1500" b="0">
                 <a:solidFill>
-                  <a:srgbClr val="2B2B2B"/>
+                  <a:srgbClr val="1A1A1A"/>
                 </a:solidFill>
                 <a:latin typeface="Calibri"/>
               </a:rPr>
@@ -7315,20 +7064,20 @@
       </p:sp>
       <p:sp>
         <p:nvSpPr>
-          <p:cNvPr id="10" name="Rounded Rectangle 9"/>
+          <p:cNvPr id="11" name="Rounded Rectangle 10"/>
           <p:cNvSpPr/>
           <p:nvPr/>
         </p:nvSpPr>
         <p:spPr>
           <a:xfrm>
-            <a:off x="8046719" y="1737360"/>
+            <a:off x="8046719" y="1828800"/>
             <a:ext cx="3474720" cy="3474720"/>
           </a:xfrm>
           <a:prstGeom prst="roundRect">
             <a:avLst/>
           </a:prstGeom>
           <a:solidFill>
-            <a:srgbClr val="F4F6FB"/>
+            <a:srgbClr val="F4F4F6"/>
           </a:solidFill>
           <a:ln>
             <a:noFill/>
@@ -7359,20 +7108,20 @@
       </p:sp>
       <p:sp>
         <p:nvSpPr>
-          <p:cNvPr id="11" name="Oval 10"/>
+          <p:cNvPr id="12" name="Oval 11"/>
           <p:cNvSpPr/>
           <p:nvPr/>
         </p:nvSpPr>
         <p:spPr>
           <a:xfrm>
-            <a:off x="8321040" y="2011680"/>
+            <a:off x="8321040" y="2103120"/>
             <a:ext cx="502920" cy="502920"/>
           </a:xfrm>
           <a:prstGeom prst="ellipse">
             <a:avLst/>
           </a:prstGeom>
           <a:solidFill>
-            <a:srgbClr val="00A896"/>
+            <a:srgbClr val="C9A227"/>
           </a:solidFill>
           <a:ln>
             <a:noFill/>
@@ -7412,13 +7161,13 @@
       </p:sp>
       <p:sp>
         <p:nvSpPr>
-          <p:cNvPr id="12" name="TextBox 11"/>
+          <p:cNvPr id="13" name="TextBox 12"/>
           <p:cNvSpPr txBox="1"/>
           <p:nvPr/>
         </p:nvSpPr>
         <p:spPr>
           <a:xfrm>
-            <a:off x="8321040" y="2743200"/>
+            <a:off x="8321040" y="2834640"/>
             <a:ext cx="2926080" cy="2286000"/>
           </a:xfrm>
           <a:prstGeom prst="rect">
@@ -7440,7 +7189,7 @@
             <a:r>
               <a:rPr sz="2200" b="1">
                 <a:solidFill>
-                  <a:srgbClr val="1E2761"/>
+                  <a:srgbClr val="1A1A1A"/>
                 </a:solidFill>
                 <a:latin typeface="Calibri"/>
               </a:rPr>
@@ -7456,7 +7205,7 @@
             <a:r>
               <a:rPr sz="1500" b="0">
                 <a:solidFill>
-                  <a:srgbClr val="2B2B2B"/>
+                  <a:srgbClr val="1A1A1A"/>
                 </a:solidFill>
                 <a:latin typeface="Calibri"/>
               </a:rPr>
@@ -7553,7 +7302,7 @@
             <a:r>
               <a:rPr sz="3400" b="1">
                 <a:solidFill>
-                  <a:srgbClr val="1E2761"/>
+                  <a:srgbClr val="1A1A1A"/>
                 </a:solidFill>
                 <a:latin typeface="Calibri"/>
               </a:rPr>
@@ -7564,55 +7313,20 @@
       </p:sp>
       <p:sp>
         <p:nvSpPr>
-          <p:cNvPr id="4" name="TextBox 3"/>
-          <p:cNvSpPr txBox="1"/>
-          <p:nvPr/>
-        </p:nvSpPr>
-        <p:spPr>
-          <a:xfrm>
-            <a:off x="640080" y="1417320"/>
-            <a:ext cx="6400800" cy="1097280"/>
+          <p:cNvPr id="4" name="Rectangle 3"/>
+          <p:cNvSpPr/>
+          <p:nvPr/>
+        </p:nvSpPr>
+        <p:spPr>
+          <a:xfrm>
+            <a:off x="658368" y="1252728"/>
+            <a:ext cx="1280160" cy="54864"/>
           </a:xfrm>
           <a:prstGeom prst="rect">
             <a:avLst/>
           </a:prstGeom>
-          <a:noFill/>
-        </p:spPr>
-        <p:txBody>
-          <a:bodyPr wrap="square" anchor="t" lIns="0" rIns="0" tIns="0" bIns="0">
-            <a:spAutoFit/>
-          </a:bodyPr>
-          <a:lstStyle/>
-          <a:p>
-            <a:pPr algn="l"/>
-            <a:r>
-              <a:rPr sz="1700" b="0">
-                <a:solidFill>
-                  <a:srgbClr val="2B2B2B"/>
-                </a:solidFill>
-                <a:latin typeface="Calibri"/>
-              </a:rPr>
-              <a:t>Um gate automatico valida as camadas. Se algo critico falha, a pipeline para antes de um numero errado chegar a um relatorio.</a:t>
-            </a:r>
-          </a:p>
-        </p:txBody>
-      </p:sp>
-      <p:sp>
-        <p:nvSpPr>
-          <p:cNvPr id="5" name="Oval 4"/>
-          <p:cNvSpPr/>
-          <p:nvPr/>
-        </p:nvSpPr>
-        <p:spPr>
-          <a:xfrm>
-            <a:off x="640080" y="2697480"/>
-            <a:ext cx="502920" cy="502920"/>
-          </a:xfrm>
-          <a:prstGeom prst="ellipse">
-            <a:avLst/>
-          </a:prstGeom>
           <a:solidFill>
-            <a:srgbClr val="00A896"/>
+            <a:srgbClr val="ED145B"/>
           </a:solidFill>
           <a:ln>
             <a:noFill/>
@@ -7634,32 +7348,23 @@
           </a:fontRef>
         </p:style>
         <p:txBody>
-          <a:bodyPr rtlCol="0" anchor="ctr" wrap="none"/>
+          <a:bodyPr rtlCol="0" anchor="ctr"/>
           <a:lstStyle/>
           <a:p>
             <a:pPr algn="ctr"/>
-            <a:r>
-              <a:rPr sz="1200" b="1">
-                <a:solidFill>
-                  <a:srgbClr val="FFFFFF"/>
-                </a:solidFill>
-                <a:latin typeface="Calibri"/>
-              </a:rPr>
-              <a:t>ok</a:t>
-            </a:r>
-          </a:p>
-        </p:txBody>
-      </p:sp>
-      <p:sp>
-        <p:nvSpPr>
-          <p:cNvPr id="6" name="TextBox 5"/>
+          </a:p>
+        </p:txBody>
+      </p:sp>
+      <p:sp>
+        <p:nvSpPr>
+          <p:cNvPr id="5" name="TextBox 4"/>
           <p:cNvSpPr txBox="1"/>
           <p:nvPr/>
         </p:nvSpPr>
         <p:spPr>
           <a:xfrm>
-            <a:off x="1371600" y="2743200"/>
-            <a:ext cx="5486400" cy="548640"/>
+            <a:off x="640080" y="1554480"/>
+            <a:ext cx="6400800" cy="1097280"/>
           </a:xfrm>
           <a:prstGeom prst="rect">
             <a:avLst/>
@@ -7674,33 +7379,33 @@
           <a:p>
             <a:pPr algn="l"/>
             <a:r>
-              <a:rPr sz="1700" b="1">
-                <a:solidFill>
-                  <a:srgbClr val="1E2761"/>
-                </a:solidFill>
-                <a:latin typeface="Calibri"/>
-              </a:rPr>
-              <a:t>Duplicidade</a:t>
-            </a:r>
-          </a:p>
-        </p:txBody>
-      </p:sp>
-      <p:sp>
-        <p:nvSpPr>
-          <p:cNvPr id="7" name="Oval 6"/>
+              <a:rPr sz="1700" b="0">
+                <a:solidFill>
+                  <a:srgbClr val="1A1A1A"/>
+                </a:solidFill>
+                <a:latin typeface="Calibri"/>
+              </a:rPr>
+              <a:t>Um gate automatico valida as camadas. Se algo critico falha, a pipeline para antes de um numero errado chegar a um relatorio.</a:t>
+            </a:r>
+          </a:p>
+        </p:txBody>
+      </p:sp>
+      <p:sp>
+        <p:nvSpPr>
+          <p:cNvPr id="6" name="Oval 5"/>
           <p:cNvSpPr/>
           <p:nvPr/>
         </p:nvSpPr>
         <p:spPr>
           <a:xfrm>
-            <a:off x="640080" y="3566160"/>
+            <a:off x="640080" y="2788920"/>
             <a:ext cx="502920" cy="502920"/>
           </a:xfrm>
           <a:prstGeom prst="ellipse">
             <a:avLst/>
           </a:prstGeom>
           <a:solidFill>
-            <a:srgbClr val="00A896"/>
+            <a:srgbClr val="ED145B"/>
           </a:solidFill>
           <a:ln>
             <a:noFill/>
@@ -7740,13 +7445,13 @@
       </p:sp>
       <p:sp>
         <p:nvSpPr>
-          <p:cNvPr id="8" name="TextBox 7"/>
+          <p:cNvPr id="7" name="TextBox 6"/>
           <p:cNvSpPr txBox="1"/>
           <p:nvPr/>
         </p:nvSpPr>
         <p:spPr>
           <a:xfrm>
-            <a:off x="1371600" y="3611880"/>
+            <a:off x="1371600" y="2834639"/>
             <a:ext cx="5486400" cy="548640"/>
           </a:xfrm>
           <a:prstGeom prst="rect">
@@ -7764,31 +7469,31 @@
             <a:r>
               <a:rPr sz="1700" b="1">
                 <a:solidFill>
-                  <a:srgbClr val="1E2761"/>
-                </a:solidFill>
-                <a:latin typeface="Calibri"/>
-              </a:rPr>
-              <a:t>Valores ausentes</a:t>
-            </a:r>
-          </a:p>
-        </p:txBody>
-      </p:sp>
-      <p:sp>
-        <p:nvSpPr>
-          <p:cNvPr id="9" name="Oval 8"/>
+                  <a:srgbClr val="1A1A1A"/>
+                </a:solidFill>
+                <a:latin typeface="Calibri"/>
+              </a:rPr>
+              <a:t>Duplicidade</a:t>
+            </a:r>
+          </a:p>
+        </p:txBody>
+      </p:sp>
+      <p:sp>
+        <p:nvSpPr>
+          <p:cNvPr id="8" name="Oval 7"/>
           <p:cNvSpPr/>
           <p:nvPr/>
         </p:nvSpPr>
         <p:spPr>
           <a:xfrm>
-            <a:off x="640080" y="4434840"/>
+            <a:off x="640080" y="3657600"/>
             <a:ext cx="502920" cy="502920"/>
           </a:xfrm>
           <a:prstGeom prst="ellipse">
             <a:avLst/>
           </a:prstGeom>
           <a:solidFill>
-            <a:srgbClr val="00A896"/>
+            <a:srgbClr val="ED145B"/>
           </a:solidFill>
           <a:ln>
             <a:noFill/>
@@ -7828,13 +7533,13 @@
       </p:sp>
       <p:sp>
         <p:nvSpPr>
-          <p:cNvPr id="10" name="TextBox 9"/>
+          <p:cNvPr id="9" name="TextBox 8"/>
           <p:cNvSpPr txBox="1"/>
           <p:nvPr/>
         </p:nvSpPr>
         <p:spPr>
           <a:xfrm>
-            <a:off x="1371600" y="4480559"/>
+            <a:off x="1371600" y="3703320"/>
             <a:ext cx="5486400" cy="548640"/>
           </a:xfrm>
           <a:prstGeom prst="rect">
@@ -7852,31 +7557,31 @@
             <a:r>
               <a:rPr sz="1700" b="1">
                 <a:solidFill>
-                  <a:srgbClr val="1E2761"/>
-                </a:solidFill>
-                <a:latin typeface="Calibri"/>
-              </a:rPr>
-              <a:t>Chaves de relacionamento</a:t>
-            </a:r>
-          </a:p>
-        </p:txBody>
-      </p:sp>
-      <p:sp>
-        <p:nvSpPr>
-          <p:cNvPr id="11" name="Oval 10"/>
+                  <a:srgbClr val="1A1A1A"/>
+                </a:solidFill>
+                <a:latin typeface="Calibri"/>
+              </a:rPr>
+              <a:t>Valores ausentes</a:t>
+            </a:r>
+          </a:p>
+        </p:txBody>
+      </p:sp>
+      <p:sp>
+        <p:nvSpPr>
+          <p:cNvPr id="10" name="Oval 9"/>
           <p:cNvSpPr/>
           <p:nvPr/>
         </p:nvSpPr>
         <p:spPr>
           <a:xfrm>
-            <a:off x="640080" y="5303520"/>
+            <a:off x="640080" y="4526279"/>
             <a:ext cx="502920" cy="502920"/>
           </a:xfrm>
           <a:prstGeom prst="ellipse">
             <a:avLst/>
           </a:prstGeom>
           <a:solidFill>
-            <a:srgbClr val="00A896"/>
+            <a:srgbClr val="ED145B"/>
           </a:solidFill>
           <a:ln>
             <a:noFill/>
@@ -7916,13 +7621,13 @@
       </p:sp>
       <p:sp>
         <p:nvSpPr>
-          <p:cNvPr id="12" name="TextBox 11"/>
+          <p:cNvPr id="11" name="TextBox 10"/>
           <p:cNvSpPr txBox="1"/>
           <p:nvPr/>
         </p:nvSpPr>
         <p:spPr>
           <a:xfrm>
-            <a:off x="1371600" y="5349240"/>
+            <a:off x="1371600" y="4571999"/>
             <a:ext cx="5486400" cy="548640"/>
           </a:xfrm>
           <a:prstGeom prst="rect">
@@ -7940,31 +7645,31 @@
             <a:r>
               <a:rPr sz="1700" b="1">
                 <a:solidFill>
-                  <a:srgbClr val="1E2761"/>
-                </a:solidFill>
-                <a:latin typeface="Calibri"/>
-              </a:rPr>
-              <a:t>Consistencia entre tabelas</a:t>
-            </a:r>
-          </a:p>
-        </p:txBody>
-      </p:sp>
-      <p:sp>
-        <p:nvSpPr>
-          <p:cNvPr id="13" name="Rounded Rectangle 12"/>
+                  <a:srgbClr val="1A1A1A"/>
+                </a:solidFill>
+                <a:latin typeface="Calibri"/>
+              </a:rPr>
+              <a:t>Chaves de relacionamento</a:t>
+            </a:r>
+          </a:p>
+        </p:txBody>
+      </p:sp>
+      <p:sp>
+        <p:nvSpPr>
+          <p:cNvPr id="12" name="Oval 11"/>
           <p:cNvSpPr/>
           <p:nvPr/>
         </p:nvSpPr>
         <p:spPr>
           <a:xfrm>
-            <a:off x="7498079" y="2377440"/>
-            <a:ext cx="4023360" cy="2103120"/>
-          </a:xfrm>
-          <a:prstGeom prst="roundRect">
+            <a:off x="640080" y="5394959"/>
+            <a:ext cx="502920" cy="502920"/>
+          </a:xfrm>
+          <a:prstGeom prst="ellipse">
             <a:avLst/>
           </a:prstGeom>
           <a:solidFill>
-            <a:srgbClr val="F4F6FB"/>
+            <a:srgbClr val="ED145B"/>
           </a:solidFill>
           <a:ln>
             <a:noFill/>
@@ -7986,6 +7691,94 @@
           </a:fontRef>
         </p:style>
         <p:txBody>
+          <a:bodyPr rtlCol="0" anchor="ctr" wrap="none"/>
+          <a:lstStyle/>
+          <a:p>
+            <a:pPr algn="ctr"/>
+            <a:r>
+              <a:rPr sz="1200" b="1">
+                <a:solidFill>
+                  <a:srgbClr val="FFFFFF"/>
+                </a:solidFill>
+                <a:latin typeface="Calibri"/>
+              </a:rPr>
+              <a:t>ok</a:t>
+            </a:r>
+          </a:p>
+        </p:txBody>
+      </p:sp>
+      <p:sp>
+        <p:nvSpPr>
+          <p:cNvPr id="13" name="TextBox 12"/>
+          <p:cNvSpPr txBox="1"/>
+          <p:nvPr/>
+        </p:nvSpPr>
+        <p:spPr>
+          <a:xfrm>
+            <a:off x="1371600" y="5440679"/>
+            <a:ext cx="5486400" cy="548640"/>
+          </a:xfrm>
+          <a:prstGeom prst="rect">
+            <a:avLst/>
+          </a:prstGeom>
+          <a:noFill/>
+        </p:spPr>
+        <p:txBody>
+          <a:bodyPr wrap="square" anchor="t" lIns="0" rIns="0" tIns="0" bIns="0">
+            <a:spAutoFit/>
+          </a:bodyPr>
+          <a:lstStyle/>
+          <a:p>
+            <a:pPr algn="l"/>
+            <a:r>
+              <a:rPr sz="1700" b="1">
+                <a:solidFill>
+                  <a:srgbClr val="1A1A1A"/>
+                </a:solidFill>
+                <a:latin typeface="Calibri"/>
+              </a:rPr>
+              <a:t>Consistencia entre tabelas</a:t>
+            </a:r>
+          </a:p>
+        </p:txBody>
+      </p:sp>
+      <p:sp>
+        <p:nvSpPr>
+          <p:cNvPr id="14" name="Rounded Rectangle 13"/>
+          <p:cNvSpPr/>
+          <p:nvPr/>
+        </p:nvSpPr>
+        <p:spPr>
+          <a:xfrm>
+            <a:off x="7498079" y="2468880"/>
+            <a:ext cx="4023360" cy="2103120"/>
+          </a:xfrm>
+          <a:prstGeom prst="roundRect">
+            <a:avLst/>
+          </a:prstGeom>
+          <a:solidFill>
+            <a:srgbClr val="F4F4F6"/>
+          </a:solidFill>
+          <a:ln>
+            <a:noFill/>
+          </a:ln>
+          <a:effectLst/>
+        </p:spPr>
+        <p:style>
+          <a:lnRef idx="1">
+            <a:schemeClr val="accent1"/>
+          </a:lnRef>
+          <a:fillRef idx="3">
+            <a:schemeClr val="accent1"/>
+          </a:fillRef>
+          <a:effectRef idx="2">
+            <a:schemeClr val="accent1"/>
+          </a:effectRef>
+          <a:fontRef idx="minor">
+            <a:schemeClr val="lt1"/>
+          </a:fontRef>
+        </p:style>
+        <p:txBody>
           <a:bodyPr rtlCol="0" anchor="ctr"/>
           <a:lstStyle/>
           <a:p>
@@ -7995,13 +7788,13 @@
       </p:sp>
       <p:sp>
         <p:nvSpPr>
-          <p:cNvPr id="14" name="TextBox 13"/>
+          <p:cNvPr id="15" name="TextBox 14"/>
           <p:cNvSpPr txBox="1"/>
           <p:nvPr/>
         </p:nvSpPr>
         <p:spPr>
           <a:xfrm>
-            <a:off x="7680960" y="2651760"/>
+            <a:off x="7680960" y="2743200"/>
             <a:ext cx="3657600" cy="1645920"/>
           </a:xfrm>
           <a:prstGeom prst="rect">
@@ -8023,7 +7816,7 @@
             <a:r>
               <a:rPr sz="6000" b="1">
                 <a:solidFill>
-                  <a:srgbClr val="00A896"/>
+                  <a:srgbClr val="ED145B"/>
                 </a:solidFill>
                 <a:latin typeface="Calibri"/>
               </a:rPr>
@@ -8039,7 +7832,7 @@
             <a:r>
               <a:rPr sz="1300" b="0">
                 <a:solidFill>
-                  <a:srgbClr val="5A5A5A"/>
+                  <a:srgbClr val="555555"/>
                 </a:solidFill>
                 <a:latin typeface="Calibri"/>
               </a:rPr>
@@ -8136,7 +7929,7 @@
             <a:r>
               <a:rPr sz="3400" b="1">
                 <a:solidFill>
-                  <a:srgbClr val="1E2761"/>
+                  <a:srgbClr val="1A1A1A"/>
                 </a:solidFill>
                 <a:latin typeface="Calibri"/>
               </a:rPr>
@@ -8147,20 +7940,20 @@
       </p:sp>
       <p:sp>
         <p:nvSpPr>
-          <p:cNvPr id="4" name="Rounded Rectangle 3"/>
+          <p:cNvPr id="4" name="Rectangle 3"/>
           <p:cNvSpPr/>
           <p:nvPr/>
         </p:nvSpPr>
         <p:spPr>
           <a:xfrm>
-            <a:off x="640080" y="1554480"/>
-            <a:ext cx="5349240" cy="4206240"/>
-          </a:xfrm>
-          <a:prstGeom prst="roundRect">
+            <a:off x="658368" y="1252728"/>
+            <a:ext cx="1280160" cy="54864"/>
+          </a:xfrm>
+          <a:prstGeom prst="rect">
             <a:avLst/>
           </a:prstGeom>
           <a:solidFill>
-            <a:srgbClr val="F4F6FB"/>
+            <a:srgbClr val="ED145B"/>
           </a:solidFill>
           <a:ln>
             <a:noFill/>
@@ -8191,13 +7984,57 @@
       </p:sp>
       <p:sp>
         <p:nvSpPr>
-          <p:cNvPr id="5" name="TextBox 4"/>
+          <p:cNvPr id="5" name="Rounded Rectangle 4"/>
+          <p:cNvSpPr/>
+          <p:nvPr/>
+        </p:nvSpPr>
+        <p:spPr>
+          <a:xfrm>
+            <a:off x="640080" y="1645920"/>
+            <a:ext cx="5349240" cy="4206240"/>
+          </a:xfrm>
+          <a:prstGeom prst="roundRect">
+            <a:avLst/>
+          </a:prstGeom>
+          <a:solidFill>
+            <a:srgbClr val="F4F4F6"/>
+          </a:solidFill>
+          <a:ln>
+            <a:noFill/>
+          </a:ln>
+          <a:effectLst/>
+        </p:spPr>
+        <p:style>
+          <a:lnRef idx="1">
+            <a:schemeClr val="accent1"/>
+          </a:lnRef>
+          <a:fillRef idx="3">
+            <a:schemeClr val="accent1"/>
+          </a:fillRef>
+          <a:effectRef idx="2">
+            <a:schemeClr val="accent1"/>
+          </a:effectRef>
+          <a:fontRef idx="minor">
+            <a:schemeClr val="lt1"/>
+          </a:fontRef>
+        </p:style>
+        <p:txBody>
+          <a:bodyPr rtlCol="0" anchor="ctr"/>
+          <a:lstStyle/>
+          <a:p>
+            <a:pPr algn="ctr"/>
+          </a:p>
+        </p:txBody>
+      </p:sp>
+      <p:sp>
+        <p:nvSpPr>
+          <p:cNvPr id="6" name="TextBox 5"/>
           <p:cNvSpPr txBox="1"/>
           <p:nvPr/>
         </p:nvSpPr>
         <p:spPr>
           <a:xfrm>
-            <a:off x="914400" y="1828800"/>
+            <a:off x="914400" y="1920240"/>
             <a:ext cx="4846320" cy="3657600"/>
           </a:xfrm>
           <a:prstGeom prst="rect">
@@ -8219,7 +8056,7 @@
             <a:r>
               <a:rPr sz="2000" b="1">
                 <a:solidFill>
-                  <a:srgbClr val="1E2761"/>
+                  <a:srgbClr val="1A1A1A"/>
                 </a:solidFill>
                 <a:latin typeface="Calibri"/>
               </a:rPr>
@@ -8235,7 +8072,7 @@
             <a:r>
               <a:rPr sz="1500" b="0">
                 <a:solidFill>
-                  <a:srgbClr val="2B2B2B"/>
+                  <a:srgbClr val="1A1A1A"/>
                 </a:solidFill>
                 <a:latin typeface="Calibri"/>
               </a:rPr>
@@ -8251,7 +8088,7 @@
             <a:r>
               <a:rPr sz="1500" b="0">
                 <a:solidFill>
-                  <a:srgbClr val="2B2B2B"/>
+                  <a:srgbClr val="1A1A1A"/>
                 </a:solidFill>
                 <a:latin typeface="Calibri"/>
               </a:rPr>
@@ -8262,20 +8099,20 @@
       </p:sp>
       <p:sp>
         <p:nvSpPr>
-          <p:cNvPr id="6" name="Rounded Rectangle 5"/>
+          <p:cNvPr id="7" name="Rounded Rectangle 6"/>
           <p:cNvSpPr/>
           <p:nvPr/>
         </p:nvSpPr>
         <p:spPr>
           <a:xfrm>
-            <a:off x="6217920" y="1554480"/>
+            <a:off x="6217920" y="1645920"/>
             <a:ext cx="5349240" cy="4206240"/>
           </a:xfrm>
           <a:prstGeom prst="roundRect">
             <a:avLst/>
           </a:prstGeom>
           <a:solidFill>
-            <a:srgbClr val="F4F6FB"/>
+            <a:srgbClr val="F4F4F6"/>
           </a:solidFill>
           <a:ln>
             <a:noFill/>
@@ -8306,13 +8143,13 @@
       </p:sp>
       <p:sp>
         <p:nvSpPr>
-          <p:cNvPr id="7" name="TextBox 6"/>
+          <p:cNvPr id="8" name="TextBox 7"/>
           <p:cNvSpPr txBox="1"/>
           <p:nvPr/>
         </p:nvSpPr>
         <p:spPr>
           <a:xfrm>
-            <a:off x="6492240" y="1828800"/>
+            <a:off x="6492240" y="1920240"/>
             <a:ext cx="4846320" cy="3657600"/>
           </a:xfrm>
           <a:prstGeom prst="rect">
@@ -8334,7 +8171,7 @@
             <a:r>
               <a:rPr sz="2000" b="1">
                 <a:solidFill>
-                  <a:srgbClr val="00A896"/>
+                  <a:srgbClr val="ED145B"/>
                 </a:solidFill>
                 <a:latin typeface="Calibri"/>
               </a:rPr>
@@ -8350,7 +8187,7 @@
             <a:r>
               <a:rPr sz="1500" b="0">
                 <a:solidFill>
-                  <a:srgbClr val="2B2B2B"/>
+                  <a:srgbClr val="1A1A1A"/>
                 </a:solidFill>
                 <a:latin typeface="Calibri"/>
               </a:rPr>
@@ -8366,7 +8203,7 @@
             <a:r>
               <a:rPr sz="1500" b="0">
                 <a:solidFill>
-                  <a:srgbClr val="2B2B2B"/>
+                  <a:srgbClr val="1A1A1A"/>
                 </a:solidFill>
                 <a:latin typeface="Calibri"/>
               </a:rPr>
@@ -8382,7 +8219,7 @@
             <a:r>
               <a:rPr sz="1500" b="0">
                 <a:solidFill>
-                  <a:srgbClr val="2B2B2B"/>
+                  <a:srgbClr val="1A1A1A"/>
                 </a:solidFill>
                 <a:latin typeface="Calibri"/>
               </a:rPr>

</xml_diff>

<commit_message>
slide de evidencia: escala real, gate aprovado, custo e desigualdade regional
</commit_message>
<xml_diff>
--- a/reports/slides/pipeline_alfabetizacao_fase2.pptx
+++ b/reports/slides/pipeline_alfabetizacao_fase2.pptx
@@ -16,6 +16,7 @@
     <p:sldId id="264" r:id="rId15"/>
     <p:sldId id="265" r:id="rId16"/>
     <p:sldId id="266" r:id="rId17"/>
+    <p:sldId id="267" r:id="rId18"/>
   </p:sldIdLst>
   <p:sldSz cx="12191695" cy="6858000" type="screen4x3"/>
   <p:notesSz cx="6858000" cy="9144000"/>
@@ -3556,7 +3557,7 @@
                 </a:solidFill>
                 <a:latin typeface="Calibri"/>
               </a:rPr>
-              <a:t>VALOR</a:t>
+              <a:t>EVIDÊNCIA</a:t>
             </a:r>
           </a:p>
         </p:txBody>
@@ -3591,7 +3592,7 @@
                 </a:solidFill>
                 <a:latin typeface="Calibri"/>
               </a:rPr>
-              <a:t>Valor e potencial de IA</a:t>
+              <a:t>Rodou em escala real, com custo controlado</a:t>
             </a:r>
           </a:p>
         </p:txBody>
@@ -3642,58 +3643,27 @@
       </p:sp>
       <p:sp>
         <p:nvSpPr>
-          <p:cNvPr id="6" name="TextBox 5"/>
-          <p:cNvSpPr txBox="1"/>
-          <p:nvPr/>
-        </p:nvSpPr>
-        <p:spPr>
-          <a:xfrm>
-            <a:off x="640080" y="1645920"/>
-            <a:ext cx="10881360" cy="502920"/>
-          </a:xfrm>
-          <a:prstGeom prst="rect">
-            <a:avLst/>
-          </a:prstGeom>
-          <a:noFill/>
-        </p:spPr>
-        <p:txBody>
-          <a:bodyPr wrap="square" anchor="t" lIns="0" rIns="0" tIns="0" bIns="0">
-            <a:spAutoFit/>
-          </a:bodyPr>
-          <a:lstStyle/>
-          <a:p>
-            <a:pPr algn="l"/>
-            <a:r>
-              <a:rPr sz="1500" b="0">
-                <a:solidFill>
-                  <a:srgbClr val="555555"/>
-                </a:solidFill>
-                <a:latin typeface="Calibri"/>
-              </a:rPr>
-              <a:t>A Gold sai pronta para alimentar modelos e análises. Três frentes concretas:</a:t>
-            </a:r>
-          </a:p>
-        </p:txBody>
-      </p:sp>
-      <p:sp>
-        <p:nvSpPr>
-          <p:cNvPr id="7" name="Oval 6"/>
+          <p:cNvPr id="6" name="Rounded Rectangle 5"/>
           <p:cNvSpPr/>
           <p:nvPr/>
         </p:nvSpPr>
         <p:spPr>
           <a:xfrm>
-            <a:off x="640080" y="2286000"/>
-            <a:ext cx="566928" cy="566928"/>
-          </a:xfrm>
-          <a:prstGeom prst="ellipse">
-            <a:avLst/>
+            <a:off x="640080" y="1874519"/>
+            <a:ext cx="4892040" cy="1234440"/>
+          </a:xfrm>
+          <a:prstGeom prst="roundRect">
+            <a:avLst>
+              <a:gd name="adj" fmla="val 6000"/>
+            </a:avLst>
           </a:prstGeom>
           <a:solidFill>
-            <a:srgbClr val="ED145B"/>
+            <a:srgbClr val="F4F4F6"/>
           </a:solidFill>
-          <a:ln>
-            <a:noFill/>
+          <a:ln w="12700">
+            <a:solidFill>
+              <a:srgbClr val="E0E0E0"/>
+            </a:solidFill>
           </a:ln>
           <a:effectLst/>
         </p:spPr>
@@ -3716,14 +3686,40 @@
           <a:lstStyle/>
           <a:p>
             <a:pPr algn="ctr"/>
-            <a:r>
-              <a:rPr sz="1700" b="1">
-                <a:solidFill>
-                  <a:srgbClr val="FFFFFF"/>
-                </a:solidFill>
-                <a:latin typeface="Calibri"/>
-              </a:rPr>
-              <a:t>1</a:t>
+          </a:p>
+        </p:txBody>
+      </p:sp>
+      <p:sp>
+        <p:nvSpPr>
+          <p:cNvPr id="7" name="TextBox 6"/>
+          <p:cNvSpPr txBox="1"/>
+          <p:nvPr/>
+        </p:nvSpPr>
+        <p:spPr>
+          <a:xfrm>
+            <a:off x="868680" y="1874519"/>
+            <a:ext cx="1691640" cy="1234440"/>
+          </a:xfrm>
+          <a:prstGeom prst="rect">
+            <a:avLst/>
+          </a:prstGeom>
+          <a:noFill/>
+        </p:spPr>
+        <p:txBody>
+          <a:bodyPr wrap="square" anchor="ctr" lIns="0" rIns="0" tIns="0" bIns="0">
+            <a:spAutoFit/>
+          </a:bodyPr>
+          <a:lstStyle/>
+          <a:p>
+            <a:pPr algn="l"/>
+            <a:r>
+              <a:rPr sz="3300" b="1">
+                <a:solidFill>
+                  <a:srgbClr val="ED145B"/>
+                </a:solidFill>
+                <a:latin typeface="Calibri"/>
+              </a:rPr>
+              <a:t>5.571</a:t>
             </a:r>
           </a:p>
         </p:txBody>
@@ -3736,8 +3732,8 @@
         </p:nvSpPr>
         <p:spPr>
           <a:xfrm>
-            <a:off x="1417320" y="2240280"/>
-            <a:ext cx="10149840" cy="1188720"/>
+            <a:off x="2606040" y="1874519"/>
+            <a:ext cx="2743200" cy="1234440"/>
           </a:xfrm>
           <a:prstGeom prst="rect">
             <a:avLst/>
@@ -3745,88 +3741,47 @@
           <a:noFill/>
         </p:spPr>
         <p:txBody>
-          <a:bodyPr wrap="square" anchor="t" lIns="0" rIns="0" tIns="0" bIns="0">
+          <a:bodyPr wrap="square" anchor="ctr" lIns="0" rIns="0" tIns="0" bIns="0">
             <a:spAutoFit/>
           </a:bodyPr>
           <a:lstStyle/>
           <a:p>
-            <a:pPr algn="l">
-              <a:spcAft>
-                <a:spcPts val="300"/>
-              </a:spcAft>
-            </a:pPr>
-            <a:r>
-              <a:rPr sz="1800" b="1">
-                <a:solidFill>
-                  <a:srgbClr val="1A1A1A"/>
-                </a:solidFill>
-                <a:latin typeface="Calibri"/>
-              </a:rPr>
-              <a:t>Antecipar</a:t>
-            </a:r>
-          </a:p>
-          <a:p>
-            <a:pPr algn="l">
-              <a:spcAft>
-                <a:spcPts val="300"/>
-              </a:spcAft>
-            </a:pPr>
-            <a:r>
-              <a:rPr sz="1400" b="0">
-                <a:solidFill>
-                  <a:srgbClr val="1A1A1A"/>
-                </a:solidFill>
-                <a:latin typeface="Calibri"/>
-              </a:rPr>
-              <a:t>Prever quais municípios tendem a ficar abaixo da meta e agir antes do resultado consolidado.</a:t>
-            </a:r>
-          </a:p>
-          <a:p>
-            <a:pPr algn="l">
-              <a:spcAft>
-                <a:spcPts val="300"/>
-              </a:spcAft>
-            </a:pPr>
-            <a:r>
-              <a:rPr sz="1200" b="1">
-                <a:solidFill>
-                  <a:srgbClr val="ED145B"/>
-                </a:solidFill>
-                <a:latin typeface="Calibri"/>
-              </a:rPr>
-              <a:t>Na Gold  </a:t>
-            </a:r>
-            <a:r>
-              <a:rPr sz="1200" b="0">
+            <a:pPr algn="l"/>
+            <a:r>
+              <a:rPr sz="1300" b="0">
                 <a:solidFill>
                   <a:srgbClr val="555555"/>
                 </a:solidFill>
                 <a:latin typeface="Calibri"/>
               </a:rPr>
-              <a:t>Insumo: fato por município (indicador_pct, gap_meta_pp, atingiu_meta) mais enriquecimento socioeconômico como base de treino.</a:t>
-            </a:r>
-          </a:p>
-        </p:txBody>
-      </p:sp>
-      <p:sp>
-        <p:nvSpPr>
-          <p:cNvPr id="9" name="Oval 8"/>
+              <a:t>municípios e 27 UFs, território real da API pública do IBGE</a:t>
+            </a:r>
+          </a:p>
+        </p:txBody>
+      </p:sp>
+      <p:sp>
+        <p:nvSpPr>
+          <p:cNvPr id="9" name="Rounded Rectangle 8"/>
           <p:cNvSpPr/>
           <p:nvPr/>
         </p:nvSpPr>
         <p:spPr>
           <a:xfrm>
-            <a:off x="640080" y="3584448"/>
-            <a:ext cx="566928" cy="566928"/>
-          </a:xfrm>
-          <a:prstGeom prst="ellipse">
-            <a:avLst/>
+            <a:off x="640080" y="3246120"/>
+            <a:ext cx="4892040" cy="1234440"/>
+          </a:xfrm>
+          <a:prstGeom prst="roundRect">
+            <a:avLst>
+              <a:gd name="adj" fmla="val 6000"/>
+            </a:avLst>
           </a:prstGeom>
           <a:solidFill>
-            <a:srgbClr val="1A1A1A"/>
+            <a:srgbClr val="F4F4F6"/>
           </a:solidFill>
-          <a:ln>
-            <a:noFill/>
+          <a:ln w="12700">
+            <a:solidFill>
+              <a:srgbClr val="E0E0E0"/>
+            </a:solidFill>
           </a:ln>
           <a:effectLst/>
         </p:spPr>
@@ -3849,15 +3804,6 @@
           <a:lstStyle/>
           <a:p>
             <a:pPr algn="ctr"/>
-            <a:r>
-              <a:rPr sz="1700" b="1">
-                <a:solidFill>
-                  <a:srgbClr val="FFFFFF"/>
-                </a:solidFill>
-                <a:latin typeface="Calibri"/>
-              </a:rPr>
-              <a:t>2</a:t>
-            </a:r>
           </a:p>
         </p:txBody>
       </p:sp>
@@ -3869,8 +3815,8 @@
         </p:nvSpPr>
         <p:spPr>
           <a:xfrm>
-            <a:off x="1417320" y="3538728"/>
-            <a:ext cx="10149840" cy="1188720"/>
+            <a:off x="868680" y="3246120"/>
+            <a:ext cx="1691640" cy="1234440"/>
           </a:xfrm>
           <a:prstGeom prst="rect">
             <a:avLst/>
@@ -3878,88 +3824,82 @@
           <a:noFill/>
         </p:spPr>
         <p:txBody>
-          <a:bodyPr wrap="square" anchor="t" lIns="0" rIns="0" tIns="0" bIns="0">
+          <a:bodyPr wrap="square" anchor="ctr" lIns="0" rIns="0" tIns="0" bIns="0">
             <a:spAutoFit/>
           </a:bodyPr>
           <a:lstStyle/>
           <a:p>
-            <a:pPr algn="l">
-              <a:spcAft>
-                <a:spcPts val="300"/>
-              </a:spcAft>
-            </a:pPr>
-            <a:r>
-              <a:rPr sz="1800" b="1">
-                <a:solidFill>
-                  <a:srgbClr val="1A1A1A"/>
-                </a:solidFill>
-                <a:latin typeface="Calibri"/>
-              </a:rPr>
-              <a:t>Enxergar desigualdade</a:t>
-            </a:r>
-          </a:p>
-          <a:p>
-            <a:pPr algn="l">
-              <a:spcAft>
-                <a:spcPts val="300"/>
-              </a:spcAft>
-            </a:pPr>
-            <a:r>
-              <a:rPr sz="1400" b="0">
-                <a:solidFill>
-                  <a:srgbClr val="1A1A1A"/>
-                </a:solidFill>
-                <a:latin typeface="Calibri"/>
-              </a:rPr>
-              <a:t>Comparar regiões e redes e identificar grupos em maior vulnerabilidade educacional.</a:t>
-            </a:r>
-          </a:p>
-          <a:p>
-            <a:pPr algn="l">
-              <a:spcAft>
-                <a:spcPts val="300"/>
-              </a:spcAft>
-            </a:pPr>
-            <a:r>
-              <a:rPr sz="1200" b="1">
+            <a:pPr algn="l"/>
+            <a:r>
+              <a:rPr sz="3300" b="1">
                 <a:solidFill>
                   <a:srgbClr val="ED145B"/>
                 </a:solidFill>
                 <a:latin typeface="Calibri"/>
               </a:rPr>
-              <a:t>Na Gold  </a:t>
-            </a:r>
-            <a:r>
-              <a:rPr sz="1200" b="0">
+              <a:t>11/11</a:t>
+            </a:r>
+          </a:p>
+        </p:txBody>
+      </p:sp>
+      <p:sp>
+        <p:nvSpPr>
+          <p:cNvPr id="11" name="TextBox 10"/>
+          <p:cNvSpPr txBox="1"/>
+          <p:nvPr/>
+        </p:nvSpPr>
+        <p:spPr>
+          <a:xfrm>
+            <a:off x="2606040" y="3246120"/>
+            <a:ext cx="2743200" cy="1234440"/>
+          </a:xfrm>
+          <a:prstGeom prst="rect">
+            <a:avLst/>
+          </a:prstGeom>
+          <a:noFill/>
+        </p:spPr>
+        <p:txBody>
+          <a:bodyPr wrap="square" anchor="ctr" lIns="0" rIns="0" tIns="0" bIns="0">
+            <a:spAutoFit/>
+          </a:bodyPr>
+          <a:lstStyle/>
+          <a:p>
+            <a:pPr algn="l"/>
+            <a:r>
+              <a:rPr sz="1300" b="0">
                 <a:solidFill>
                   <a:srgbClr val="555555"/>
                 </a:solidFill>
                 <a:latin typeface="Calibri"/>
               </a:rPr>
-              <a:t>Insumo: clusterização sobre indicador, região, rede e distância da meta para achar padrões.</a:t>
-            </a:r>
-          </a:p>
-        </p:txBody>
-      </p:sp>
-      <p:sp>
-        <p:nvSpPr>
-          <p:cNvPr id="11" name="Oval 10"/>
+              <a:t>checagens do gate de qualidade aprovadas na execução</a:t>
+            </a:r>
+          </a:p>
+        </p:txBody>
+      </p:sp>
+      <p:sp>
+        <p:nvSpPr>
+          <p:cNvPr id="12" name="Rounded Rectangle 11"/>
           <p:cNvSpPr/>
           <p:nvPr/>
         </p:nvSpPr>
         <p:spPr>
           <a:xfrm>
-            <a:off x="640080" y="4882896"/>
-            <a:ext cx="566928" cy="566928"/>
-          </a:xfrm>
-          <a:prstGeom prst="ellipse">
-            <a:avLst/>
+            <a:off x="640080" y="4617720"/>
+            <a:ext cx="4892040" cy="1234440"/>
+          </a:xfrm>
+          <a:prstGeom prst="roundRect">
+            <a:avLst>
+              <a:gd name="adj" fmla="val 6000"/>
+            </a:avLst>
           </a:prstGeom>
           <a:solidFill>
-            <a:srgbClr val="ED145B"/>
+            <a:srgbClr val="F4F4F6"/>
           </a:solidFill>
-          <a:ln>
-            <a:noFill/>
+          <a:ln w="12700">
+            <a:solidFill>
+              <a:srgbClr val="E0E0E0"/>
+            </a:solidFill>
           </a:ln>
           <a:effectLst/>
         </p:spPr>
@@ -3982,28 +3922,89 @@
           <a:lstStyle/>
           <a:p>
             <a:pPr algn="ctr"/>
-            <a:r>
-              <a:rPr sz="1700" b="1">
-                <a:solidFill>
-                  <a:srgbClr val="FFFFFF"/>
-                </a:solidFill>
-                <a:latin typeface="Calibri"/>
-              </a:rPr>
-              <a:t>3</a:t>
-            </a:r>
-          </a:p>
-        </p:txBody>
-      </p:sp>
-      <p:sp>
-        <p:nvSpPr>
-          <p:cNvPr id="12" name="TextBox 11"/>
+          </a:p>
+        </p:txBody>
+      </p:sp>
+      <p:sp>
+        <p:nvSpPr>
+          <p:cNvPr id="13" name="TextBox 12"/>
           <p:cNvSpPr txBox="1"/>
           <p:nvPr/>
         </p:nvSpPr>
         <p:spPr>
           <a:xfrm>
-            <a:off x="1417320" y="4837176"/>
-            <a:ext cx="10149840" cy="1188720"/>
+            <a:off x="868680" y="4617720"/>
+            <a:ext cx="1691640" cy="1234440"/>
+          </a:xfrm>
+          <a:prstGeom prst="rect">
+            <a:avLst/>
+          </a:prstGeom>
+          <a:noFill/>
+        </p:spPr>
+        <p:txBody>
+          <a:bodyPr wrap="square" anchor="ctr" lIns="0" rIns="0" tIns="0" bIns="0">
+            <a:spAutoFit/>
+          </a:bodyPr>
+          <a:lstStyle/>
+          <a:p>
+            <a:pPr algn="l"/>
+            <a:r>
+              <a:rPr sz="3300" b="1">
+                <a:solidFill>
+                  <a:srgbClr val="ED145B"/>
+                </a:solidFill>
+                <a:latin typeface="Calibri"/>
+              </a:rPr>
+              <a:t>R$ 0</a:t>
+            </a:r>
+          </a:p>
+        </p:txBody>
+      </p:sp>
+      <p:sp>
+        <p:nvSpPr>
+          <p:cNvPr id="14" name="TextBox 13"/>
+          <p:cNvSpPr txBox="1"/>
+          <p:nvPr/>
+        </p:nvSpPr>
+        <p:spPr>
+          <a:xfrm>
+            <a:off x="2606040" y="4617720"/>
+            <a:ext cx="2743200" cy="1234440"/>
+          </a:xfrm>
+          <a:prstGeom prst="rect">
+            <a:avLst/>
+          </a:prstGeom>
+          <a:noFill/>
+        </p:spPr>
+        <p:txBody>
+          <a:bodyPr wrap="square" anchor="ctr" lIns="0" rIns="0" tIns="0" bIns="0">
+            <a:spAutoFit/>
+          </a:bodyPr>
+          <a:lstStyle/>
+          <a:p>
+            <a:pPr algn="l"/>
+            <a:r>
+              <a:rPr sz="1300" b="0">
+                <a:solidFill>
+                  <a:srgbClr val="555555"/>
+                </a:solidFill>
+                <a:latin typeface="Calibri"/>
+              </a:rPr>
+              <a:t>leitura da fonte no BigQuery, dentro da franquia de 1 TB/mês</a:t>
+            </a:r>
+          </a:p>
+        </p:txBody>
+      </p:sp>
+      <p:sp>
+        <p:nvSpPr>
+          <p:cNvPr id="15" name="TextBox 14"/>
+          <p:cNvSpPr txBox="1"/>
+          <p:nvPr/>
+        </p:nvSpPr>
+        <p:spPr>
+          <a:xfrm>
+            <a:off x="6035040" y="1828800"/>
+            <a:ext cx="5577840" cy="365760"/>
           </a:xfrm>
           <a:prstGeom prst="rect">
             <a:avLst/>
@@ -4016,67 +4017,546 @@
           </a:bodyPr>
           <a:lstStyle/>
           <a:p>
-            <a:pPr algn="l">
-              <a:spcAft>
-                <a:spcPts val="300"/>
-              </a:spcAft>
-            </a:pPr>
-            <a:r>
-              <a:rPr sz="1800" b="1">
+            <a:pPr algn="l"/>
+            <a:r>
+              <a:rPr sz="1300" b="1">
                 <a:solidFill>
                   <a:srgbClr val="1A1A1A"/>
                 </a:solidFill>
                 <a:latin typeface="Calibri"/>
               </a:rPr>
-              <a:t>Decidir com dados</a:t>
-            </a:r>
-          </a:p>
-          <a:p>
-            <a:pPr algn="l">
-              <a:spcAft>
-                <a:spcPts val="300"/>
-              </a:spcAft>
-            </a:pPr>
-            <a:r>
-              <a:rPr sz="1400" b="0">
-                <a:solidFill>
-                  <a:srgbClr val="1A1A1A"/>
-                </a:solidFill>
-                <a:latin typeface="Calibri"/>
-              </a:rPr>
-              <a:t>Priorizar recurso onde há maior distância da meta e medir o efeito das ações no tempo.</a:t>
-            </a:r>
-          </a:p>
-          <a:p>
-            <a:pPr algn="l">
-              <a:spcAft>
-                <a:spcPts val="300"/>
-              </a:spcAft>
-            </a:pPr>
-            <a:r>
-              <a:rPr sz="1200" b="1">
-                <a:solidFill>
-                  <a:srgbClr val="ED145B"/>
-                </a:solidFill>
-                <a:latin typeface="Calibri"/>
-              </a:rPr>
-              <a:t>Na Gold  </a:t>
-            </a:r>
-            <a:r>
-              <a:rPr sz="1200" b="0">
-                <a:solidFill>
-                  <a:srgbClr val="555555"/>
-                </a:solidFill>
-                <a:latin typeface="Calibri"/>
-              </a:rPr>
-              <a:t>Insumo: comparação meta vs resultado por UF e município e a evolução temporal ano a ano.</a:t>
-            </a:r>
-          </a:p>
-        </p:txBody>
-      </p:sp>
-      <p:sp>
-        <p:nvSpPr>
-          <p:cNvPr id="13" name="Rectangle 12"/>
+              <a:t>Indicador por região em 2025, dos 5.571 municípios (mart da Gold)</a:t>
+            </a:r>
+          </a:p>
+        </p:txBody>
+      </p:sp>
+      <p:graphicFrame>
+        <p:nvGraphicFramePr>
+          <p:cNvPr id="16" name="Table 15"/>
+          <p:cNvGraphicFramePr>
+            <a:graphicFrameLocks noGrp="1"/>
+          </p:cNvGraphicFramePr>
+          <p:nvPr/>
+        </p:nvGraphicFramePr>
+        <p:xfrm>
+          <a:off x="6035040" y="2286000"/>
+          <a:ext cx="5532120" cy="3383280"/>
+        </p:xfrm>
+        <a:graphic>
+          <a:graphicData uri="http://schemas.openxmlformats.org/drawingml/2006/table">
+            <a:tbl>
+              <a:tblPr>
+                <a:tableStyleId>{5C22544A-7EE6-4342-B048-85BDC9FD1C3A}</a:tableStyleId>
+              </a:tblPr>
+              <a:tblGrid>
+                <a:gridCol w="2148840"/>
+                <a:gridCol w="1783080"/>
+                <a:gridCol w="1600200"/>
+              </a:tblGrid>
+              <a:tr h="483325">
+                <a:tc>
+                  <a:txBody>
+                    <a:bodyPr/>
+                    <a:lstStyle/>
+                    <a:p>
+                      <a:pPr algn="l"/>
+                      <a:r>
+                        <a:rPr sz="1200" b="1">
+                          <a:solidFill>
+                            <a:srgbClr val="FFFFFF"/>
+                          </a:solidFill>
+                          <a:latin typeface="Calibri"/>
+                        </a:rPr>
+                        <a:t>Região</a:t>
+                      </a:r>
+                    </a:p>
+                  </a:txBody>
+                  <a:tcPr marL="91440" marT="18288" marB="18288" anchor="ctr">
+                    <a:solidFill>
+                      <a:srgbClr val="ED145B"/>
+                    </a:solidFill>
+                  </a:tcPr>
+                </a:tc>
+                <a:tc>
+                  <a:txBody>
+                    <a:bodyPr/>
+                    <a:lstStyle/>
+                    <a:p>
+                      <a:pPr algn="ctr"/>
+                      <a:r>
+                        <a:rPr sz="1200" b="1">
+                          <a:solidFill>
+                            <a:srgbClr val="FFFFFF"/>
+                          </a:solidFill>
+                          <a:latin typeface="Calibri"/>
+                        </a:rPr>
+                        <a:t>Indicador médio</a:t>
+                      </a:r>
+                    </a:p>
+                  </a:txBody>
+                  <a:tcPr marL="91440" marT="18288" marB="18288" anchor="ctr">
+                    <a:solidFill>
+                      <a:srgbClr val="ED145B"/>
+                    </a:solidFill>
+                  </a:tcPr>
+                </a:tc>
+                <a:tc>
+                  <a:txBody>
+                    <a:bodyPr/>
+                    <a:lstStyle/>
+                    <a:p>
+                      <a:pPr algn="ctr"/>
+                      <a:r>
+                        <a:rPr sz="1200" b="1">
+                          <a:solidFill>
+                            <a:srgbClr val="FFFFFF"/>
+                          </a:solidFill>
+                          <a:latin typeface="Calibri"/>
+                        </a:rPr>
+                        <a:t>Atingiram a meta</a:t>
+                      </a:r>
+                    </a:p>
+                  </a:txBody>
+                  <a:tcPr marL="91440" marT="18288" marB="18288" anchor="ctr">
+                    <a:solidFill>
+                      <a:srgbClr val="ED145B"/>
+                    </a:solidFill>
+                  </a:tcPr>
+                </a:tc>
+              </a:tr>
+              <a:tr h="483325">
+                <a:tc>
+                  <a:txBody>
+                    <a:bodyPr/>
+                    <a:lstStyle/>
+                    <a:p>
+                      <a:pPr algn="l"/>
+                      <a:r>
+                        <a:rPr sz="1250" b="1">
+                          <a:solidFill>
+                            <a:srgbClr val="1A1A1A"/>
+                          </a:solidFill>
+                          <a:latin typeface="Calibri"/>
+                        </a:rPr>
+                        <a:t>Sul</a:t>
+                      </a:r>
+                    </a:p>
+                  </a:txBody>
+                  <a:tcPr marL="91440" marT="18288" marB="18288" anchor="ctr">
+                    <a:solidFill>
+                      <a:srgbClr val="FFFFFF"/>
+                    </a:solidFill>
+                  </a:tcPr>
+                </a:tc>
+                <a:tc>
+                  <a:txBody>
+                    <a:bodyPr/>
+                    <a:lstStyle/>
+                    <a:p>
+                      <a:pPr algn="ctr"/>
+                      <a:r>
+                        <a:rPr sz="1250" b="0">
+                          <a:solidFill>
+                            <a:srgbClr val="1A1A1A"/>
+                          </a:solidFill>
+                          <a:latin typeface="Calibri"/>
+                        </a:rPr>
+                        <a:t>80,2%</a:t>
+                      </a:r>
+                    </a:p>
+                  </a:txBody>
+                  <a:tcPr marL="91440" marT="18288" marB="18288" anchor="ctr">
+                    <a:solidFill>
+                      <a:srgbClr val="FFFFFF"/>
+                    </a:solidFill>
+                  </a:tcPr>
+                </a:tc>
+                <a:tc>
+                  <a:txBody>
+                    <a:bodyPr/>
+                    <a:lstStyle/>
+                    <a:p>
+                      <a:pPr algn="ctr"/>
+                      <a:r>
+                        <a:rPr sz="1250" b="0">
+                          <a:solidFill>
+                            <a:srgbClr val="1A1A1A"/>
+                          </a:solidFill>
+                          <a:latin typeface="Calibri"/>
+                        </a:rPr>
+                        <a:t>37%</a:t>
+                      </a:r>
+                    </a:p>
+                  </a:txBody>
+                  <a:tcPr marL="91440" marT="18288" marB="18288" anchor="ctr">
+                    <a:solidFill>
+                      <a:srgbClr val="FFFFFF"/>
+                    </a:solidFill>
+                  </a:tcPr>
+                </a:tc>
+              </a:tr>
+              <a:tr h="483325">
+                <a:tc>
+                  <a:txBody>
+                    <a:bodyPr/>
+                    <a:lstStyle/>
+                    <a:p>
+                      <a:pPr algn="l"/>
+                      <a:r>
+                        <a:rPr sz="1250" b="1">
+                          <a:solidFill>
+                            <a:srgbClr val="1A1A1A"/>
+                          </a:solidFill>
+                          <a:latin typeface="Calibri"/>
+                        </a:rPr>
+                        <a:t>Sudeste</a:t>
+                      </a:r>
+                    </a:p>
+                  </a:txBody>
+                  <a:tcPr marL="91440" marT="18288" marB="18288" anchor="ctr">
+                    <a:solidFill>
+                      <a:srgbClr val="F4F4F6"/>
+                    </a:solidFill>
+                  </a:tcPr>
+                </a:tc>
+                <a:tc>
+                  <a:txBody>
+                    <a:bodyPr/>
+                    <a:lstStyle/>
+                    <a:p>
+                      <a:pPr algn="ctr"/>
+                      <a:r>
+                        <a:rPr sz="1250" b="0">
+                          <a:solidFill>
+                            <a:srgbClr val="1A1A1A"/>
+                          </a:solidFill>
+                          <a:latin typeface="Calibri"/>
+                        </a:rPr>
+                        <a:t>76,0%</a:t>
+                      </a:r>
+                    </a:p>
+                  </a:txBody>
+                  <a:tcPr marL="91440" marT="18288" marB="18288" anchor="ctr">
+                    <a:solidFill>
+                      <a:srgbClr val="F4F4F6"/>
+                    </a:solidFill>
+                  </a:tcPr>
+                </a:tc>
+                <a:tc>
+                  <a:txBody>
+                    <a:bodyPr/>
+                    <a:lstStyle/>
+                    <a:p>
+                      <a:pPr algn="ctr"/>
+                      <a:r>
+                        <a:rPr sz="1250" b="0">
+                          <a:solidFill>
+                            <a:srgbClr val="1A1A1A"/>
+                          </a:solidFill>
+                          <a:latin typeface="Calibri"/>
+                        </a:rPr>
+                        <a:t>42%</a:t>
+                      </a:r>
+                    </a:p>
+                  </a:txBody>
+                  <a:tcPr marL="91440" marT="18288" marB="18288" anchor="ctr">
+                    <a:solidFill>
+                      <a:srgbClr val="F4F4F6"/>
+                    </a:solidFill>
+                  </a:tcPr>
+                </a:tc>
+              </a:tr>
+              <a:tr h="483325">
+                <a:tc>
+                  <a:txBody>
+                    <a:bodyPr/>
+                    <a:lstStyle/>
+                    <a:p>
+                      <a:pPr algn="l"/>
+                      <a:r>
+                        <a:rPr sz="1250" b="1">
+                          <a:solidFill>
+                            <a:srgbClr val="1A1A1A"/>
+                          </a:solidFill>
+                          <a:latin typeface="Calibri"/>
+                        </a:rPr>
+                        <a:t>Centro-Oeste</a:t>
+                      </a:r>
+                    </a:p>
+                  </a:txBody>
+                  <a:tcPr marL="91440" marT="18288" marB="18288" anchor="ctr">
+                    <a:solidFill>
+                      <a:srgbClr val="FFFFFF"/>
+                    </a:solidFill>
+                  </a:tcPr>
+                </a:tc>
+                <a:tc>
+                  <a:txBody>
+                    <a:bodyPr/>
+                    <a:lstStyle/>
+                    <a:p>
+                      <a:pPr algn="ctr"/>
+                      <a:r>
+                        <a:rPr sz="1250" b="0">
+                          <a:solidFill>
+                            <a:srgbClr val="1A1A1A"/>
+                          </a:solidFill>
+                          <a:latin typeface="Calibri"/>
+                        </a:rPr>
+                        <a:t>72,0%</a:t>
+                      </a:r>
+                    </a:p>
+                  </a:txBody>
+                  <a:tcPr marL="91440" marT="18288" marB="18288" anchor="ctr">
+                    <a:solidFill>
+                      <a:srgbClr val="FFFFFF"/>
+                    </a:solidFill>
+                  </a:tcPr>
+                </a:tc>
+                <a:tc>
+                  <a:txBody>
+                    <a:bodyPr/>
+                    <a:lstStyle/>
+                    <a:p>
+                      <a:pPr algn="ctr"/>
+                      <a:r>
+                        <a:rPr sz="1250" b="0">
+                          <a:solidFill>
+                            <a:srgbClr val="1A1A1A"/>
+                          </a:solidFill>
+                          <a:latin typeface="Calibri"/>
+                        </a:rPr>
+                        <a:t>38%</a:t>
+                      </a:r>
+                    </a:p>
+                  </a:txBody>
+                  <a:tcPr marL="91440" marT="18288" marB="18288" anchor="ctr">
+                    <a:solidFill>
+                      <a:srgbClr val="FFFFFF"/>
+                    </a:solidFill>
+                  </a:tcPr>
+                </a:tc>
+              </a:tr>
+              <a:tr h="483325">
+                <a:tc>
+                  <a:txBody>
+                    <a:bodyPr/>
+                    <a:lstStyle/>
+                    <a:p>
+                      <a:pPr algn="l"/>
+                      <a:r>
+                        <a:rPr sz="1250" b="1">
+                          <a:solidFill>
+                            <a:srgbClr val="1A1A1A"/>
+                          </a:solidFill>
+                          <a:latin typeface="Calibri"/>
+                        </a:rPr>
+                        <a:t>Nordeste</a:t>
+                      </a:r>
+                    </a:p>
+                  </a:txBody>
+                  <a:tcPr marL="91440" marT="18288" marB="18288" anchor="ctr">
+                    <a:solidFill>
+                      <a:srgbClr val="F4F4F6"/>
+                    </a:solidFill>
+                  </a:tcPr>
+                </a:tc>
+                <a:tc>
+                  <a:txBody>
+                    <a:bodyPr/>
+                    <a:lstStyle/>
+                    <a:p>
+                      <a:pPr algn="ctr"/>
+                      <a:r>
+                        <a:rPr sz="1250" b="0">
+                          <a:solidFill>
+                            <a:srgbClr val="1A1A1A"/>
+                          </a:solidFill>
+                          <a:latin typeface="Calibri"/>
+                        </a:rPr>
+                        <a:t>61,1%</a:t>
+                      </a:r>
+                    </a:p>
+                  </a:txBody>
+                  <a:tcPr marL="91440" marT="18288" marB="18288" anchor="ctr">
+                    <a:solidFill>
+                      <a:srgbClr val="F4F4F6"/>
+                    </a:solidFill>
+                  </a:tcPr>
+                </a:tc>
+                <a:tc>
+                  <a:txBody>
+                    <a:bodyPr/>
+                    <a:lstStyle/>
+                    <a:p>
+                      <a:pPr algn="ctr"/>
+                      <a:r>
+                        <a:rPr sz="1250" b="0">
+                          <a:solidFill>
+                            <a:srgbClr val="1A1A1A"/>
+                          </a:solidFill>
+                          <a:latin typeface="Calibri"/>
+                        </a:rPr>
+                        <a:t>32%</a:t>
+                      </a:r>
+                    </a:p>
+                  </a:txBody>
+                  <a:tcPr marL="91440" marT="18288" marB="18288" anchor="ctr">
+                    <a:solidFill>
+                      <a:srgbClr val="F4F4F6"/>
+                    </a:solidFill>
+                  </a:tcPr>
+                </a:tc>
+              </a:tr>
+              <a:tr h="483325">
+                <a:tc>
+                  <a:txBody>
+                    <a:bodyPr/>
+                    <a:lstStyle/>
+                    <a:p>
+                      <a:pPr algn="l"/>
+                      <a:r>
+                        <a:rPr sz="1250" b="1">
+                          <a:solidFill>
+                            <a:srgbClr val="1A1A1A"/>
+                          </a:solidFill>
+                          <a:latin typeface="Calibri"/>
+                        </a:rPr>
+                        <a:t>Norte</a:t>
+                      </a:r>
+                    </a:p>
+                  </a:txBody>
+                  <a:tcPr marL="91440" marT="18288" marB="18288" anchor="ctr">
+                    <a:solidFill>
+                      <a:srgbClr val="FFFFFF"/>
+                    </a:solidFill>
+                  </a:tcPr>
+                </a:tc>
+                <a:tc>
+                  <a:txBody>
+                    <a:bodyPr/>
+                    <a:lstStyle/>
+                    <a:p>
+                      <a:pPr algn="ctr"/>
+                      <a:r>
+                        <a:rPr sz="1250" b="0">
+                          <a:solidFill>
+                            <a:srgbClr val="1A1A1A"/>
+                          </a:solidFill>
+                          <a:latin typeface="Calibri"/>
+                        </a:rPr>
+                        <a:t>59,2%</a:t>
+                      </a:r>
+                    </a:p>
+                  </a:txBody>
+                  <a:tcPr marL="91440" marT="18288" marB="18288" anchor="ctr">
+                    <a:solidFill>
+                      <a:srgbClr val="FFFFFF"/>
+                    </a:solidFill>
+                  </a:tcPr>
+                </a:tc>
+                <a:tc>
+                  <a:txBody>
+                    <a:bodyPr/>
+                    <a:lstStyle/>
+                    <a:p>
+                      <a:pPr algn="ctr"/>
+                      <a:r>
+                        <a:rPr sz="1250" b="0">
+                          <a:solidFill>
+                            <a:srgbClr val="1A1A1A"/>
+                          </a:solidFill>
+                          <a:latin typeface="Calibri"/>
+                        </a:rPr>
+                        <a:t>26%</a:t>
+                      </a:r>
+                    </a:p>
+                  </a:txBody>
+                  <a:tcPr marL="91440" marT="18288" marB="18288" anchor="ctr">
+                    <a:solidFill>
+                      <a:srgbClr val="FFFFFF"/>
+                    </a:solidFill>
+                  </a:tcPr>
+                </a:tc>
+              </a:tr>
+              <a:tr h="483330">
+                <a:tc>
+                  <a:txBody>
+                    <a:bodyPr/>
+                    <a:lstStyle/>
+                    <a:p>
+                      <a:pPr algn="l"/>
+                      <a:r>
+                        <a:rPr sz="1250" b="1">
+                          <a:solidFill>
+                            <a:srgbClr val="1A1A1A"/>
+                          </a:solidFill>
+                          <a:latin typeface="Calibri"/>
+                        </a:rPr>
+                        <a:t>Brasil</a:t>
+                      </a:r>
+                    </a:p>
+                  </a:txBody>
+                  <a:tcPr marL="91440" marT="18288" marB="18288" anchor="ctr">
+                    <a:solidFill>
+                      <a:srgbClr val="FCE4EC"/>
+                    </a:solidFill>
+                  </a:tcPr>
+                </a:tc>
+                <a:tc>
+                  <a:txBody>
+                    <a:bodyPr/>
+                    <a:lstStyle/>
+                    <a:p>
+                      <a:pPr algn="ctr"/>
+                      <a:r>
+                        <a:rPr sz="1250" b="1">
+                          <a:solidFill>
+                            <a:srgbClr val="1A1A1A"/>
+                          </a:solidFill>
+                          <a:latin typeface="Calibri"/>
+                        </a:rPr>
+                        <a:t>70,4%</a:t>
+                      </a:r>
+                    </a:p>
+                  </a:txBody>
+                  <a:tcPr marL="91440" marT="18288" marB="18288" anchor="ctr">
+                    <a:solidFill>
+                      <a:srgbClr val="FCE4EC"/>
+                    </a:solidFill>
+                  </a:tcPr>
+                </a:tc>
+                <a:tc>
+                  <a:txBody>
+                    <a:bodyPr/>
+                    <a:lstStyle/>
+                    <a:p>
+                      <a:pPr algn="ctr"/>
+                      <a:r>
+                        <a:rPr sz="1250" b="1">
+                          <a:solidFill>
+                            <a:srgbClr val="1A1A1A"/>
+                          </a:solidFill>
+                          <a:latin typeface="Calibri"/>
+                        </a:rPr>
+                        <a:t>36%</a:t>
+                      </a:r>
+                    </a:p>
+                  </a:txBody>
+                  <a:tcPr marL="91440" marT="18288" marB="18288" anchor="ctr">
+                    <a:solidFill>
+                      <a:srgbClr val="FCE4EC"/>
+                    </a:solidFill>
+                  </a:tcPr>
+                </a:tc>
+              </a:tr>
+            </a:tbl>
+          </a:graphicData>
+        </a:graphic>
+      </p:graphicFrame>
+      <p:sp>
+        <p:nvSpPr>
+          <p:cNvPr id="17" name="Rectangle 16"/>
           <p:cNvSpPr/>
           <p:nvPr/>
         </p:nvSpPr>
@@ -4120,7 +4600,7 @@
       </p:sp>
       <p:sp>
         <p:nvSpPr>
-          <p:cNvPr id="14" name="TextBox 13"/>
+          <p:cNvPr id="18" name="TextBox 17"/>
           <p:cNvSpPr txBox="1"/>
           <p:nvPr/>
         </p:nvSpPr>
@@ -4155,7 +4635,7 @@
       </p:sp>
       <p:sp>
         <p:nvSpPr>
-          <p:cNvPr id="15" name="TextBox 14"/>
+          <p:cNvPr id="19" name="TextBox 18"/>
           <p:cNvSpPr txBox="1"/>
           <p:nvPr/>
         </p:nvSpPr>
@@ -4197,6 +4677,730 @@
 </file>
 
 <file path=ppt/slides/slide11.xml><?xml version="1.0" encoding="utf-8"?>
+<p:sld xmlns:a="http://schemas.openxmlformats.org/drawingml/2006/main" xmlns:p="http://schemas.openxmlformats.org/presentationml/2006/main" xmlns:r="http://schemas.openxmlformats.org/officeDocument/2006/relationships">
+  <p:cSld>
+    <p:spTree>
+      <p:nvGrpSpPr>
+        <p:cNvPr id="1" name=""/>
+        <p:cNvGrpSpPr/>
+        <p:nvPr/>
+      </p:nvGrpSpPr>
+      <p:grpSpPr/>
+      <p:sp>
+        <p:nvSpPr>
+          <p:cNvPr id="2" name="Rectangle 1"/>
+          <p:cNvSpPr/>
+          <p:nvPr/>
+        </p:nvSpPr>
+        <p:spPr>
+          <a:xfrm>
+            <a:off x="0" y="0"/>
+            <a:ext cx="12191695" cy="6858000"/>
+          </a:xfrm>
+          <a:prstGeom prst="rect">
+            <a:avLst/>
+          </a:prstGeom>
+          <a:solidFill>
+            <a:srgbClr val="FFFFFF"/>
+          </a:solidFill>
+          <a:ln>
+            <a:noFill/>
+          </a:ln>
+          <a:effectLst/>
+        </p:spPr>
+        <p:style>
+          <a:lnRef idx="1">
+            <a:schemeClr val="accent1"/>
+          </a:lnRef>
+          <a:fillRef idx="3">
+            <a:schemeClr val="accent1"/>
+          </a:fillRef>
+          <a:effectRef idx="2">
+            <a:schemeClr val="accent1"/>
+          </a:effectRef>
+          <a:fontRef idx="minor">
+            <a:schemeClr val="lt1"/>
+          </a:fontRef>
+        </p:style>
+        <p:txBody>
+          <a:bodyPr rtlCol="0" anchor="ctr"/>
+          <a:lstStyle/>
+          <a:p>
+            <a:pPr algn="ctr"/>
+          </a:p>
+        </p:txBody>
+      </p:sp>
+      <p:sp>
+        <p:nvSpPr>
+          <p:cNvPr id="3" name="TextBox 2"/>
+          <p:cNvSpPr txBox="1"/>
+          <p:nvPr/>
+        </p:nvSpPr>
+        <p:spPr>
+          <a:xfrm>
+            <a:off x="640080" y="457200"/>
+            <a:ext cx="10972800" cy="320040"/>
+          </a:xfrm>
+          <a:prstGeom prst="rect">
+            <a:avLst/>
+          </a:prstGeom>
+          <a:noFill/>
+        </p:spPr>
+        <p:txBody>
+          <a:bodyPr wrap="square" anchor="t" lIns="0" rIns="0" tIns="0" bIns="0">
+            <a:spAutoFit/>
+          </a:bodyPr>
+          <a:lstStyle/>
+          <a:p>
+            <a:pPr algn="l"/>
+            <a:r>
+              <a:rPr sz="1300" b="1">
+                <a:solidFill>
+                  <a:srgbClr val="ED145B"/>
+                </a:solidFill>
+                <a:latin typeface="Calibri"/>
+              </a:rPr>
+              <a:t>VALOR</a:t>
+            </a:r>
+          </a:p>
+        </p:txBody>
+      </p:sp>
+      <p:sp>
+        <p:nvSpPr>
+          <p:cNvPr id="4" name="TextBox 3"/>
+          <p:cNvSpPr txBox="1"/>
+          <p:nvPr/>
+        </p:nvSpPr>
+        <p:spPr>
+          <a:xfrm>
+            <a:off x="640080" y="749808"/>
+            <a:ext cx="10972800" cy="822960"/>
+          </a:xfrm>
+          <a:prstGeom prst="rect">
+            <a:avLst/>
+          </a:prstGeom>
+          <a:noFill/>
+        </p:spPr>
+        <p:txBody>
+          <a:bodyPr wrap="square" anchor="t" lIns="0" rIns="0" tIns="0" bIns="0">
+            <a:spAutoFit/>
+          </a:bodyPr>
+          <a:lstStyle/>
+          <a:p>
+            <a:pPr algn="l"/>
+            <a:r>
+              <a:rPr sz="3200" b="1">
+                <a:solidFill>
+                  <a:srgbClr val="1A1A1A"/>
+                </a:solidFill>
+                <a:latin typeface="Calibri"/>
+              </a:rPr>
+              <a:t>Valor e potencial de IA</a:t>
+            </a:r>
+          </a:p>
+        </p:txBody>
+      </p:sp>
+      <p:sp>
+        <p:nvSpPr>
+          <p:cNvPr id="5" name="Rectangle 4"/>
+          <p:cNvSpPr/>
+          <p:nvPr/>
+        </p:nvSpPr>
+        <p:spPr>
+          <a:xfrm>
+            <a:off x="658368" y="1463040"/>
+            <a:ext cx="1188720" cy="50292"/>
+          </a:xfrm>
+          <a:prstGeom prst="rect">
+            <a:avLst/>
+          </a:prstGeom>
+          <a:solidFill>
+            <a:srgbClr val="ED145B"/>
+          </a:solidFill>
+          <a:ln>
+            <a:noFill/>
+          </a:ln>
+          <a:effectLst/>
+        </p:spPr>
+        <p:style>
+          <a:lnRef idx="1">
+            <a:schemeClr val="accent1"/>
+          </a:lnRef>
+          <a:fillRef idx="3">
+            <a:schemeClr val="accent1"/>
+          </a:fillRef>
+          <a:effectRef idx="2">
+            <a:schemeClr val="accent1"/>
+          </a:effectRef>
+          <a:fontRef idx="minor">
+            <a:schemeClr val="lt1"/>
+          </a:fontRef>
+        </p:style>
+        <p:txBody>
+          <a:bodyPr rtlCol="0" anchor="ctr"/>
+          <a:lstStyle/>
+          <a:p>
+            <a:pPr algn="ctr"/>
+          </a:p>
+        </p:txBody>
+      </p:sp>
+      <p:sp>
+        <p:nvSpPr>
+          <p:cNvPr id="6" name="TextBox 5"/>
+          <p:cNvSpPr txBox="1"/>
+          <p:nvPr/>
+        </p:nvSpPr>
+        <p:spPr>
+          <a:xfrm>
+            <a:off x="640080" y="1645920"/>
+            <a:ext cx="10881360" cy="502920"/>
+          </a:xfrm>
+          <a:prstGeom prst="rect">
+            <a:avLst/>
+          </a:prstGeom>
+          <a:noFill/>
+        </p:spPr>
+        <p:txBody>
+          <a:bodyPr wrap="square" anchor="t" lIns="0" rIns="0" tIns="0" bIns="0">
+            <a:spAutoFit/>
+          </a:bodyPr>
+          <a:lstStyle/>
+          <a:p>
+            <a:pPr algn="l"/>
+            <a:r>
+              <a:rPr sz="1500" b="0">
+                <a:solidFill>
+                  <a:srgbClr val="555555"/>
+                </a:solidFill>
+                <a:latin typeface="Calibri"/>
+              </a:rPr>
+              <a:t>A Gold sai pronta para alimentar modelos e análises. Três frentes concretas:</a:t>
+            </a:r>
+          </a:p>
+        </p:txBody>
+      </p:sp>
+      <p:sp>
+        <p:nvSpPr>
+          <p:cNvPr id="7" name="Oval 6"/>
+          <p:cNvSpPr/>
+          <p:nvPr/>
+        </p:nvSpPr>
+        <p:spPr>
+          <a:xfrm>
+            <a:off x="640080" y="2286000"/>
+            <a:ext cx="566928" cy="566928"/>
+          </a:xfrm>
+          <a:prstGeom prst="ellipse">
+            <a:avLst/>
+          </a:prstGeom>
+          <a:solidFill>
+            <a:srgbClr val="ED145B"/>
+          </a:solidFill>
+          <a:ln>
+            <a:noFill/>
+          </a:ln>
+          <a:effectLst/>
+        </p:spPr>
+        <p:style>
+          <a:lnRef idx="1">
+            <a:schemeClr val="accent1"/>
+          </a:lnRef>
+          <a:fillRef idx="3">
+            <a:schemeClr val="accent1"/>
+          </a:fillRef>
+          <a:effectRef idx="2">
+            <a:schemeClr val="accent1"/>
+          </a:effectRef>
+          <a:fontRef idx="minor">
+            <a:schemeClr val="lt1"/>
+          </a:fontRef>
+        </p:style>
+        <p:txBody>
+          <a:bodyPr rtlCol="0" anchor="ctr"/>
+          <a:lstStyle/>
+          <a:p>
+            <a:pPr algn="ctr"/>
+            <a:r>
+              <a:rPr sz="1700" b="1">
+                <a:solidFill>
+                  <a:srgbClr val="FFFFFF"/>
+                </a:solidFill>
+                <a:latin typeface="Calibri"/>
+              </a:rPr>
+              <a:t>1</a:t>
+            </a:r>
+          </a:p>
+        </p:txBody>
+      </p:sp>
+      <p:sp>
+        <p:nvSpPr>
+          <p:cNvPr id="8" name="TextBox 7"/>
+          <p:cNvSpPr txBox="1"/>
+          <p:nvPr/>
+        </p:nvSpPr>
+        <p:spPr>
+          <a:xfrm>
+            <a:off x="1417320" y="2240280"/>
+            <a:ext cx="10149840" cy="1188720"/>
+          </a:xfrm>
+          <a:prstGeom prst="rect">
+            <a:avLst/>
+          </a:prstGeom>
+          <a:noFill/>
+        </p:spPr>
+        <p:txBody>
+          <a:bodyPr wrap="square" anchor="t" lIns="0" rIns="0" tIns="0" bIns="0">
+            <a:spAutoFit/>
+          </a:bodyPr>
+          <a:lstStyle/>
+          <a:p>
+            <a:pPr algn="l">
+              <a:spcAft>
+                <a:spcPts val="300"/>
+              </a:spcAft>
+            </a:pPr>
+            <a:r>
+              <a:rPr sz="1800" b="1">
+                <a:solidFill>
+                  <a:srgbClr val="1A1A1A"/>
+                </a:solidFill>
+                <a:latin typeface="Calibri"/>
+              </a:rPr>
+              <a:t>Antecipar</a:t>
+            </a:r>
+          </a:p>
+          <a:p>
+            <a:pPr algn="l">
+              <a:spcAft>
+                <a:spcPts val="300"/>
+              </a:spcAft>
+            </a:pPr>
+            <a:r>
+              <a:rPr sz="1400" b="0">
+                <a:solidFill>
+                  <a:srgbClr val="1A1A1A"/>
+                </a:solidFill>
+                <a:latin typeface="Calibri"/>
+              </a:rPr>
+              <a:t>Prever quais municípios tendem a ficar abaixo da meta e agir antes do resultado consolidado.</a:t>
+            </a:r>
+          </a:p>
+          <a:p>
+            <a:pPr algn="l">
+              <a:spcAft>
+                <a:spcPts val="300"/>
+              </a:spcAft>
+            </a:pPr>
+            <a:r>
+              <a:rPr sz="1200" b="1">
+                <a:solidFill>
+                  <a:srgbClr val="ED145B"/>
+                </a:solidFill>
+                <a:latin typeface="Calibri"/>
+              </a:rPr>
+              <a:t>Na Gold  </a:t>
+            </a:r>
+            <a:r>
+              <a:rPr sz="1200" b="0">
+                <a:solidFill>
+                  <a:srgbClr val="555555"/>
+                </a:solidFill>
+                <a:latin typeface="Calibri"/>
+              </a:rPr>
+              <a:t>Insumo: fato por município (indicador_pct, gap_meta_pp, atingiu_meta) mais enriquecimento socioeconômico como base de treino.</a:t>
+            </a:r>
+          </a:p>
+        </p:txBody>
+      </p:sp>
+      <p:sp>
+        <p:nvSpPr>
+          <p:cNvPr id="9" name="Oval 8"/>
+          <p:cNvSpPr/>
+          <p:nvPr/>
+        </p:nvSpPr>
+        <p:spPr>
+          <a:xfrm>
+            <a:off x="640080" y="3584448"/>
+            <a:ext cx="566928" cy="566928"/>
+          </a:xfrm>
+          <a:prstGeom prst="ellipse">
+            <a:avLst/>
+          </a:prstGeom>
+          <a:solidFill>
+            <a:srgbClr val="1A1A1A"/>
+          </a:solidFill>
+          <a:ln>
+            <a:noFill/>
+          </a:ln>
+          <a:effectLst/>
+        </p:spPr>
+        <p:style>
+          <a:lnRef idx="1">
+            <a:schemeClr val="accent1"/>
+          </a:lnRef>
+          <a:fillRef idx="3">
+            <a:schemeClr val="accent1"/>
+          </a:fillRef>
+          <a:effectRef idx="2">
+            <a:schemeClr val="accent1"/>
+          </a:effectRef>
+          <a:fontRef idx="minor">
+            <a:schemeClr val="lt1"/>
+          </a:fontRef>
+        </p:style>
+        <p:txBody>
+          <a:bodyPr rtlCol="0" anchor="ctr"/>
+          <a:lstStyle/>
+          <a:p>
+            <a:pPr algn="ctr"/>
+            <a:r>
+              <a:rPr sz="1700" b="1">
+                <a:solidFill>
+                  <a:srgbClr val="FFFFFF"/>
+                </a:solidFill>
+                <a:latin typeface="Calibri"/>
+              </a:rPr>
+              <a:t>2</a:t>
+            </a:r>
+          </a:p>
+        </p:txBody>
+      </p:sp>
+      <p:sp>
+        <p:nvSpPr>
+          <p:cNvPr id="10" name="TextBox 9"/>
+          <p:cNvSpPr txBox="1"/>
+          <p:nvPr/>
+        </p:nvSpPr>
+        <p:spPr>
+          <a:xfrm>
+            <a:off x="1417320" y="3538728"/>
+            <a:ext cx="10149840" cy="1188720"/>
+          </a:xfrm>
+          <a:prstGeom prst="rect">
+            <a:avLst/>
+          </a:prstGeom>
+          <a:noFill/>
+        </p:spPr>
+        <p:txBody>
+          <a:bodyPr wrap="square" anchor="t" lIns="0" rIns="0" tIns="0" bIns="0">
+            <a:spAutoFit/>
+          </a:bodyPr>
+          <a:lstStyle/>
+          <a:p>
+            <a:pPr algn="l">
+              <a:spcAft>
+                <a:spcPts val="300"/>
+              </a:spcAft>
+            </a:pPr>
+            <a:r>
+              <a:rPr sz="1800" b="1">
+                <a:solidFill>
+                  <a:srgbClr val="1A1A1A"/>
+                </a:solidFill>
+                <a:latin typeface="Calibri"/>
+              </a:rPr>
+              <a:t>Enxergar desigualdade</a:t>
+            </a:r>
+          </a:p>
+          <a:p>
+            <a:pPr algn="l">
+              <a:spcAft>
+                <a:spcPts val="300"/>
+              </a:spcAft>
+            </a:pPr>
+            <a:r>
+              <a:rPr sz="1400" b="0">
+                <a:solidFill>
+                  <a:srgbClr val="1A1A1A"/>
+                </a:solidFill>
+                <a:latin typeface="Calibri"/>
+              </a:rPr>
+              <a:t>Comparar regiões e redes e identificar grupos em maior vulnerabilidade educacional.</a:t>
+            </a:r>
+          </a:p>
+          <a:p>
+            <a:pPr algn="l">
+              <a:spcAft>
+                <a:spcPts val="300"/>
+              </a:spcAft>
+            </a:pPr>
+            <a:r>
+              <a:rPr sz="1200" b="1">
+                <a:solidFill>
+                  <a:srgbClr val="ED145B"/>
+                </a:solidFill>
+                <a:latin typeface="Calibri"/>
+              </a:rPr>
+              <a:t>Na Gold  </a:t>
+            </a:r>
+            <a:r>
+              <a:rPr sz="1200" b="0">
+                <a:solidFill>
+                  <a:srgbClr val="555555"/>
+                </a:solidFill>
+                <a:latin typeface="Calibri"/>
+              </a:rPr>
+              <a:t>Insumo: clusterização sobre indicador, região, rede e distância da meta para achar padrões.</a:t>
+            </a:r>
+          </a:p>
+        </p:txBody>
+      </p:sp>
+      <p:sp>
+        <p:nvSpPr>
+          <p:cNvPr id="11" name="Oval 10"/>
+          <p:cNvSpPr/>
+          <p:nvPr/>
+        </p:nvSpPr>
+        <p:spPr>
+          <a:xfrm>
+            <a:off x="640080" y="4882896"/>
+            <a:ext cx="566928" cy="566928"/>
+          </a:xfrm>
+          <a:prstGeom prst="ellipse">
+            <a:avLst/>
+          </a:prstGeom>
+          <a:solidFill>
+            <a:srgbClr val="ED145B"/>
+          </a:solidFill>
+          <a:ln>
+            <a:noFill/>
+          </a:ln>
+          <a:effectLst/>
+        </p:spPr>
+        <p:style>
+          <a:lnRef idx="1">
+            <a:schemeClr val="accent1"/>
+          </a:lnRef>
+          <a:fillRef idx="3">
+            <a:schemeClr val="accent1"/>
+          </a:fillRef>
+          <a:effectRef idx="2">
+            <a:schemeClr val="accent1"/>
+          </a:effectRef>
+          <a:fontRef idx="minor">
+            <a:schemeClr val="lt1"/>
+          </a:fontRef>
+        </p:style>
+        <p:txBody>
+          <a:bodyPr rtlCol="0" anchor="ctr"/>
+          <a:lstStyle/>
+          <a:p>
+            <a:pPr algn="ctr"/>
+            <a:r>
+              <a:rPr sz="1700" b="1">
+                <a:solidFill>
+                  <a:srgbClr val="FFFFFF"/>
+                </a:solidFill>
+                <a:latin typeface="Calibri"/>
+              </a:rPr>
+              <a:t>3</a:t>
+            </a:r>
+          </a:p>
+        </p:txBody>
+      </p:sp>
+      <p:sp>
+        <p:nvSpPr>
+          <p:cNvPr id="12" name="TextBox 11"/>
+          <p:cNvSpPr txBox="1"/>
+          <p:nvPr/>
+        </p:nvSpPr>
+        <p:spPr>
+          <a:xfrm>
+            <a:off x="1417320" y="4837176"/>
+            <a:ext cx="10149840" cy="1188720"/>
+          </a:xfrm>
+          <a:prstGeom prst="rect">
+            <a:avLst/>
+          </a:prstGeom>
+          <a:noFill/>
+        </p:spPr>
+        <p:txBody>
+          <a:bodyPr wrap="square" anchor="t" lIns="0" rIns="0" tIns="0" bIns="0">
+            <a:spAutoFit/>
+          </a:bodyPr>
+          <a:lstStyle/>
+          <a:p>
+            <a:pPr algn="l">
+              <a:spcAft>
+                <a:spcPts val="300"/>
+              </a:spcAft>
+            </a:pPr>
+            <a:r>
+              <a:rPr sz="1800" b="1">
+                <a:solidFill>
+                  <a:srgbClr val="1A1A1A"/>
+                </a:solidFill>
+                <a:latin typeface="Calibri"/>
+              </a:rPr>
+              <a:t>Decidir com dados</a:t>
+            </a:r>
+          </a:p>
+          <a:p>
+            <a:pPr algn="l">
+              <a:spcAft>
+                <a:spcPts val="300"/>
+              </a:spcAft>
+            </a:pPr>
+            <a:r>
+              <a:rPr sz="1400" b="0">
+                <a:solidFill>
+                  <a:srgbClr val="1A1A1A"/>
+                </a:solidFill>
+                <a:latin typeface="Calibri"/>
+              </a:rPr>
+              <a:t>Priorizar recurso onde há maior distância da meta e medir o efeito das ações no tempo.</a:t>
+            </a:r>
+          </a:p>
+          <a:p>
+            <a:pPr algn="l">
+              <a:spcAft>
+                <a:spcPts val="300"/>
+              </a:spcAft>
+            </a:pPr>
+            <a:r>
+              <a:rPr sz="1200" b="1">
+                <a:solidFill>
+                  <a:srgbClr val="ED145B"/>
+                </a:solidFill>
+                <a:latin typeface="Calibri"/>
+              </a:rPr>
+              <a:t>Na Gold  </a:t>
+            </a:r>
+            <a:r>
+              <a:rPr sz="1200" b="0">
+                <a:solidFill>
+                  <a:srgbClr val="555555"/>
+                </a:solidFill>
+                <a:latin typeface="Calibri"/>
+              </a:rPr>
+              <a:t>Insumo: comparação meta vs resultado por UF e município e a evolução temporal ano a ano.</a:t>
+            </a:r>
+          </a:p>
+        </p:txBody>
+      </p:sp>
+      <p:sp>
+        <p:nvSpPr>
+          <p:cNvPr id="13" name="Rectangle 12"/>
+          <p:cNvSpPr/>
+          <p:nvPr/>
+        </p:nvSpPr>
+        <p:spPr>
+          <a:xfrm>
+            <a:off x="640080" y="6382512"/>
+            <a:ext cx="10908792" cy="10972"/>
+          </a:xfrm>
+          <a:prstGeom prst="rect">
+            <a:avLst/>
+          </a:prstGeom>
+          <a:solidFill>
+            <a:srgbClr val="E0E0E0"/>
+          </a:solidFill>
+          <a:ln>
+            <a:noFill/>
+          </a:ln>
+          <a:effectLst/>
+        </p:spPr>
+        <p:style>
+          <a:lnRef idx="1">
+            <a:schemeClr val="accent1"/>
+          </a:lnRef>
+          <a:fillRef idx="3">
+            <a:schemeClr val="accent1"/>
+          </a:fillRef>
+          <a:effectRef idx="2">
+            <a:schemeClr val="accent1"/>
+          </a:effectRef>
+          <a:fontRef idx="minor">
+            <a:schemeClr val="lt1"/>
+          </a:fontRef>
+        </p:style>
+        <p:txBody>
+          <a:bodyPr rtlCol="0" anchor="ctr"/>
+          <a:lstStyle/>
+          <a:p>
+            <a:pPr algn="ctr"/>
+          </a:p>
+        </p:txBody>
+      </p:sp>
+      <p:sp>
+        <p:nvSpPr>
+          <p:cNvPr id="14" name="TextBox 13"/>
+          <p:cNvSpPr txBox="1"/>
+          <p:nvPr/>
+        </p:nvSpPr>
+        <p:spPr>
+          <a:xfrm>
+            <a:off x="640080" y="6455664"/>
+            <a:ext cx="8686800" cy="274320"/>
+          </a:xfrm>
+          <a:prstGeom prst="rect">
+            <a:avLst/>
+          </a:prstGeom>
+          <a:noFill/>
+        </p:spPr>
+        <p:txBody>
+          <a:bodyPr wrap="square" anchor="t" lIns="0" rIns="0" tIns="0" bIns="0">
+            <a:spAutoFit/>
+          </a:bodyPr>
+          <a:lstStyle/>
+          <a:p>
+            <a:pPr algn="l"/>
+            <a:r>
+              <a:rPr sz="1000" b="0">
+                <a:solidFill>
+                  <a:srgbClr val="555555"/>
+                </a:solidFill>
+                <a:latin typeface="Calibri"/>
+              </a:rPr>
+              <a:t>Pipeline de Alfabetização  ·  Tech Challenge Fase 2  ·  MBA AI Scientist FIAP</a:t>
+            </a:r>
+          </a:p>
+        </p:txBody>
+      </p:sp>
+      <p:sp>
+        <p:nvSpPr>
+          <p:cNvPr id="15" name="TextBox 14"/>
+          <p:cNvSpPr txBox="1"/>
+          <p:nvPr/>
+        </p:nvSpPr>
+        <p:spPr>
+          <a:xfrm>
+            <a:off x="10789920" y="6455664"/>
+            <a:ext cx="758952" cy="274320"/>
+          </a:xfrm>
+          <a:prstGeom prst="rect">
+            <a:avLst/>
+          </a:prstGeom>
+          <a:noFill/>
+        </p:spPr>
+        <p:txBody>
+          <a:bodyPr wrap="square" anchor="t" lIns="0" rIns="0" tIns="0" bIns="0">
+            <a:spAutoFit/>
+          </a:bodyPr>
+          <a:lstStyle/>
+          <a:p>
+            <a:pPr algn="r"/>
+            <a:r>
+              <a:rPr sz="1100" b="1">
+                <a:solidFill>
+                  <a:srgbClr val="ED145B"/>
+                </a:solidFill>
+                <a:latin typeface="Calibri"/>
+              </a:rPr>
+              <a:t>11</a:t>
+            </a:r>
+          </a:p>
+        </p:txBody>
+      </p:sp>
+    </p:spTree>
+  </p:cSld>
+  <p:clrMapOvr>
+    <a:masterClrMapping/>
+  </p:clrMapOvr>
+</p:sld>
+</file>
+
+<file path=ppt/slides/slide12.xml><?xml version="1.0" encoding="utf-8"?>
 <p:sld xmlns:a="http://schemas.openxmlformats.org/drawingml/2006/main" xmlns:p="http://schemas.openxmlformats.org/presentationml/2006/main" xmlns:r="http://schemas.openxmlformats.org/officeDocument/2006/relationships">
   <p:cSld>
     <p:spTree>

</xml_diff>

<commit_message>
link do video na capa e no fechamento do deck, e o deck exportado em pdf
</commit_message>
<xml_diff>
--- a/reports/slides/pipeline_alfabetizacao_fase2.pptx
+++ b/reports/slides/pipeline_alfabetizacao_fase2.pptx
@@ -3422,8 +3422,8 @@
         </p:blipFill>
         <p:spPr>
           <a:xfrm>
-            <a:off x="868680" y="5870448"/>
-            <a:ext cx="256032" cy="256032"/>
+            <a:off x="868680" y="5815584"/>
+            <a:ext cx="237744" cy="237744"/>
           </a:xfrm>
           <a:prstGeom prst="rect">
             <a:avLst/>
@@ -3438,8 +3438,8 @@
         </p:nvSpPr>
         <p:spPr>
           <a:xfrm>
-            <a:off x="1216152" y="5852160"/>
-            <a:ext cx="10058400" cy="320040"/>
+            <a:off x="1216152" y="5797296"/>
+            <a:ext cx="10058400" cy="292608"/>
           </a:xfrm>
           <a:prstGeom prst="rect">
             <a:avLst/>
@@ -3461,6 +3461,50 @@
                 <a:latin typeface="Calibri"/>
               </a:rPr>
               <a:t>github.com/guillecosme/fiap-ai-scientist-tech-challenge-fase-02</a:t>
+            </a:r>
+          </a:p>
+        </p:txBody>
+      </p:sp>
+      <p:sp>
+        <p:nvSpPr>
+          <p:cNvPr id="12" name="TextBox 11"/>
+          <p:cNvSpPr txBox="1"/>
+          <p:nvPr/>
+        </p:nvSpPr>
+        <p:spPr>
+          <a:xfrm>
+            <a:off x="868680" y="6163056"/>
+            <a:ext cx="10058400" cy="292608"/>
+          </a:xfrm>
+          <a:prstGeom prst="rect">
+            <a:avLst/>
+          </a:prstGeom>
+          <a:noFill/>
+        </p:spPr>
+        <p:txBody>
+          <a:bodyPr wrap="square" anchor="t" lIns="0" rIns="0" tIns="0" bIns="0">
+            <a:spAutoFit/>
+          </a:bodyPr>
+          <a:lstStyle/>
+          <a:p>
+            <a:pPr algn="l"/>
+            <a:r>
+              <a:rPr sz="1200" b="1">
+                <a:solidFill>
+                  <a:srgbClr val="ED145B"/>
+                </a:solidFill>
+                <a:latin typeface="Calibri"/>
+              </a:rPr>
+              <a:t>Vídeo executivo (5 min): </a:t>
+            </a:r>
+            <a:r>
+              <a:rPr sz="1200" b="0">
+                <a:solidFill>
+                  <a:srgbClr val="555555"/>
+                </a:solidFill>
+                <a:latin typeface="Calibri"/>
+              </a:rPr>
+              <a:t>www.loom.com/share/ade3918fb4774c129402f385f178e717</a:t>
             </a:r>
           </a:p>
         </p:txBody>
@@ -5632,6 +5676,50 @@
           </a:p>
         </p:txBody>
       </p:sp>
+      <p:sp>
+        <p:nvSpPr>
+          <p:cNvPr id="7" name="TextBox 6"/>
+          <p:cNvSpPr txBox="1"/>
+          <p:nvPr/>
+        </p:nvSpPr>
+        <p:spPr>
+          <a:xfrm>
+            <a:off x="868680" y="5989320"/>
+            <a:ext cx="10515600" cy="320040"/>
+          </a:xfrm>
+          <a:prstGeom prst="rect">
+            <a:avLst/>
+          </a:prstGeom>
+          <a:noFill/>
+        </p:spPr>
+        <p:txBody>
+          <a:bodyPr wrap="square" anchor="t" lIns="0" rIns="0" tIns="0" bIns="0">
+            <a:spAutoFit/>
+          </a:bodyPr>
+          <a:lstStyle/>
+          <a:p>
+            <a:pPr algn="l"/>
+            <a:r>
+              <a:rPr sz="1300" b="1">
+                <a:solidFill>
+                  <a:srgbClr val="1A1A1A"/>
+                </a:solidFill>
+                <a:latin typeface="Calibri"/>
+              </a:rPr>
+              <a:t>Vídeo da apresentação: </a:t>
+            </a:r>
+            <a:r>
+              <a:rPr sz="1300" b="0">
+                <a:solidFill>
+                  <a:srgbClr val="555555"/>
+                </a:solidFill>
+                <a:latin typeface="Calibri"/>
+              </a:rPr>
+              <a:t>www.loom.com/share/ade3918fb4774c129402f385f178e717</a:t>
+            </a:r>
+          </a:p>
+        </p:txBody>
+      </p:sp>
     </p:spTree>
   </p:cSld>
   <p:clrMapOvr>

</xml_diff>